<commit_message>
Update Q3 deck with revised September cash flow statement
The revised statement reclassifies RM200K (RHB) from investing
'Collection from Investor Fund' to operating 'Licensing package'.
September net cash flow and closing balance are unchanged.

Co-Authored-By: Claude Opus 5.5 <noreply@anthropic.com>
Claude-Session: https://claude.ai/code/session_01UekZ1BuiJW323matwahEES
</commit_message>
<xml_diff>
--- a/q3-finance-report/Q3_2026_Finance_Report.pptx
+++ b/q3-finance-report/Q3_2026_Finance_Report.pptx
@@ -3295,7 +3295,7 @@
                 </a:solidFill>
                 <a:latin typeface="Aptos"/>
               </a:rPr>
-              <a:t>Q3 operating cash was positive overall at RM2.27M, but negative in July after a RM1.03M SST payment. Net cash flow was (RM2.88M), mainly from RM3.34M new-branch capex and a RM2.00M fixed deposit placement.</a:t>
+              <a:t>Q3 operating cash was positive overall at RM2.47M, but negative in July after a RM1.03M SST payment. Net cash flow was (RM2.88M), mainly from RM3.34M new-branch capex and a RM2.00M fixed deposit placement.</a:t>
             </a:r>
           </a:p>
         </p:txBody>
@@ -3330,7 +3330,7 @@
                 </a:solidFill>
                 <a:latin typeface="Aptos"/>
               </a:rPr>
-              <a:t>Source: TGFB Cash Flow Statement PDFs for July, August and September 2026</a:t>
+              <a:t>Source: TGFB Cash Flow Statement PDFs for July, August and September 2026 (September revised upload)</a:t>
             </a:r>
           </a:p>
         </p:txBody>
@@ -3460,7 +3460,7 @@
                 </a:solidFill>
                 <a:latin typeface="Aptos"/>
               </a:rPr>
-              <a:t>RM28.95M</a:t>
+              <a:t>RM29.15M</a:t>
             </a:r>
           </a:p>
         </p:txBody>
@@ -3495,7 +3495,7 @@
                 </a:solidFill>
                 <a:latin typeface="Aptos"/>
               </a:rPr>
-              <a:t>Customers &amp; sales contribute 95.7%</a:t>
+              <a:t>Customers &amp; sales contribute 95.0%</a:t>
             </a:r>
           </a:p>
         </p:txBody>
@@ -3790,7 +3790,7 @@
                 </a:solidFill>
                 <a:latin typeface="Aptos"/>
               </a:rPr>
-              <a:t>RM2.27M</a:t>
+              <a:t>RM2.47M</a:t>
             </a:r>
           </a:p>
         </p:txBody>
@@ -4709,7 +4709,7 @@
                           </a:solidFill>
                           <a:latin typeface="Aptos"/>
                         </a:rPr>
-                        <a:t>9,919,617.17</a:t>
+                        <a:t>10,119,617.17</a:t>
                       </a:r>
                     </a:p>
                   </a:txBody>
@@ -4758,7 +4758,7 @@
                           </a:solidFill>
                           <a:latin typeface="Aptos"/>
                         </a:rPr>
-                        <a:t>28,946,566.89</a:t>
+                        <a:t>29,146,566.89</a:t>
                       </a:r>
                     </a:p>
                   </a:txBody>
@@ -4807,7 +4807,7 @@
                           </a:solidFill>
                           <a:latin typeface="Aptos"/>
                         </a:rPr>
-                        <a:t>Increased every month; Sep highest at RM9.92M</a:t>
+                        <a:t>Increased every month; Sep highest at RM10.12M</a:t>
                       </a:r>
                     </a:p>
                   </a:txBody>
@@ -5301,7 +5301,7 @@
                           </a:solidFill>
                           <a:latin typeface="Aptos"/>
                         </a:rPr>
-                        <a:t>833,010.69</a:t>
+                        <a:t>1,033,010.69</a:t>
                       </a:r>
                     </a:p>
                   </a:txBody>
@@ -5350,7 +5350,7 @@
                           </a:solidFill>
                           <a:latin typeface="Aptos"/>
                         </a:rPr>
-                        <a:t>2,273,524.59</a:t>
+                        <a:t>2,473,524.59</a:t>
                       </a:r>
                     </a:p>
                   </a:txBody>
@@ -5597,7 +5597,7 @@
                           </a:solidFill>
                           <a:latin typeface="Aptos"/>
                         </a:rPr>
-                        <a:t>(2,445,279.73)</a:t>
+                        <a:t>(2,645,279.73)</a:t>
                       </a:r>
                     </a:p>
                   </a:txBody>
@@ -5646,7 +5646,7 @@
                           </a:solidFill>
                           <a:latin typeface="Aptos"/>
                         </a:rPr>
-                        <a:t>(4,356,453.78)</a:t>
+                        <a:t>(4,556,453.78)</a:t>
                       </a:r>
                     </a:p>
                   </a:txBody>
@@ -6396,7 +6396,7 @@
                 </a:solidFill>
                 <a:latin typeface="Aptos"/>
               </a:rPr>
-              <a:t>Cash receipts grew every month from RM9.23M to RM9.92M, but SST payments in July and September (RM2.18M combined) and new-branch capex of RM3.34M pulled cash down. RM2.00M of the decline was placed in fixed deposit, not spent.</a:t>
+              <a:t>Cash receipts grew every month from RM9.23M to RM10.12M, but SST payments in July and September (RM2.18M combined) and new-branch capex of RM3.34M pulled cash down. RM2.00M of the decline was placed in fixed deposit, not spent.</a:t>
             </a:r>
           </a:p>
         </p:txBody>
@@ -6617,13 +6617,13 @@
           <a:p>
             <a:pPr algn="l"/>
             <a:r>
-              <a:rPr b="1" sz="1200">
+              <a:rPr b="1" sz="1150">
                 <a:solidFill>
                   <a:srgbClr val="0F172A"/>
                 </a:solidFill>
                 <a:latin typeface="Aptos"/>
               </a:rPr>
-              <a:t>Total cash receipts increased every month, from RM9.23M in July to RM9.92M in September. Royalty declined after July.</a:t>
+              <a:t>Total cash receipts increased every month, from RM9.23M in July to RM10.12M in September. Royalty declined after July.</a:t>
             </a:r>
           </a:p>
         </p:txBody>
@@ -6658,7 +6658,7 @@
                 </a:solidFill>
                 <a:latin typeface="Aptos"/>
               </a:rPr>
-              <a:t>Source: TGFB Cash Flow Statement PDFs for July, August and September 2026</a:t>
+              <a:t>Source: TGFB Cash Flow Statement PDFs for July, August and September 2026 (September revised upload)</a:t>
             </a:r>
           </a:p>
         </p:txBody>
@@ -7360,7 +7360,7 @@
                           </a:solidFill>
                           <a:latin typeface="Aptos"/>
                         </a:rPr>
-                        <a:t>95.7%</a:t>
+                        <a:t>95.0%</a:t>
                       </a:r>
                     </a:p>
                   </a:txBody>
@@ -7607,7 +7607,7 @@
                           </a:solidFill>
                           <a:latin typeface="Aptos"/>
                         </a:rPr>
-                        <a:t>120,000.00</a:t>
+                        <a:t>320,000.00</a:t>
                       </a:r>
                     </a:p>
                   </a:txBody>
@@ -7656,7 +7656,7 @@
                           </a:solidFill>
                           <a:latin typeface="Aptos"/>
                         </a:rPr>
-                        <a:t>130,000.00</a:t>
+                        <a:t>330,000.00</a:t>
                       </a:r>
                     </a:p>
                   </a:txBody>
@@ -7705,7 +7705,7 @@
                           </a:solidFill>
                           <a:latin typeface="Aptos"/>
                         </a:rPr>
-                        <a:t>0.4%</a:t>
+                        <a:t>1.1%</a:t>
                       </a:r>
                     </a:p>
                   </a:txBody>
@@ -7754,7 +7754,7 @@
                           </a:solidFill>
                           <a:latin typeface="Aptos"/>
                         </a:rPr>
-                        <a:t>No receipts in Jul; RM120K licensing fee in Sep</a:t>
+                        <a:t>Nil in Jul; Sep RM120K fee + RM200K package</a:t>
                       </a:r>
                     </a:p>
                   </a:txBody>
@@ -8642,7 +8642,7 @@
                           </a:solidFill>
                           <a:latin typeface="Aptos"/>
                         </a:rPr>
-                        <a:t>9,919,617.17</a:t>
+                        <a:t>10,119,617.17</a:t>
                       </a:r>
                     </a:p>
                   </a:txBody>
@@ -8691,7 +8691,7 @@
                           </a:solidFill>
                           <a:latin typeface="Aptos"/>
                         </a:rPr>
-                        <a:t>28,946,566.89</a:t>
+                        <a:t>29,146,566.89</a:t>
                       </a:r>
                     </a:p>
                   </a:txBody>
@@ -8901,7 +8901,7 @@
                 </a:solidFill>
                 <a:latin typeface="Aptos"/>
               </a:rPr>
-              <a:t>• Customers &amp; Sales contributed 95.7% of Q3 receipts.</a:t>
+              <a:t>• Customers &amp; Sales contributed 95.0% of Q3 receipts.</a:t>
             </a:r>
           </a:p>
           <a:p>
@@ -8925,7 +8925,7 @@
                 </a:solidFill>
                 <a:latin typeface="Aptos"/>
               </a:rPr>
-              <a:t>• Licensing fee receipts rose from nil in July to RM120.0K in September.</a:t>
+              <a:t>• Licensing fee &amp; package receipts rose from nil in July to RM320.0K in September.</a:t>
             </a:r>
           </a:p>
           <a:p>
@@ -9199,7 +9199,7 @@
                 </a:solidFill>
                 <a:latin typeface="Aptos"/>
               </a:rPr>
-              <a:t>Source: TGFB Cash Flow Statement PDFs for July, August and September 2026</a:t>
+              <a:t>Source: TGFB Cash Flow Statement PDFs for July, August and September 2026 (September revised upload)</a:t>
             </a:r>
           </a:p>
         </p:txBody>
@@ -17221,7 +17221,7 @@
                 </a:solidFill>
                 <a:latin typeface="Aptos"/>
               </a:rPr>
-              <a:t>Source: TGFB Cash Flow Statement PDFs for July, August and September 2026</a:t>
+              <a:t>Source: TGFB Cash Flow Statement PDFs for July, August and September 2026 (September revised upload)</a:t>
             </a:r>
           </a:p>
         </p:txBody>
@@ -17923,7 +17923,7 @@
                           </a:solidFill>
                           <a:latin typeface="Aptos"/>
                         </a:rPr>
-                        <a:t>2.9%</a:t>
+                        <a:t>3.0%</a:t>
                       </a:r>
                     </a:p>
                   </a:txBody>
@@ -18515,7 +18515,7 @@
                           </a:solidFill>
                           <a:latin typeface="Aptos"/>
                         </a:rPr>
-                        <a:t>200,000.00</a:t>
+                        <a:t>0.00</a:t>
                       </a:r>
                     </a:p>
                   </a:txBody>
@@ -18564,7 +18564,7 @@
                           </a:solidFill>
                           <a:latin typeface="Aptos"/>
                         </a:rPr>
-                        <a:t>920,000.00</a:t>
+                        <a:t>720,000.00</a:t>
                       </a:r>
                     </a:p>
                   </a:txBody>
@@ -18613,7 +18613,7 @@
                           </a:solidFill>
                           <a:latin typeface="Aptos"/>
                         </a:rPr>
-                        <a:t>14.0%</a:t>
+                        <a:t>11.3%</a:t>
                       </a:r>
                     </a:p>
                   </a:txBody>
@@ -18662,7 +18662,7 @@
                           </a:solidFill>
                           <a:latin typeface="Aptos"/>
                         </a:rPr>
-                        <a:t>Investor fund; Sep received via RHB</a:t>
+                        <a:t>Investor fund received in Jul</a:t>
                       </a:r>
                     </a:p>
                   </a:txBody>
@@ -19303,7 +19303,7 @@
                           </a:solidFill>
                           <a:latin typeface="Aptos"/>
                         </a:rPr>
-                        <a:t>2.0%</a:t>
+                        <a:t>2.1%</a:t>
                       </a:r>
                     </a:p>
                   </a:txBody>
@@ -19648,7 +19648,7 @@
                           </a:solidFill>
                           <a:latin typeface="Aptos"/>
                         </a:rPr>
-                        <a:t>50.7%</a:t>
+                        <a:t>52.3%</a:t>
                       </a:r>
                     </a:p>
                   </a:txBody>
@@ -19993,7 +19993,7 @@
                           </a:solidFill>
                           <a:latin typeface="Aptos"/>
                         </a:rPr>
-                        <a:t>30.3%</a:t>
+                        <a:t>31.3%</a:t>
                       </a:r>
                     </a:p>
                   </a:txBody>
@@ -20585,7 +20585,7 @@
                           </a:solidFill>
                           <a:latin typeface="Aptos"/>
                         </a:rPr>
-                        <a:t>(2,445,279.73)</a:t>
+                        <a:t>(2,645,279.73)</a:t>
                       </a:r>
                     </a:p>
                   </a:txBody>
@@ -20634,7 +20634,7 @@
                           </a:solidFill>
                           <a:latin typeface="Aptos"/>
                         </a:rPr>
-                        <a:t>(4,356,453.78)</a:t>
+                        <a:t>(4,556,453.78)</a:t>
                       </a:r>
                     </a:p>
                   </a:txBody>

</xml_diff>

<commit_message>
Reclassify Sep investor fund collection to investing in Q3 deck
Moves the RM229K September 'Collection of Investor funds' from financing
to investing, consistent with July and Q2. Net cash flow is unchanged;
the reclassification is noted in the slide source line.

Co-Authored-By: Claude Opus 5.5 <noreply@anthropic.com>
Claude-Session: https://claude.ai/code/session_01UekZ1BuiJW323matwahEES
</commit_message>
<xml_diff>
--- a/q3-finance-report/Q3_2026_Finance_Report.pptx
+++ b/q3-finance-report/Q3_2026_Finance_Report.pptx
@@ -3309,7 +3309,7 @@
         <p:spPr>
           <a:xfrm>
             <a:off x="256032" y="6675120"/>
-            <a:ext cx="7315200" cy="137160"/>
+            <a:ext cx="10972800" cy="137160"/>
           </a:xfrm>
           <a:prstGeom prst="rect">
             <a:avLst/>
@@ -3330,7 +3330,7 @@
                 </a:solidFill>
                 <a:latin typeface="Aptos"/>
               </a:rPr>
-              <a:t>Source: TGFB Cash Flow Statement PDFs for July, August and September 2026 (September revised upload)</a:t>
+              <a:t>Source: TGFB Cash Flow Statement PDFs for July, August and September 2026 (September revised upload). Sep RM229K investor fund reclassified from financing to investing, consistent with Jul and Q2.</a:t>
             </a:r>
           </a:p>
         </p:txBody>
@@ -5597,7 +5597,7 @@
                           </a:solidFill>
                           <a:latin typeface="Aptos"/>
                         </a:rPr>
-                        <a:t>(2,645,279.73)</a:t>
+                        <a:t>(2,416,279.73)</a:t>
                       </a:r>
                     </a:p>
                   </a:txBody>
@@ -5646,7 +5646,7 @@
                           </a:solidFill>
                           <a:latin typeface="Aptos"/>
                         </a:rPr>
-                        <a:t>(4,556,453.78)</a:t>
+                        <a:t>(4,327,453.78)</a:t>
                       </a:r>
                     </a:p>
                   </a:txBody>
@@ -5893,7 +5893,7 @@
                           </a:solidFill>
                           <a:latin typeface="Aptos"/>
                         </a:rPr>
-                        <a:t>(107,801.93)</a:t>
+                        <a:t>(336,801.93)</a:t>
                       </a:r>
                     </a:p>
                   </a:txBody>
@@ -5942,7 +5942,7 @@
                           </a:solidFill>
                           <a:latin typeface="Aptos"/>
                         </a:rPr>
-                        <a:t>(792,374.42)</a:t>
+                        <a:t>(1,021,374.42)</a:t>
                       </a:r>
                     </a:p>
                   </a:txBody>
@@ -6637,7 +6637,7 @@
         <p:spPr>
           <a:xfrm>
             <a:off x="256032" y="6675120"/>
-            <a:ext cx="7315200" cy="137160"/>
+            <a:ext cx="10972800" cy="137160"/>
           </a:xfrm>
           <a:prstGeom prst="rect">
             <a:avLst/>
@@ -6658,7 +6658,7 @@
                 </a:solidFill>
                 <a:latin typeface="Aptos"/>
               </a:rPr>
-              <a:t>Source: TGFB Cash Flow Statement PDFs for July, August and September 2026 (September revised upload)</a:t>
+              <a:t>Source: TGFB Cash Flow Statement PDFs for July, August and September 2026 (September revised upload). Sep RM229K investor fund reclassified from financing to investing, consistent with Jul and Q2.</a:t>
             </a:r>
           </a:p>
         </p:txBody>
@@ -9178,7 +9178,7 @@
         <p:spPr>
           <a:xfrm>
             <a:off x="256032" y="6675120"/>
-            <a:ext cx="7315200" cy="137160"/>
+            <a:ext cx="10972800" cy="137160"/>
           </a:xfrm>
           <a:prstGeom prst="rect">
             <a:avLst/>
@@ -9199,7 +9199,7 @@
                 </a:solidFill>
                 <a:latin typeface="Aptos"/>
               </a:rPr>
-              <a:t>Source: TGFB Cash Flow Statement PDFs for July, August and September 2026 (September revised upload)</a:t>
+              <a:t>Source: TGFB Cash Flow Statement PDFs for July, August and September 2026 (September revised upload). Sep RM229K investor fund reclassified from financing to investing, consistent with Jul and Q2.</a:t>
             </a:r>
           </a:p>
         </p:txBody>
@@ -17200,7 +17200,7 @@
         <p:spPr>
           <a:xfrm>
             <a:off x="256032" y="6675120"/>
-            <a:ext cx="7315200" cy="137160"/>
+            <a:ext cx="10972800" cy="137160"/>
           </a:xfrm>
           <a:prstGeom prst="rect">
             <a:avLst/>
@@ -17221,7 +17221,7 @@
                 </a:solidFill>
                 <a:latin typeface="Aptos"/>
               </a:rPr>
-              <a:t>Source: TGFB Cash Flow Statement PDFs for July, August and September 2026 (September revised upload)</a:t>
+              <a:t>Source: TGFB Cash Flow Statement PDFs for July, August and September 2026 (September revised upload). Sep RM229K investor fund reclassified from financing to investing, consistent with Jul and Q2.</a:t>
             </a:r>
           </a:p>
         </p:txBody>
@@ -17923,7 +17923,7 @@
                           </a:solidFill>
                           <a:latin typeface="Aptos"/>
                         </a:rPr>
-                        <a:t>3.0%</a:t>
+                        <a:t>2.9%</a:t>
                       </a:r>
                     </a:p>
                   </a:txBody>
@@ -18515,7 +18515,7 @@
                           </a:solidFill>
                           <a:latin typeface="Aptos"/>
                         </a:rPr>
-                        <a:t>0.00</a:t>
+                        <a:t>229,000.00</a:t>
                       </a:r>
                     </a:p>
                   </a:txBody>
@@ -18564,7 +18564,7 @@
                           </a:solidFill>
                           <a:latin typeface="Aptos"/>
                         </a:rPr>
-                        <a:t>720,000.00</a:t>
+                        <a:t>949,000.00</a:t>
                       </a:r>
                     </a:p>
                   </a:txBody>
@@ -18613,7 +18613,7 @@
                           </a:solidFill>
                           <a:latin typeface="Aptos"/>
                         </a:rPr>
-                        <a:t>11.3%</a:t>
+                        <a:t>14.3%</a:t>
                       </a:r>
                     </a:p>
                   </a:txBody>
@@ -18662,7 +18662,7 @@
                           </a:solidFill>
                           <a:latin typeface="Aptos"/>
                         </a:rPr>
-                        <a:t>Investor fund received in Jul</a:t>
+                        <a:t>Investor fund; Sep reclassified from financing</a:t>
                       </a:r>
                     </a:p>
                   </a:txBody>
@@ -19303,7 +19303,7 @@
                           </a:solidFill>
                           <a:latin typeface="Aptos"/>
                         </a:rPr>
-                        <a:t>2.1%</a:t>
+                        <a:t>2.0%</a:t>
                       </a:r>
                     </a:p>
                   </a:txBody>
@@ -19648,7 +19648,7 @@
                           </a:solidFill>
                           <a:latin typeface="Aptos"/>
                         </a:rPr>
-                        <a:t>52.3%</a:t>
+                        <a:t>50.5%</a:t>
                       </a:r>
                     </a:p>
                   </a:txBody>
@@ -19993,7 +19993,7 @@
                           </a:solidFill>
                           <a:latin typeface="Aptos"/>
                         </a:rPr>
-                        <a:t>31.3%</a:t>
+                        <a:t>30.2%</a:t>
                       </a:r>
                     </a:p>
                   </a:txBody>
@@ -20585,7 +20585,7 @@
                           </a:solidFill>
                           <a:latin typeface="Aptos"/>
                         </a:rPr>
-                        <a:t>(2,645,279.73)</a:t>
+                        <a:t>(2,416,279.73)</a:t>
                       </a:r>
                     </a:p>
                   </a:txBody>
@@ -20634,7 +20634,7 @@
                           </a:solidFill>
                           <a:latin typeface="Aptos"/>
                         </a:rPr>
-                        <a:t>(4,556,453.78)</a:t>
+                        <a:t>(4,327,453.78)</a:t>
                       </a:r>
                     </a:p>
                   </a:txBody>
@@ -20845,7 +20845,7 @@
         </p:nvGraphicFramePr>
         <p:xfrm>
           <a:off x="256032" y="3730752"/>
-          <a:ext cx="11676888" cy="2377440"/>
+          <a:ext cx="11676888" cy="2194560"/>
         </p:xfrm>
         <a:graphic>
           <a:graphicData uri="http://schemas.openxmlformats.org/drawingml/2006/table">
@@ -21913,7 +21913,7 @@
                           </a:solidFill>
                           <a:latin typeface="Aptos"/>
                         </a:rPr>
-                        <a:t>Collection of Investor funds</a:t>
+                        <a:t>Borrowing</a:t>
                       </a:r>
                     </a:p>
                   </a:txBody>
@@ -22060,7 +22060,7 @@
                           </a:solidFill>
                           <a:latin typeface="Aptos"/>
                         </a:rPr>
-                        <a:t>229,000.00</a:t>
+                        <a:t>0.00</a:t>
                       </a:r>
                     </a:p>
                   </a:txBody>
@@ -22109,7 +22109,7 @@
                           </a:solidFill>
                           <a:latin typeface="Aptos"/>
                         </a:rPr>
-                        <a:t>229,000.00</a:t>
+                        <a:t>0.00</a:t>
                       </a:r>
                     </a:p>
                   </a:txBody>
@@ -22158,7 +22158,7 @@
                           </a:solidFill>
                           <a:latin typeface="Aptos"/>
                         </a:rPr>
-                        <a:t>13.1%</a:t>
+                        <a:t>0.0%</a:t>
                       </a:r>
                     </a:p>
                   </a:txBody>
@@ -22207,7 +22207,7 @@
                           </a:solidFill>
                           <a:latin typeface="Aptos"/>
                         </a:rPr>
-                        <a:t>Investor fund recorded under financing in Sep</a:t>
+                        <a:t> </a:t>
                       </a:r>
                     </a:p>
                   </a:txBody>
@@ -22258,7 +22258,7 @@
                           </a:solidFill>
                           <a:latin typeface="Aptos"/>
                         </a:rPr>
-                        <a:t>Borrowing</a:t>
+                        <a:t>Repayment from related parties</a:t>
                       </a:r>
                     </a:p>
                   </a:txBody>
@@ -22303,11 +22303,11 @@
                       <a:r>
                         <a:rPr b="1" sz="800">
                           <a:solidFill>
-                            <a:srgbClr val="0F172A"/>
-                          </a:solidFill>
-                          <a:latin typeface="Aptos"/>
-                        </a:rPr>
-                        <a:t>0.00</a:t>
+                            <a:srgbClr val="C00000"/>
+                          </a:solidFill>
+                          <a:latin typeface="Aptos"/>
+                        </a:rPr>
+                        <a:t>(79,760.50)</a:t>
                       </a:r>
                     </a:p>
                   </a:txBody>
@@ -22356,7 +22356,7 @@
                           </a:solidFill>
                           <a:latin typeface="Aptos"/>
                         </a:rPr>
-                        <a:t>0.00</a:t>
+                        <a:t>230,281.85</a:t>
                       </a:r>
                     </a:p>
                   </a:txBody>
@@ -22405,7 +22405,7 @@
                           </a:solidFill>
                           <a:latin typeface="Aptos"/>
                         </a:rPr>
-                        <a:t>0.00</a:t>
+                        <a:t>15,899.00</a:t>
                       </a:r>
                     </a:p>
                   </a:txBody>
@@ -22454,7 +22454,7 @@
                           </a:solidFill>
                           <a:latin typeface="Aptos"/>
                         </a:rPr>
-                        <a:t>0.00</a:t>
+                        <a:t>166,420.35</a:t>
                       </a:r>
                     </a:p>
                   </a:txBody>
@@ -22503,7 +22503,7 @@
                           </a:solidFill>
                           <a:latin typeface="Aptos"/>
                         </a:rPr>
-                        <a:t>0.0%</a:t>
+                        <a:t>21.5%</a:t>
                       </a:r>
                     </a:p>
                   </a:txBody>
@@ -22552,7 +22552,7 @@
                           </a:solidFill>
                           <a:latin typeface="Aptos"/>
                         </a:rPr>
-                        <a:t> </a:t>
+                        <a:t>Net outflow in Jul; RM230.3K received in Aug</a:t>
                       </a:r>
                     </a:p>
                   </a:txBody>
@@ -22603,7 +22603,7 @@
                           </a:solidFill>
                           <a:latin typeface="Aptos"/>
                         </a:rPr>
-                        <a:t>Repayment from related parties</a:t>
+                        <a:t>Purchase of investment</a:t>
                       </a:r>
                     </a:p>
                   </a:txBody>
@@ -22652,7 +22652,7 @@
                           </a:solidFill>
                           <a:latin typeface="Aptos"/>
                         </a:rPr>
-                        <a:t>(79,760.50)</a:t>
+                        <a:t>(286,293.00)</a:t>
                       </a:r>
                     </a:p>
                   </a:txBody>
@@ -22701,7 +22701,7 @@
                           </a:solidFill>
                           <a:latin typeface="Aptos"/>
                         </a:rPr>
-                        <a:t>230,281.85</a:t>
+                        <a:t>0.00</a:t>
                       </a:r>
                     </a:p>
                   </a:txBody>
@@ -22750,7 +22750,7 @@
                           </a:solidFill>
                           <a:latin typeface="Aptos"/>
                         </a:rPr>
-                        <a:t>15,899.00</a:t>
+                        <a:t>0.00</a:t>
                       </a:r>
                     </a:p>
                   </a:txBody>
@@ -22795,11 +22795,11 @@
                       <a:r>
                         <a:rPr b="1" sz="800">
                           <a:solidFill>
-                            <a:srgbClr val="0F172A"/>
-                          </a:solidFill>
-                          <a:latin typeface="Aptos"/>
-                        </a:rPr>
-                        <a:t>166,420.35</a:t>
+                            <a:srgbClr val="C00000"/>
+                          </a:solidFill>
+                          <a:latin typeface="Aptos"/>
+                        </a:rPr>
+                        <a:t>(286,293.00)</a:t>
                       </a:r>
                     </a:p>
                   </a:txBody>
@@ -22848,7 +22848,7 @@
                           </a:solidFill>
                           <a:latin typeface="Aptos"/>
                         </a:rPr>
-                        <a:t>18.7%</a:t>
+                        <a:t>18.9%</a:t>
                       </a:r>
                     </a:p>
                   </a:txBody>
@@ -22897,7 +22897,7 @@
                           </a:solidFill>
                           <a:latin typeface="Aptos"/>
                         </a:rPr>
-                        <a:t>Net outflow in Jul; RM230.3K received in Aug</a:t>
+                        <a:t>Jul only (recorded under financing)</a:t>
                       </a:r>
                     </a:p>
                   </a:txBody>
@@ -22948,7 +22948,7 @@
                           </a:solidFill>
                           <a:latin typeface="Aptos"/>
                         </a:rPr>
-                        <a:t>Purchase of investment</a:t>
+                        <a:t>Repayment of loans</a:t>
                       </a:r>
                     </a:p>
                   </a:txBody>
@@ -22997,7 +22997,7 @@
                           </a:solidFill>
                           <a:latin typeface="Aptos"/>
                         </a:rPr>
-                        <a:t>(286,293.00)</a:t>
+                        <a:t>(159,745.15)</a:t>
                       </a:r>
                     </a:p>
                   </a:txBody>
@@ -23042,11 +23042,11 @@
                       <a:r>
                         <a:rPr b="1" sz="800">
                           <a:solidFill>
-                            <a:srgbClr val="0F172A"/>
-                          </a:solidFill>
-                          <a:latin typeface="Aptos"/>
-                        </a:rPr>
-                        <a:t>0.00</a:t>
+                            <a:srgbClr val="C00000"/>
+                          </a:solidFill>
+                          <a:latin typeface="Aptos"/>
+                        </a:rPr>
+                        <a:t>(155,237.00)</a:t>
                       </a:r>
                     </a:p>
                   </a:txBody>
@@ -23091,11 +23091,11 @@
                       <a:r>
                         <a:rPr b="1" sz="800">
                           <a:solidFill>
-                            <a:srgbClr val="0F172A"/>
-                          </a:solidFill>
-                          <a:latin typeface="Aptos"/>
-                        </a:rPr>
-                        <a:t>0.00</a:t>
+                            <a:srgbClr val="C00000"/>
+                          </a:solidFill>
+                          <a:latin typeface="Aptos"/>
+                        </a:rPr>
+                        <a:t>(159,887.29)</a:t>
                       </a:r>
                     </a:p>
                   </a:txBody>
@@ -23144,7 +23144,7 @@
                           </a:solidFill>
                           <a:latin typeface="Aptos"/>
                         </a:rPr>
-                        <a:t>(286,293.00)</a:t>
+                        <a:t>(474,869.44)</a:t>
                       </a:r>
                     </a:p>
                   </a:txBody>
@@ -23193,7 +23193,7 @@
                           </a:solidFill>
                           <a:latin typeface="Aptos"/>
                         </a:rPr>
-                        <a:t>16.4%</a:t>
+                        <a:t>31.4%</a:t>
                       </a:r>
                     </a:p>
                   </a:txBody>
@@ -23242,7 +23242,7 @@
                           </a:solidFill>
                           <a:latin typeface="Aptos"/>
                         </a:rPr>
-                        <a:t>Jul only (recorded under financing)</a:t>
+                        <a:t>Stable at about RM155K-RM160K monthly</a:t>
                       </a:r>
                     </a:p>
                   </a:txBody>
@@ -23293,7 +23293,7 @@
                           </a:solidFill>
                           <a:latin typeface="Aptos"/>
                         </a:rPr>
-                        <a:t>Repayment of loans</a:t>
+                        <a:t>Dividends</a:t>
                       </a:r>
                     </a:p>
                   </a:txBody>
@@ -23338,11 +23338,11 @@
                       <a:r>
                         <a:rPr b="1" sz="800">
                           <a:solidFill>
-                            <a:srgbClr val="C00000"/>
-                          </a:solidFill>
-                          <a:latin typeface="Aptos"/>
-                        </a:rPr>
-                        <a:t>(159,745.15)</a:t>
+                            <a:srgbClr val="0F172A"/>
+                          </a:solidFill>
+                          <a:latin typeface="Aptos"/>
+                        </a:rPr>
+                        <a:t>0.00</a:t>
                       </a:r>
                     </a:p>
                   </a:txBody>
@@ -23387,11 +23387,11 @@
                       <a:r>
                         <a:rPr b="1" sz="800">
                           <a:solidFill>
-                            <a:srgbClr val="C00000"/>
-                          </a:solidFill>
-                          <a:latin typeface="Aptos"/>
-                        </a:rPr>
-                        <a:t>(155,237.00)</a:t>
+                            <a:srgbClr val="0F172A"/>
+                          </a:solidFill>
+                          <a:latin typeface="Aptos"/>
+                        </a:rPr>
+                        <a:t>0.00</a:t>
                       </a:r>
                     </a:p>
                   </a:txBody>
@@ -23436,11 +23436,11 @@
                       <a:r>
                         <a:rPr b="1" sz="800">
                           <a:solidFill>
-                            <a:srgbClr val="C00000"/>
-                          </a:solidFill>
-                          <a:latin typeface="Aptos"/>
-                        </a:rPr>
-                        <a:t>(159,887.29)</a:t>
+                            <a:srgbClr val="0F172A"/>
+                          </a:solidFill>
+                          <a:latin typeface="Aptos"/>
+                        </a:rPr>
+                        <a:t>0.00</a:t>
                       </a:r>
                     </a:p>
                   </a:txBody>
@@ -23485,11 +23485,11 @@
                       <a:r>
                         <a:rPr b="1" sz="800">
                           <a:solidFill>
-                            <a:srgbClr val="C00000"/>
-                          </a:solidFill>
-                          <a:latin typeface="Aptos"/>
-                        </a:rPr>
-                        <a:t>(474,869.44)</a:t>
+                            <a:srgbClr val="0F172A"/>
+                          </a:solidFill>
+                          <a:latin typeface="Aptos"/>
+                        </a:rPr>
+                        <a:t>0.00</a:t>
                       </a:r>
                     </a:p>
                   </a:txBody>
@@ -23538,7 +23538,7 @@
                           </a:solidFill>
                           <a:latin typeface="Aptos"/>
                         </a:rPr>
-                        <a:t>27.2%</a:t>
+                        <a:t>0.0%</a:t>
                       </a:r>
                     </a:p>
                   </a:txBody>
@@ -23587,7 +23587,7 @@
                           </a:solidFill>
                           <a:latin typeface="Aptos"/>
                         </a:rPr>
-                        <a:t>Stable at about RM155K-RM160K monthly</a:t>
+                        <a:t> </a:t>
                       </a:r>
                     </a:p>
                   </a:txBody>
@@ -23638,7 +23638,7 @@
                           </a:solidFill>
                           <a:latin typeface="Aptos"/>
                         </a:rPr>
-                        <a:t>Dividends</a:t>
+                        <a:t>Advance to related parties</a:t>
                       </a:r>
                     </a:p>
                   </a:txBody>
@@ -23683,11 +23683,11 @@
                       <a:r>
                         <a:rPr b="1" sz="800">
                           <a:solidFill>
-                            <a:srgbClr val="0F172A"/>
-                          </a:solidFill>
-                          <a:latin typeface="Aptos"/>
-                        </a:rPr>
-                        <a:t>0.00</a:t>
+                            <a:srgbClr val="C00000"/>
+                          </a:solidFill>
+                          <a:latin typeface="Aptos"/>
+                        </a:rPr>
+                        <a:t>(233,400.76)</a:t>
                       </a:r>
                     </a:p>
                   </a:txBody>
@@ -23732,11 +23732,11 @@
                       <a:r>
                         <a:rPr b="1" sz="800">
                           <a:solidFill>
-                            <a:srgbClr val="0F172A"/>
-                          </a:solidFill>
-                          <a:latin typeface="Aptos"/>
-                        </a:rPr>
-                        <a:t>0.00</a:t>
+                            <a:srgbClr val="C00000"/>
+                          </a:solidFill>
+                          <a:latin typeface="Aptos"/>
+                        </a:rPr>
+                        <a:t>(417.93)</a:t>
                       </a:r>
                     </a:p>
                   </a:txBody>
@@ -23781,11 +23781,11 @@
                       <a:r>
                         <a:rPr b="1" sz="800">
                           <a:solidFill>
-                            <a:srgbClr val="0F172A"/>
-                          </a:solidFill>
-                          <a:latin typeface="Aptos"/>
-                        </a:rPr>
-                        <a:t>0.00</a:t>
+                            <a:srgbClr val="C00000"/>
+                          </a:solidFill>
+                          <a:latin typeface="Aptos"/>
+                        </a:rPr>
+                        <a:t>(192,813.64)</a:t>
                       </a:r>
                     </a:p>
                   </a:txBody>
@@ -23830,11 +23830,11 @@
                       <a:r>
                         <a:rPr b="1" sz="800">
                           <a:solidFill>
-                            <a:srgbClr val="0F172A"/>
-                          </a:solidFill>
-                          <a:latin typeface="Aptos"/>
-                        </a:rPr>
-                        <a:t>0.00</a:t>
+                            <a:srgbClr val="C00000"/>
+                          </a:solidFill>
+                          <a:latin typeface="Aptos"/>
+                        </a:rPr>
+                        <a:t>(426,632.33)</a:t>
                       </a:r>
                     </a:p>
                   </a:txBody>
@@ -23883,7 +23883,7 @@
                           </a:solidFill>
                           <a:latin typeface="Aptos"/>
                         </a:rPr>
-                        <a:t>0.0%</a:t>
+                        <a:t>28.2%</a:t>
                       </a:r>
                     </a:p>
                   </a:txBody>
@@ -23932,7 +23932,7 @@
                           </a:solidFill>
                           <a:latin typeface="Aptos"/>
                         </a:rPr>
-                        <a:t> </a:t>
+                        <a:t>Jul-26 highest; Aug-26 minimal</a:t>
                       </a:r>
                     </a:p>
                   </a:txBody>
@@ -23983,7 +23983,7 @@
                           </a:solidFill>
                           <a:latin typeface="Aptos"/>
                         </a:rPr>
-                        <a:t>Advance to related parties</a:t>
+                        <a:t>Repayment to related parties</a:t>
                       </a:r>
                     </a:p>
                   </a:txBody>
@@ -24028,11 +24028,11 @@
                       <a:r>
                         <a:rPr b="1" sz="800">
                           <a:solidFill>
-                            <a:srgbClr val="C00000"/>
-                          </a:solidFill>
-                          <a:latin typeface="Aptos"/>
-                        </a:rPr>
-                        <a:t>(233,400.76)</a:t>
+                            <a:srgbClr val="0F172A"/>
+                          </a:solidFill>
+                          <a:latin typeface="Aptos"/>
+                        </a:rPr>
+                        <a:t>0.00</a:t>
                       </a:r>
                     </a:p>
                   </a:txBody>
@@ -24077,11 +24077,11 @@
                       <a:r>
                         <a:rPr b="1" sz="800">
                           <a:solidFill>
-                            <a:srgbClr val="C00000"/>
-                          </a:solidFill>
-                          <a:latin typeface="Aptos"/>
-                        </a:rPr>
-                        <a:t>(417.93)</a:t>
+                            <a:srgbClr val="0F172A"/>
+                          </a:solidFill>
+                          <a:latin typeface="Aptos"/>
+                        </a:rPr>
+                        <a:t>0.00</a:t>
                       </a:r>
                     </a:p>
                   </a:txBody>
@@ -24126,11 +24126,11 @@
                       <a:r>
                         <a:rPr b="1" sz="800">
                           <a:solidFill>
-                            <a:srgbClr val="C00000"/>
-                          </a:solidFill>
-                          <a:latin typeface="Aptos"/>
-                        </a:rPr>
-                        <a:t>(192,813.64)</a:t>
+                            <a:srgbClr val="0F172A"/>
+                          </a:solidFill>
+                          <a:latin typeface="Aptos"/>
+                        </a:rPr>
+                        <a:t>0.00</a:t>
                       </a:r>
                     </a:p>
                   </a:txBody>
@@ -24175,11 +24175,11 @@
                       <a:r>
                         <a:rPr b="1" sz="800">
                           <a:solidFill>
-                            <a:srgbClr val="C00000"/>
-                          </a:solidFill>
-                          <a:latin typeface="Aptos"/>
-                        </a:rPr>
-                        <a:t>(426,632.33)</a:t>
+                            <a:srgbClr val="0F172A"/>
+                          </a:solidFill>
+                          <a:latin typeface="Aptos"/>
+                        </a:rPr>
+                        <a:t>0.00</a:t>
                       </a:r>
                     </a:p>
                   </a:txBody>
@@ -24228,7 +24228,7 @@
                           </a:solidFill>
                           <a:latin typeface="Aptos"/>
                         </a:rPr>
-                        <a:t>24.5%</a:t>
+                        <a:t>0.0%</a:t>
                       </a:r>
                     </a:p>
                   </a:txBody>
@@ -24277,7 +24277,7 @@
                           </a:solidFill>
                           <a:latin typeface="Aptos"/>
                         </a:rPr>
-                        <a:t>Jul-26 highest; Aug-26 minimal</a:t>
+                        <a:t> </a:t>
                       </a:r>
                     </a:p>
                   </a:txBody>
@@ -24328,7 +24328,7 @@
                           </a:solidFill>
                           <a:latin typeface="Aptos"/>
                         </a:rPr>
-                        <a:t>Repayment to related parties</a:t>
+                        <a:t>Pending</a:t>
                       </a:r>
                     </a:p>
                   </a:txBody>
@@ -24669,41 +24669,41 @@
                       <a:r>
                         <a:rPr b="1" sz="800">
                           <a:solidFill>
-                            <a:srgbClr val="0F172A"/>
-                          </a:solidFill>
-                          <a:latin typeface="Aptos"/>
-                        </a:rPr>
-                        <a:t>Pending</a:t>
-                      </a:r>
-                    </a:p>
-                  </a:txBody>
-                  <a:tcPr marL="45720" marR="45720" marT="0" marB="0" anchor="ctr">
-                    <a:lnL w="12700" cap="flat" cmpd="sng" algn="ctr">
-                      <a:solidFill>
-                        <a:srgbClr val="FFFFFF"/>
-                      </a:solidFill>
-                      <a:prstDash val="solid"/>
-                    </a:lnL>
-                    <a:lnR w="12700" cap="flat" cmpd="sng" algn="ctr">
-                      <a:solidFill>
-                        <a:srgbClr val="FFFFFF"/>
-                      </a:solidFill>
-                      <a:prstDash val="solid"/>
-                    </a:lnR>
-                    <a:lnT w="12700" cap="flat" cmpd="sng" algn="ctr">
-                      <a:solidFill>
-                        <a:srgbClr val="FFFFFF"/>
-                      </a:solidFill>
-                      <a:prstDash val="solid"/>
-                    </a:lnT>
-                    <a:lnB w="12700" cap="flat" cmpd="sng" algn="ctr">
-                      <a:solidFill>
-                        <a:srgbClr val="FFFFFF"/>
-                      </a:solidFill>
-                      <a:prstDash val="solid"/>
-                    </a:lnB>
-                    <a:solidFill>
-                      <a:srgbClr val="FFF2B3"/>
+                            <a:srgbClr val="FFFFFF"/>
+                          </a:solidFill>
+                          <a:latin typeface="Aptos"/>
+                        </a:rPr>
+                        <a:t>NET FINANCING ACTIVITIES</a:t>
+                      </a:r>
+                    </a:p>
+                  </a:txBody>
+                  <a:tcPr marL="45720" marR="45720" marT="0" marB="0" anchor="ctr">
+                    <a:lnL w="12700" cap="flat" cmpd="sng" algn="ctr">
+                      <a:solidFill>
+                        <a:srgbClr val="FFFFFF"/>
+                      </a:solidFill>
+                      <a:prstDash val="solid"/>
+                    </a:lnL>
+                    <a:lnR w="12700" cap="flat" cmpd="sng" algn="ctr">
+                      <a:solidFill>
+                        <a:srgbClr val="FFFFFF"/>
+                      </a:solidFill>
+                      <a:prstDash val="solid"/>
+                    </a:lnR>
+                    <a:lnT w="12700" cap="flat" cmpd="sng" algn="ctr">
+                      <a:solidFill>
+                        <a:srgbClr val="FFFFFF"/>
+                      </a:solidFill>
+                      <a:prstDash val="solid"/>
+                    </a:lnT>
+                    <a:lnB w="12700" cap="flat" cmpd="sng" algn="ctr">
+                      <a:solidFill>
+                        <a:srgbClr val="FFFFFF"/>
+                      </a:solidFill>
+                      <a:prstDash val="solid"/>
+                    </a:lnB>
+                    <a:solidFill>
+                      <a:srgbClr val="081E42"/>
                     </a:solidFill>
                   </a:tcPr>
                 </a:tc>
@@ -24718,41 +24718,41 @@
                       <a:r>
                         <a:rPr b="1" sz="800">
                           <a:solidFill>
-                            <a:srgbClr val="0F172A"/>
-                          </a:solidFill>
-                          <a:latin typeface="Aptos"/>
-                        </a:rPr>
-                        <a:t>0.00</a:t>
-                      </a:r>
-                    </a:p>
-                  </a:txBody>
-                  <a:tcPr marL="45720" marR="45720" marT="0" marB="0" anchor="ctr">
-                    <a:lnL w="12700" cap="flat" cmpd="sng" algn="ctr">
-                      <a:solidFill>
-                        <a:srgbClr val="FFFFFF"/>
-                      </a:solidFill>
-                      <a:prstDash val="solid"/>
-                    </a:lnL>
-                    <a:lnR w="12700" cap="flat" cmpd="sng" algn="ctr">
-                      <a:solidFill>
-                        <a:srgbClr val="FFFFFF"/>
-                      </a:solidFill>
-                      <a:prstDash val="solid"/>
-                    </a:lnR>
-                    <a:lnT w="12700" cap="flat" cmpd="sng" algn="ctr">
-                      <a:solidFill>
-                        <a:srgbClr val="FFFFFF"/>
-                      </a:solidFill>
-                      <a:prstDash val="solid"/>
-                    </a:lnT>
-                    <a:lnB w="12700" cap="flat" cmpd="sng" algn="ctr">
-                      <a:solidFill>
-                        <a:srgbClr val="FFFFFF"/>
-                      </a:solidFill>
-                      <a:prstDash val="solid"/>
-                    </a:lnB>
-                    <a:solidFill>
-                      <a:srgbClr val="F8FAFC"/>
+                            <a:srgbClr val="C00000"/>
+                          </a:solidFill>
+                          <a:latin typeface="Aptos"/>
+                        </a:rPr>
+                        <a:t>(759,199.41)</a:t>
+                      </a:r>
+                    </a:p>
+                  </a:txBody>
+                  <a:tcPr marL="45720" marR="45720" marT="0" marB="0" anchor="ctr">
+                    <a:lnL w="12700" cap="flat" cmpd="sng" algn="ctr">
+                      <a:solidFill>
+                        <a:srgbClr val="FFFFFF"/>
+                      </a:solidFill>
+                      <a:prstDash val="solid"/>
+                    </a:lnL>
+                    <a:lnR w="12700" cap="flat" cmpd="sng" algn="ctr">
+                      <a:solidFill>
+                        <a:srgbClr val="FFFFFF"/>
+                      </a:solidFill>
+                      <a:prstDash val="solid"/>
+                    </a:lnR>
+                    <a:lnT w="12700" cap="flat" cmpd="sng" algn="ctr">
+                      <a:solidFill>
+                        <a:srgbClr val="FFFFFF"/>
+                      </a:solidFill>
+                      <a:prstDash val="solid"/>
+                    </a:lnT>
+                    <a:lnB w="12700" cap="flat" cmpd="sng" algn="ctr">
+                      <a:solidFill>
+                        <a:srgbClr val="FFFFFF"/>
+                      </a:solidFill>
+                      <a:prstDash val="solid"/>
+                    </a:lnB>
+                    <a:solidFill>
+                      <a:srgbClr val="FFC20E"/>
                     </a:solidFill>
                   </a:tcPr>
                 </a:tc>
@@ -24771,37 +24771,37 @@
                           </a:solidFill>
                           <a:latin typeface="Aptos"/>
                         </a:rPr>
-                        <a:t>0.00</a:t>
-                      </a:r>
-                    </a:p>
-                  </a:txBody>
-                  <a:tcPr marL="45720" marR="45720" marT="0" marB="0" anchor="ctr">
-                    <a:lnL w="12700" cap="flat" cmpd="sng" algn="ctr">
-                      <a:solidFill>
-                        <a:srgbClr val="FFFFFF"/>
-                      </a:solidFill>
-                      <a:prstDash val="solid"/>
-                    </a:lnL>
-                    <a:lnR w="12700" cap="flat" cmpd="sng" algn="ctr">
-                      <a:solidFill>
-                        <a:srgbClr val="FFFFFF"/>
-                      </a:solidFill>
-                      <a:prstDash val="solid"/>
-                    </a:lnR>
-                    <a:lnT w="12700" cap="flat" cmpd="sng" algn="ctr">
-                      <a:solidFill>
-                        <a:srgbClr val="FFFFFF"/>
-                      </a:solidFill>
-                      <a:prstDash val="solid"/>
-                    </a:lnT>
-                    <a:lnB w="12700" cap="flat" cmpd="sng" algn="ctr">
-                      <a:solidFill>
-                        <a:srgbClr val="FFFFFF"/>
-                      </a:solidFill>
-                      <a:prstDash val="solid"/>
-                    </a:lnB>
-                    <a:solidFill>
-                      <a:srgbClr val="FFFFFF"/>
+                        <a:t>74,626.92</a:t>
+                      </a:r>
+                    </a:p>
+                  </a:txBody>
+                  <a:tcPr marL="45720" marR="45720" marT="0" marB="0" anchor="ctr">
+                    <a:lnL w="12700" cap="flat" cmpd="sng" algn="ctr">
+                      <a:solidFill>
+                        <a:srgbClr val="FFFFFF"/>
+                      </a:solidFill>
+                      <a:prstDash val="solid"/>
+                    </a:lnL>
+                    <a:lnR w="12700" cap="flat" cmpd="sng" algn="ctr">
+                      <a:solidFill>
+                        <a:srgbClr val="FFFFFF"/>
+                      </a:solidFill>
+                      <a:prstDash val="solid"/>
+                    </a:lnR>
+                    <a:lnT w="12700" cap="flat" cmpd="sng" algn="ctr">
+                      <a:solidFill>
+                        <a:srgbClr val="FFFFFF"/>
+                      </a:solidFill>
+                      <a:prstDash val="solid"/>
+                    </a:lnT>
+                    <a:lnB w="12700" cap="flat" cmpd="sng" algn="ctr">
+                      <a:solidFill>
+                        <a:srgbClr val="FFFFFF"/>
+                      </a:solidFill>
+                      <a:prstDash val="solid"/>
+                    </a:lnB>
+                    <a:solidFill>
+                      <a:srgbClr val="FFC20E"/>
                     </a:solidFill>
                   </a:tcPr>
                 </a:tc>
@@ -24816,41 +24816,41 @@
                       <a:r>
                         <a:rPr b="1" sz="800">
                           <a:solidFill>
-                            <a:srgbClr val="0F172A"/>
-                          </a:solidFill>
-                          <a:latin typeface="Aptos"/>
-                        </a:rPr>
-                        <a:t>0.00</a:t>
-                      </a:r>
-                    </a:p>
-                  </a:txBody>
-                  <a:tcPr marL="45720" marR="45720" marT="0" marB="0" anchor="ctr">
-                    <a:lnL w="12700" cap="flat" cmpd="sng" algn="ctr">
-                      <a:solidFill>
-                        <a:srgbClr val="FFFFFF"/>
-                      </a:solidFill>
-                      <a:prstDash val="solid"/>
-                    </a:lnL>
-                    <a:lnR w="12700" cap="flat" cmpd="sng" algn="ctr">
-                      <a:solidFill>
-                        <a:srgbClr val="FFFFFF"/>
-                      </a:solidFill>
-                      <a:prstDash val="solid"/>
-                    </a:lnR>
-                    <a:lnT w="12700" cap="flat" cmpd="sng" algn="ctr">
-                      <a:solidFill>
-                        <a:srgbClr val="FFFFFF"/>
-                      </a:solidFill>
-                      <a:prstDash val="solid"/>
-                    </a:lnT>
-                    <a:lnB w="12700" cap="flat" cmpd="sng" algn="ctr">
-                      <a:solidFill>
-                        <a:srgbClr val="FFFFFF"/>
-                      </a:solidFill>
-                      <a:prstDash val="solid"/>
-                    </a:lnB>
-                    <a:solidFill>
-                      <a:srgbClr val="F8FAFC"/>
+                            <a:srgbClr val="C00000"/>
+                          </a:solidFill>
+                          <a:latin typeface="Aptos"/>
+                        </a:rPr>
+                        <a:t>(336,801.93)</a:t>
+                      </a:r>
+                    </a:p>
+                  </a:txBody>
+                  <a:tcPr marL="45720" marR="45720" marT="0" marB="0" anchor="ctr">
+                    <a:lnL w="12700" cap="flat" cmpd="sng" algn="ctr">
+                      <a:solidFill>
+                        <a:srgbClr val="FFFFFF"/>
+                      </a:solidFill>
+                      <a:prstDash val="solid"/>
+                    </a:lnL>
+                    <a:lnR w="12700" cap="flat" cmpd="sng" algn="ctr">
+                      <a:solidFill>
+                        <a:srgbClr val="FFFFFF"/>
+                      </a:solidFill>
+                      <a:prstDash val="solid"/>
+                    </a:lnR>
+                    <a:lnT w="12700" cap="flat" cmpd="sng" algn="ctr">
+                      <a:solidFill>
+                        <a:srgbClr val="FFFFFF"/>
+                      </a:solidFill>
+                      <a:prstDash val="solid"/>
+                    </a:lnT>
+                    <a:lnB w="12700" cap="flat" cmpd="sng" algn="ctr">
+                      <a:solidFill>
+                        <a:srgbClr val="FFFFFF"/>
+                      </a:solidFill>
+                      <a:prstDash val="solid"/>
+                    </a:lnB>
+                    <a:solidFill>
+                      <a:srgbClr val="FFC20E"/>
                     </a:solidFill>
                   </a:tcPr>
                 </a:tc>
@@ -24865,356 +24865,11 @@
                       <a:r>
                         <a:rPr b="1" sz="800">
                           <a:solidFill>
-                            <a:srgbClr val="0F172A"/>
-                          </a:solidFill>
-                          <a:latin typeface="Aptos"/>
-                        </a:rPr>
-                        <a:t>0.00</a:t>
-                      </a:r>
-                    </a:p>
-                  </a:txBody>
-                  <a:tcPr marL="45720" marR="45720" marT="0" marB="0" anchor="ctr">
-                    <a:lnL w="12700" cap="flat" cmpd="sng" algn="ctr">
-                      <a:solidFill>
-                        <a:srgbClr val="FFFFFF"/>
-                      </a:solidFill>
-                      <a:prstDash val="solid"/>
-                    </a:lnL>
-                    <a:lnR w="12700" cap="flat" cmpd="sng" algn="ctr">
-                      <a:solidFill>
-                        <a:srgbClr val="FFFFFF"/>
-                      </a:solidFill>
-                      <a:prstDash val="solid"/>
-                    </a:lnR>
-                    <a:lnT w="12700" cap="flat" cmpd="sng" algn="ctr">
-                      <a:solidFill>
-                        <a:srgbClr val="FFFFFF"/>
-                      </a:solidFill>
-                      <a:prstDash val="solid"/>
-                    </a:lnT>
-                    <a:lnB w="12700" cap="flat" cmpd="sng" algn="ctr">
-                      <a:solidFill>
-                        <a:srgbClr val="FFFFFF"/>
-                      </a:solidFill>
-                      <a:prstDash val="solid"/>
-                    </a:lnB>
-                    <a:solidFill>
-                      <a:srgbClr val="FFFFFF"/>
-                    </a:solidFill>
-                  </a:tcPr>
-                </a:tc>
-                <a:tc>
-                  <a:txBody>
-                    <a:bodyPr wrap="square"/>
-                    <a:lstStyle/>
-                    <a:p>
-                      <a:pPr algn="ctr">
-                        <a:defRPr sz="800"/>
-                      </a:pPr>
-                      <a:r>
-                        <a:rPr b="1" sz="800">
-                          <a:solidFill>
-                            <a:srgbClr val="0F172A"/>
-                          </a:solidFill>
-                          <a:latin typeface="Aptos"/>
-                        </a:rPr>
-                        <a:t>0.0%</a:t>
-                      </a:r>
-                    </a:p>
-                  </a:txBody>
-                  <a:tcPr marL="45720" marR="45720" marT="0" marB="0" anchor="ctr">
-                    <a:lnL w="12700" cap="flat" cmpd="sng" algn="ctr">
-                      <a:solidFill>
-                        <a:srgbClr val="FFFFFF"/>
-                      </a:solidFill>
-                      <a:prstDash val="solid"/>
-                    </a:lnL>
-                    <a:lnR w="12700" cap="flat" cmpd="sng" algn="ctr">
-                      <a:solidFill>
-                        <a:srgbClr val="FFFFFF"/>
-                      </a:solidFill>
-                      <a:prstDash val="solid"/>
-                    </a:lnR>
-                    <a:lnT w="12700" cap="flat" cmpd="sng" algn="ctr">
-                      <a:solidFill>
-                        <a:srgbClr val="FFFFFF"/>
-                      </a:solidFill>
-                      <a:prstDash val="solid"/>
-                    </a:lnT>
-                    <a:lnB w="12700" cap="flat" cmpd="sng" algn="ctr">
-                      <a:solidFill>
-                        <a:srgbClr val="FFFFFF"/>
-                      </a:solidFill>
-                      <a:prstDash val="solid"/>
-                    </a:lnB>
-                    <a:solidFill>
-                      <a:srgbClr val="DDF0F8"/>
-                    </a:solidFill>
-                  </a:tcPr>
-                </a:tc>
-                <a:tc>
-                  <a:txBody>
-                    <a:bodyPr wrap="square"/>
-                    <a:lstStyle/>
-                    <a:p>
-                      <a:pPr algn="l">
-                        <a:defRPr sz="800"/>
-                      </a:pPr>
-                      <a:r>
-                        <a:rPr b="1" sz="800">
-                          <a:solidFill>
-                            <a:srgbClr val="0F172A"/>
-                          </a:solidFill>
-                          <a:latin typeface="Aptos"/>
-                        </a:rPr>
-                        <a:t> </a:t>
-                      </a:r>
-                    </a:p>
-                  </a:txBody>
-                  <a:tcPr marL="45720" marR="45720" marT="0" marB="0" anchor="ctr">
-                    <a:lnL w="12700" cap="flat" cmpd="sng" algn="ctr">
-                      <a:solidFill>
-                        <a:srgbClr val="FFFFFF"/>
-                      </a:solidFill>
-                      <a:prstDash val="solid"/>
-                    </a:lnL>
-                    <a:lnR w="12700" cap="flat" cmpd="sng" algn="ctr">
-                      <a:solidFill>
-                        <a:srgbClr val="FFFFFF"/>
-                      </a:solidFill>
-                      <a:prstDash val="solid"/>
-                    </a:lnR>
-                    <a:lnT w="12700" cap="flat" cmpd="sng" algn="ctr">
-                      <a:solidFill>
-                        <a:srgbClr val="FFFFFF"/>
-                      </a:solidFill>
-                      <a:prstDash val="solid"/>
-                    </a:lnT>
-                    <a:lnB w="12700" cap="flat" cmpd="sng" algn="ctr">
-                      <a:solidFill>
-                        <a:srgbClr val="FFFFFF"/>
-                      </a:solidFill>
-                      <a:prstDash val="solid"/>
-                    </a:lnB>
-                    <a:solidFill>
-                      <a:srgbClr val="FFFFFF"/>
-                    </a:solidFill>
-                  </a:tcPr>
-                </a:tc>
-              </a:tr>
-              <a:tr h="182880">
-                <a:tc>
-                  <a:txBody>
-                    <a:bodyPr wrap="square"/>
-                    <a:lstStyle/>
-                    <a:p>
-                      <a:pPr algn="l">
-                        <a:defRPr sz="800"/>
-                      </a:pPr>
-                      <a:r>
-                        <a:rPr b="1" sz="800">
-                          <a:solidFill>
-                            <a:srgbClr val="FFFFFF"/>
-                          </a:solidFill>
-                          <a:latin typeface="Aptos"/>
-                        </a:rPr>
-                        <a:t>NET FINANCING ACTIVITIES</a:t>
-                      </a:r>
-                    </a:p>
-                  </a:txBody>
-                  <a:tcPr marL="45720" marR="45720" marT="0" marB="0" anchor="ctr">
-                    <a:lnL w="12700" cap="flat" cmpd="sng" algn="ctr">
-                      <a:solidFill>
-                        <a:srgbClr val="FFFFFF"/>
-                      </a:solidFill>
-                      <a:prstDash val="solid"/>
-                    </a:lnL>
-                    <a:lnR w="12700" cap="flat" cmpd="sng" algn="ctr">
-                      <a:solidFill>
-                        <a:srgbClr val="FFFFFF"/>
-                      </a:solidFill>
-                      <a:prstDash val="solid"/>
-                    </a:lnR>
-                    <a:lnT w="12700" cap="flat" cmpd="sng" algn="ctr">
-                      <a:solidFill>
-                        <a:srgbClr val="FFFFFF"/>
-                      </a:solidFill>
-                      <a:prstDash val="solid"/>
-                    </a:lnT>
-                    <a:lnB w="12700" cap="flat" cmpd="sng" algn="ctr">
-                      <a:solidFill>
-                        <a:srgbClr val="FFFFFF"/>
-                      </a:solidFill>
-                      <a:prstDash val="solid"/>
-                    </a:lnB>
-                    <a:solidFill>
-                      <a:srgbClr val="081E42"/>
-                    </a:solidFill>
-                  </a:tcPr>
-                </a:tc>
-                <a:tc>
-                  <a:txBody>
-                    <a:bodyPr wrap="square"/>
-                    <a:lstStyle/>
-                    <a:p>
-                      <a:pPr algn="r">
-                        <a:defRPr sz="800"/>
-                      </a:pPr>
-                      <a:r>
-                        <a:rPr b="1" sz="800">
-                          <a:solidFill>
                             <a:srgbClr val="C00000"/>
                           </a:solidFill>
                           <a:latin typeface="Aptos"/>
                         </a:rPr>
-                        <a:t>(759,199.41)</a:t>
-                      </a:r>
-                    </a:p>
-                  </a:txBody>
-                  <a:tcPr marL="45720" marR="45720" marT="0" marB="0" anchor="ctr">
-                    <a:lnL w="12700" cap="flat" cmpd="sng" algn="ctr">
-                      <a:solidFill>
-                        <a:srgbClr val="FFFFFF"/>
-                      </a:solidFill>
-                      <a:prstDash val="solid"/>
-                    </a:lnL>
-                    <a:lnR w="12700" cap="flat" cmpd="sng" algn="ctr">
-                      <a:solidFill>
-                        <a:srgbClr val="FFFFFF"/>
-                      </a:solidFill>
-                      <a:prstDash val="solid"/>
-                    </a:lnR>
-                    <a:lnT w="12700" cap="flat" cmpd="sng" algn="ctr">
-                      <a:solidFill>
-                        <a:srgbClr val="FFFFFF"/>
-                      </a:solidFill>
-                      <a:prstDash val="solid"/>
-                    </a:lnT>
-                    <a:lnB w="12700" cap="flat" cmpd="sng" algn="ctr">
-                      <a:solidFill>
-                        <a:srgbClr val="FFFFFF"/>
-                      </a:solidFill>
-                      <a:prstDash val="solid"/>
-                    </a:lnB>
-                    <a:solidFill>
-                      <a:srgbClr val="FFC20E"/>
-                    </a:solidFill>
-                  </a:tcPr>
-                </a:tc>
-                <a:tc>
-                  <a:txBody>
-                    <a:bodyPr wrap="square"/>
-                    <a:lstStyle/>
-                    <a:p>
-                      <a:pPr algn="r">
-                        <a:defRPr sz="800"/>
-                      </a:pPr>
-                      <a:r>
-                        <a:rPr b="1" sz="800">
-                          <a:solidFill>
-                            <a:srgbClr val="0F172A"/>
-                          </a:solidFill>
-                          <a:latin typeface="Aptos"/>
-                        </a:rPr>
-                        <a:t>74,626.92</a:t>
-                      </a:r>
-                    </a:p>
-                  </a:txBody>
-                  <a:tcPr marL="45720" marR="45720" marT="0" marB="0" anchor="ctr">
-                    <a:lnL w="12700" cap="flat" cmpd="sng" algn="ctr">
-                      <a:solidFill>
-                        <a:srgbClr val="FFFFFF"/>
-                      </a:solidFill>
-                      <a:prstDash val="solid"/>
-                    </a:lnL>
-                    <a:lnR w="12700" cap="flat" cmpd="sng" algn="ctr">
-                      <a:solidFill>
-                        <a:srgbClr val="FFFFFF"/>
-                      </a:solidFill>
-                      <a:prstDash val="solid"/>
-                    </a:lnR>
-                    <a:lnT w="12700" cap="flat" cmpd="sng" algn="ctr">
-                      <a:solidFill>
-                        <a:srgbClr val="FFFFFF"/>
-                      </a:solidFill>
-                      <a:prstDash val="solid"/>
-                    </a:lnT>
-                    <a:lnB w="12700" cap="flat" cmpd="sng" algn="ctr">
-                      <a:solidFill>
-                        <a:srgbClr val="FFFFFF"/>
-                      </a:solidFill>
-                      <a:prstDash val="solid"/>
-                    </a:lnB>
-                    <a:solidFill>
-                      <a:srgbClr val="FFC20E"/>
-                    </a:solidFill>
-                  </a:tcPr>
-                </a:tc>
-                <a:tc>
-                  <a:txBody>
-                    <a:bodyPr wrap="square"/>
-                    <a:lstStyle/>
-                    <a:p>
-                      <a:pPr algn="r">
-                        <a:defRPr sz="800"/>
-                      </a:pPr>
-                      <a:r>
-                        <a:rPr b="1" sz="800">
-                          <a:solidFill>
-                            <a:srgbClr val="C00000"/>
-                          </a:solidFill>
-                          <a:latin typeface="Aptos"/>
-                        </a:rPr>
-                        <a:t>(107,801.93)</a:t>
-                      </a:r>
-                    </a:p>
-                  </a:txBody>
-                  <a:tcPr marL="45720" marR="45720" marT="0" marB="0" anchor="ctr">
-                    <a:lnL w="12700" cap="flat" cmpd="sng" algn="ctr">
-                      <a:solidFill>
-                        <a:srgbClr val="FFFFFF"/>
-                      </a:solidFill>
-                      <a:prstDash val="solid"/>
-                    </a:lnL>
-                    <a:lnR w="12700" cap="flat" cmpd="sng" algn="ctr">
-                      <a:solidFill>
-                        <a:srgbClr val="FFFFFF"/>
-                      </a:solidFill>
-                      <a:prstDash val="solid"/>
-                    </a:lnR>
-                    <a:lnT w="12700" cap="flat" cmpd="sng" algn="ctr">
-                      <a:solidFill>
-                        <a:srgbClr val="FFFFFF"/>
-                      </a:solidFill>
-                      <a:prstDash val="solid"/>
-                    </a:lnT>
-                    <a:lnB w="12700" cap="flat" cmpd="sng" algn="ctr">
-                      <a:solidFill>
-                        <a:srgbClr val="FFFFFF"/>
-                      </a:solidFill>
-                      <a:prstDash val="solid"/>
-                    </a:lnB>
-                    <a:solidFill>
-                      <a:srgbClr val="FFC20E"/>
-                    </a:solidFill>
-                  </a:tcPr>
-                </a:tc>
-                <a:tc>
-                  <a:txBody>
-                    <a:bodyPr wrap="square"/>
-                    <a:lstStyle/>
-                    <a:p>
-                      <a:pPr algn="r">
-                        <a:defRPr sz="800"/>
-                      </a:pPr>
-                      <a:r>
-                        <a:rPr b="1" sz="800">
-                          <a:solidFill>
-                            <a:srgbClr val="C00000"/>
-                          </a:solidFill>
-                          <a:latin typeface="Aptos"/>
-                        </a:rPr>
-                        <a:t>(792,374.42)</a:t>
+                        <a:t>(1,021,374.42)</a:t>
                       </a:r>
                     </a:p>
                   </a:txBody>

</xml_diff>

<commit_message>
Rebuild Q3 deck from latest Jul/Aug/Sep cash flow statements
Uses the latest revised statements for all three months: July operating
lines, investor funds (now under financing for Jul and Sep), July fixed
deposit purchase under investing, and updated related-party flows.
Remarks for investor funds and related parties use the accounts' notes.

Co-Authored-By: Claude Opus 5.5 <noreply@anthropic.com>
Claude-Session: https://claude.ai/code/session_01UekZ1BuiJW323matwahEES
</commit_message>
<xml_diff>
--- a/q3-finance-report/Q3_2026_Finance_Report.pptx
+++ b/q3-finance-report/Q3_2026_Finance_Report.pptx
@@ -3295,7 +3295,7 @@
                 </a:solidFill>
                 <a:latin typeface="Aptos"/>
               </a:rPr>
-              <a:t>Q3 operating cash was positive overall at RM2.47M, but negative in July after a RM1.03M SST payment. Net cash flow was (RM2.88M), mainly from RM3.34M new-branch capex and a RM2.00M fixed deposit placement.</a:t>
+              <a:t>Q3 operating cash was positive every month, totalling RM2.61M. Net cash flow was (RM2.88M), mainly from RM3.34M new-branch capex and RM2.29M placed in fixed deposit and investment.</a:t>
             </a:r>
           </a:p>
         </p:txBody>
@@ -3330,7 +3330,7 @@
                 </a:solidFill>
                 <a:latin typeface="Aptos"/>
               </a:rPr>
-              <a:t>Source: TGFB Cash Flow Statement PDFs for July, August and September 2026 (September revised upload). Sep RM229K investor fund reclassified from financing to investing, consistent with Jul and Q2.</a:t>
+              <a:t>Source: TGFB Cash Flow Statement PDFs for July, August and September 2026 (latest revised upload)</a:t>
             </a:r>
           </a:p>
         </p:txBody>
@@ -3625,7 +3625,7 @@
                 </a:solidFill>
                 <a:latin typeface="Aptos"/>
               </a:rPr>
-              <a:t>RM26.67M</a:t>
+              <a:t>RM26.53M</a:t>
             </a:r>
           </a:p>
         </p:txBody>
@@ -3790,7 +3790,7 @@
                 </a:solidFill>
                 <a:latin typeface="Aptos"/>
               </a:rPr>
-              <a:t>RM2.47M</a:t>
+              <a:t>RM2.61M</a:t>
             </a:r>
           </a:p>
         </p:txBody>
@@ -3825,7 +3825,7 @@
                 </a:solidFill>
                 <a:latin typeface="Aptos"/>
               </a:rPr>
-              <a:t>Negative in Jul; positive Aug-Sep</a:t>
+              <a:t>Positive across Jul-Aug-Sep</a:t>
             </a:r>
           </a:p>
         </p:txBody>
@@ -4907,7 +4907,7 @@
                           </a:solidFill>
                           <a:latin typeface="Aptos"/>
                         </a:rPr>
-                        <a:t>9,286,898.37</a:t>
+                        <a:t>9,182,345.05</a:t>
                       </a:r>
                     </a:p>
                   </a:txBody>
@@ -4956,7 +4956,7 @@
                           </a:solidFill>
                           <a:latin typeface="Aptos"/>
                         </a:rPr>
-                        <a:t>8,299,537.45</a:t>
+                        <a:t>8,279,946.95</a:t>
                       </a:r>
                     </a:p>
                   </a:txBody>
@@ -5005,7 +5005,7 @@
                           </a:solidFill>
                           <a:latin typeface="Aptos"/>
                         </a:rPr>
-                        <a:t>9,086,606.48</a:t>
+                        <a:t>9,070,707.48</a:t>
                       </a:r>
                     </a:p>
                   </a:txBody>
@@ -5054,7 +5054,7 @@
                           </a:solidFill>
                           <a:latin typeface="Aptos"/>
                         </a:rPr>
-                        <a:t>26,673,042.30</a:t>
+                        <a:t>26,532,999.48</a:t>
                       </a:r>
                     </a:p>
                   </a:txBody>
@@ -5199,11 +5199,11 @@
                       <a:r>
                         <a:rPr b="1" sz="1000">
                           <a:solidFill>
-                            <a:srgbClr val="C00000"/>
-                          </a:solidFill>
-                          <a:latin typeface="Aptos"/>
-                        </a:rPr>
-                        <a:t>(59,499.21)</a:t>
+                            <a:srgbClr val="0F172A"/>
+                          </a:solidFill>
+                          <a:latin typeface="Aptos"/>
+                        </a:rPr>
+                        <a:t>45,054.11</a:t>
                       </a:r>
                     </a:p>
                   </a:txBody>
@@ -5252,7 +5252,7 @@
                           </a:solidFill>
                           <a:latin typeface="Aptos"/>
                         </a:rPr>
-                        <a:t>1,500,013.11</a:t>
+                        <a:t>1,519,603.61</a:t>
                       </a:r>
                     </a:p>
                   </a:txBody>
@@ -5301,7 +5301,7 @@
                           </a:solidFill>
                           <a:latin typeface="Aptos"/>
                         </a:rPr>
-                        <a:t>1,033,010.69</a:t>
+                        <a:t>1,048,909.69</a:t>
                       </a:r>
                     </a:p>
                   </a:txBody>
@@ -5350,7 +5350,7 @@
                           </a:solidFill>
                           <a:latin typeface="Aptos"/>
                         </a:rPr>
-                        <a:t>2,473,524.59</a:t>
+                        <a:t>2,613,567.41</a:t>
                       </a:r>
                     </a:p>
                   </a:txBody>
@@ -5399,7 +5399,7 @@
                           </a:solidFill>
                           <a:latin typeface="Aptos"/>
                         </a:rPr>
-                        <a:t>Negative in Jul; Aug strongest at RM1.50M</a:t>
+                        <a:t>Positive every month; Aug strongest at RM1.52M</a:t>
                       </a:r>
                     </a:p>
                   </a:txBody>
@@ -5499,7 +5499,7 @@
                           </a:solidFill>
                           <a:latin typeface="Aptos"/>
                         </a:rPr>
-                        <a:t>(1,490,846.36)</a:t>
+                        <a:t>(2,497,139.36)</a:t>
                       </a:r>
                     </a:p>
                   </a:txBody>
@@ -5597,7 +5597,7 @@
                           </a:solidFill>
                           <a:latin typeface="Aptos"/>
                         </a:rPr>
-                        <a:t>(2,416,279.73)</a:t>
+                        <a:t>(2,645,279.73)</a:t>
                       </a:r>
                     </a:p>
                   </a:txBody>
@@ -5646,7 +5646,7 @@
                           </a:solidFill>
                           <a:latin typeface="Aptos"/>
                         </a:rPr>
-                        <a:t>(4,327,453.78)</a:t>
+                        <a:t>(5,562,746.78)</a:t>
                       </a:r>
                     </a:p>
                   </a:txBody>
@@ -5695,7 +5695,7 @@
                           </a:solidFill>
                           <a:latin typeface="Aptos"/>
                         </a:rPr>
-                        <a:t>Jul capex RM2.30M; Sep includes RM2.00M fixed deposit placement</a:t>
+                        <a:t>Jul capex RM2.30M; Sep RM2.00M fixed deposit placement</a:t>
                       </a:r>
                     </a:p>
                   </a:txBody>
@@ -5791,11 +5791,11 @@
                       <a:r>
                         <a:rPr b="1" sz="1000">
                           <a:solidFill>
-                            <a:srgbClr val="C00000"/>
-                          </a:solidFill>
-                          <a:latin typeface="Aptos"/>
-                        </a:rPr>
-                        <a:t>(759,199.41)</a:t>
+                            <a:srgbClr val="0F172A"/>
+                          </a:solidFill>
+                          <a:latin typeface="Aptos"/>
+                        </a:rPr>
+                        <a:t>142,540.27</a:t>
                       </a:r>
                     </a:p>
                   </a:txBody>
@@ -5844,7 +5844,7 @@
                           </a:solidFill>
                           <a:latin typeface="Aptos"/>
                         </a:rPr>
-                        <a:t>74,626.92</a:t>
+                        <a:t>55,036.42</a:t>
                       </a:r>
                     </a:p>
                   </a:txBody>
@@ -5893,7 +5893,7 @@
                           </a:solidFill>
                           <a:latin typeface="Aptos"/>
                         </a:rPr>
-                        <a:t>(336,801.93)</a:t>
+                        <a:t>(123,700.93)</a:t>
                       </a:r>
                     </a:p>
                   </a:txBody>
@@ -5938,11 +5938,11 @@
                       <a:r>
                         <a:rPr b="1" sz="1000">
                           <a:solidFill>
-                            <a:srgbClr val="C00000"/>
-                          </a:solidFill>
-                          <a:latin typeface="Aptos"/>
-                        </a:rPr>
-                        <a:t>(1,021,374.42)</a:t>
+                            <a:srgbClr val="0F172A"/>
+                          </a:solidFill>
+                          <a:latin typeface="Aptos"/>
+                        </a:rPr>
+                        <a:t>73,875.76</a:t>
                       </a:r>
                     </a:p>
                   </a:txBody>
@@ -5991,7 +5991,7 @@
                           </a:solidFill>
                           <a:latin typeface="Aptos"/>
                         </a:rPr>
-                        <a:t>Aug positive from RM230.3K repayment from related parties</a:t>
+                        <a:t>Jul includes RM720K investor funds; Sep net outflow</a:t>
                       </a:r>
                     </a:p>
                   </a:txBody>
@@ -6396,7 +6396,7 @@
                 </a:solidFill>
                 <a:latin typeface="Aptos"/>
               </a:rPr>
-              <a:t>Cash receipts grew every month from RM9.23M to RM10.12M, but SST payments in July and September (RM2.18M combined) and new-branch capex of RM3.34M pulled cash down. RM2.00M of the decline was placed in fixed deposit, not spent.</a:t>
+              <a:t>Cash receipts grew every month from RM9.23M to RM10.12M, but SST payments in July and September (RM2.18M combined) and new-branch capex of RM3.34M pulled cash down. RM2.29M went into fixed deposit and investment, not spent.</a:t>
             </a:r>
           </a:p>
         </p:txBody>
@@ -6658,7 +6658,7 @@
                 </a:solidFill>
                 <a:latin typeface="Aptos"/>
               </a:rPr>
-              <a:t>Source: TGFB Cash Flow Statement PDFs for July, August and September 2026 (September revised upload). Sep RM229K investor fund reclassified from financing to investing, consistent with Jul and Q2.</a:t>
+              <a:t>Source: TGFB Cash Flow Statement PDFs for July, August and September 2026 (latest revised upload)</a:t>
             </a:r>
           </a:p>
         </p:txBody>
@@ -9199,7 +9199,7 @@
                 </a:solidFill>
                 <a:latin typeface="Aptos"/>
               </a:rPr>
-              <a:t>Source: TGFB Cash Flow Statement PDFs for July, August and September 2026 (September revised upload). Sep RM229K investor fund reclassified from financing to investing, consistent with Jul and Q2.</a:t>
+              <a:t>Source: TGFB Cash Flow Statement PDFs for July, August and September 2026 (latest revised upload)</a:t>
             </a:r>
           </a:p>
         </p:txBody>
@@ -9901,7 +9901,7 @@
                           </a:solidFill>
                           <a:latin typeface="Aptos"/>
                         </a:rPr>
-                        <a:t>53.0%</a:t>
+                        <a:t>53.3%</a:t>
                       </a:r>
                     </a:p>
                   </a:txBody>
@@ -10740,7 +10740,7 @@
                           </a:solidFill>
                           <a:latin typeface="Aptos"/>
                         </a:rPr>
-                        <a:t>135,657.60</a:t>
+                        <a:t>139,925.45</a:t>
                       </a:r>
                     </a:p>
                   </a:txBody>
@@ -10887,7 +10887,7 @@
                           </a:solidFill>
                           <a:latin typeface="Aptos"/>
                         </a:rPr>
-                        <a:t>631,986.05</a:t>
+                        <a:t>636,253.90</a:t>
                       </a:r>
                     </a:p>
                   </a:txBody>
@@ -11085,7 +11085,7 @@
                           </a:solidFill>
                           <a:latin typeface="Aptos"/>
                         </a:rPr>
-                        <a:t>7,678.23</a:t>
+                        <a:t>10,638.63</a:t>
                       </a:r>
                     </a:p>
                   </a:txBody>
@@ -11134,7 +11134,7 @@
                           </a:solidFill>
                           <a:latin typeface="Aptos"/>
                         </a:rPr>
-                        <a:t>30,473.45</a:t>
+                        <a:t>33,472.90</a:t>
                       </a:r>
                     </a:p>
                   </a:txBody>
@@ -11232,7 +11232,7 @@
                           </a:solidFill>
                           <a:latin typeface="Aptos"/>
                         </a:rPr>
-                        <a:t>45,097.53</a:t>
+                        <a:t>51,057.38</a:t>
                       </a:r>
                     </a:p>
                   </a:txBody>
@@ -11775,7 +11775,7 @@
                           </a:solidFill>
                           <a:latin typeface="Aptos"/>
                         </a:rPr>
-                        <a:t>1,825,325.86</a:t>
+                        <a:t>1,715,948.15</a:t>
                       </a:r>
                     </a:p>
                   </a:txBody>
@@ -11824,7 +11824,7 @@
                           </a:solidFill>
                           <a:latin typeface="Aptos"/>
                         </a:rPr>
-                        <a:t>1,785,806.92</a:t>
+                        <a:t>1,766,216.42</a:t>
                       </a:r>
                     </a:p>
                   </a:txBody>
@@ -11873,7 +11873,7 @@
                           </a:solidFill>
                           <a:latin typeface="Aptos"/>
                         </a:rPr>
-                        <a:t>1,776,058.92</a:t>
+                        <a:t>1,760,159.92</a:t>
                       </a:r>
                     </a:p>
                   </a:txBody>
@@ -11922,7 +11922,7 @@
                           </a:solidFill>
                           <a:latin typeface="Aptos"/>
                         </a:rPr>
-                        <a:t>5,387,191.70</a:t>
+                        <a:t>5,242,324.49</a:t>
                       </a:r>
                     </a:p>
                   </a:txBody>
@@ -11971,7 +11971,7 @@
                           </a:solidFill>
                           <a:latin typeface="Aptos"/>
                         </a:rPr>
-                        <a:t>20.2%</a:t>
+                        <a:t>19.8%</a:t>
                       </a:r>
                     </a:p>
                   </a:txBody>
@@ -12020,7 +12020,7 @@
                           </a:solidFill>
                           <a:latin typeface="Aptos"/>
                         </a:rPr>
-                        <a:t>Stable at RM1.78M-RM1.83M monthly</a:t>
+                        <a:t>Stable at RM1.72M-RM1.77M monthly</a:t>
                       </a:r>
                     </a:p>
                   </a:txBody>
@@ -12810,7 +12810,7 @@
                           </a:solidFill>
                           <a:latin typeface="Aptos"/>
                         </a:rPr>
-                        <a:t>122,119.51</a:t>
+                        <a:t>119,159.11</a:t>
                       </a:r>
                     </a:p>
                   </a:txBody>
@@ -12859,7 +12859,7 @@
                           </a:solidFill>
                           <a:latin typeface="Aptos"/>
                         </a:rPr>
-                        <a:t>52,573.09</a:t>
+                        <a:t>49,573.64</a:t>
                       </a:r>
                     </a:p>
                   </a:txBody>
@@ -12957,7 +12957,7 @@
                           </a:solidFill>
                           <a:latin typeface="Aptos"/>
                         </a:rPr>
-                        <a:t>189,920.60</a:t>
+                        <a:t>183,960.75</a:t>
                       </a:r>
                     </a:p>
                   </a:txBody>
@@ -13155,7 +13155,7 @@
                           </a:solidFill>
                           <a:latin typeface="Aptos"/>
                         </a:rPr>
-                        <a:t>148,830.60</a:t>
+                        <a:t>148,787.27</a:t>
                       </a:r>
                     </a:p>
                   </a:txBody>
@@ -13302,7 +13302,7 @@
                           </a:solidFill>
                           <a:latin typeface="Aptos"/>
                         </a:rPr>
-                        <a:t>458,368.55</a:t>
+                        <a:t>458,325.22</a:t>
                       </a:r>
                     </a:p>
                   </a:txBody>
@@ -14880,7 +14880,7 @@
                           </a:solidFill>
                           <a:latin typeface="Aptos"/>
                         </a:rPr>
-                        <a:t>1,900.13</a:t>
+                        <a:t>2,500.00</a:t>
                       </a:r>
                     </a:p>
                   </a:txBody>
@@ -15027,7 +15027,7 @@
                           </a:solidFill>
                           <a:latin typeface="Aptos"/>
                         </a:rPr>
-                        <a:t>1,900.13</a:t>
+                        <a:t>2,500.00</a:t>
                       </a:r>
                     </a:p>
                   </a:txBody>
@@ -15570,7 +15570,7 @@
                           </a:solidFill>
                           <a:latin typeface="Aptos"/>
                         </a:rPr>
-                        <a:t>9,286,898.37</a:t>
+                        <a:t>9,182,345.05</a:t>
                       </a:r>
                     </a:p>
                   </a:txBody>
@@ -15619,7 +15619,7 @@
                           </a:solidFill>
                           <a:latin typeface="Aptos"/>
                         </a:rPr>
-                        <a:t>8,299,537.45</a:t>
+                        <a:t>8,279,946.95</a:t>
                       </a:r>
                     </a:p>
                   </a:txBody>
@@ -15668,7 +15668,7 @@
                           </a:solidFill>
                           <a:latin typeface="Aptos"/>
                         </a:rPr>
-                        <a:t>9,086,606.48</a:t>
+                        <a:t>9,070,707.48</a:t>
                       </a:r>
                     </a:p>
                   </a:txBody>
@@ -15717,7 +15717,7 @@
                           </a:solidFill>
                           <a:latin typeface="Aptos"/>
                         </a:rPr>
-                        <a:t>26,673,042.30</a:t>
+                        <a:t>26,532,999.48</a:t>
                       </a:r>
                     </a:p>
                   </a:txBody>
@@ -15924,7 +15924,7 @@
                 </a:solidFill>
                 <a:latin typeface="Aptos"/>
               </a:rPr>
-              <a:t>TOP OUTFLOW CATEGORIES: Inventory purchases RM14.14M | Wage expenses RM5.39M | SST RM2.18M | Rental RM1.31M | Income taxes RM0.75M</a:t>
+              <a:t>TOP OUTFLOW CATEGORIES: Inventory purchases RM14.14M | Wage expenses RM5.24M | SST RM2.18M | Rental RM1.31M | Income taxes RM0.75M</a:t>
             </a:r>
           </a:p>
         </p:txBody>
@@ -16151,7 +16151,7 @@
                 </a:solidFill>
                 <a:latin typeface="Aptos"/>
               </a:rPr>
-              <a:t>New-branch capex (RM3.34M) and a RM2.00M fixed deposit placement in September drove investing outflows. Financing was positive only in August, from related-party repayments.</a:t>
+              <a:t>New-branch capex (RM3.34M) and RM2.29M placed in fixed deposits drove investing outflows. Financing was positive in Jul-Aug, helped by RM949K investor funds.</a:t>
             </a:r>
           </a:p>
         </p:txBody>
@@ -16186,7 +16186,7 @@
                 </a:solidFill>
                 <a:latin typeface="Aptos"/>
               </a:rPr>
-              <a:t>Source: TGFB Cash Flow Statement PDFs for July, August and September 2026 (September revised upload). Sep RM229K investor fund reclassified from financing to investing, consistent with Jul and Q2.</a:t>
+              <a:t>Source: TGFB Cash Flow Statement PDFs for July, August and September 2026 (latest revised upload)</a:t>
             </a:r>
           </a:p>
         </p:txBody>
@@ -16274,13 +16274,13 @@
                 <a:tableStyleId>{2D5ABB26-0587-4C30-8999-92F81FD0307C}</a:tableStyleId>
               </a:tblPr>
               <a:tblGrid>
-                <a:gridCol w="2743200"/>
-                <a:gridCol w="1234440"/>
-                <a:gridCol w="1234440"/>
-                <a:gridCol w="1234440"/>
-                <a:gridCol w="1325880"/>
+                <a:gridCol w="2331720"/>
+                <a:gridCol w="1188720"/>
+                <a:gridCol w="1188720"/>
+                <a:gridCol w="1188720"/>
+                <a:gridCol w="1280160"/>
                 <a:gridCol w="685800"/>
-                <a:gridCol w="3218688"/>
+                <a:gridCol w="3813048"/>
               </a:tblGrid>
               <a:tr h="274320">
                 <a:tc>
@@ -16888,7 +16888,7 @@
                           </a:solidFill>
                           <a:latin typeface="Aptos"/>
                         </a:rPr>
-                        <a:t>2.9%</a:t>
+                        <a:t>3.2%</a:t>
                       </a:r>
                     </a:p>
                   </a:txBody>
@@ -17233,7 +17233,7 @@
                           </a:solidFill>
                           <a:latin typeface="Aptos"/>
                         </a:rPr>
-                        <a:t>0.1%</a:t>
+                        <a:t>0.2%</a:t>
                       </a:r>
                     </a:p>
                   </a:txBody>
@@ -17333,7 +17333,7 @@
                           </a:solidFill>
                           <a:latin typeface="Aptos"/>
                         </a:rPr>
-                        <a:t>Collection of Investor funds</a:t>
+                        <a:t>Purchase of property and equipment</a:t>
                       </a:r>
                     </a:p>
                   </a:txBody>
@@ -17378,11 +17378,11 @@
                       <a:r>
                         <a:rPr b="1" sz="950">
                           <a:solidFill>
-                            <a:srgbClr val="0F172A"/>
-                          </a:solidFill>
-                          <a:latin typeface="Aptos"/>
-                        </a:rPr>
-                        <a:t>720,000.00</a:t>
+                            <a:srgbClr val="C00000"/>
+                          </a:solidFill>
+                          <a:latin typeface="Aptos"/>
+                        </a:rPr>
+                        <a:t>(100,223.00)</a:t>
                       </a:r>
                     </a:p>
                   </a:txBody>
@@ -17427,11 +17427,11 @@
                       <a:r>
                         <a:rPr b="1" sz="950">
                           <a:solidFill>
-                            <a:srgbClr val="0F172A"/>
-                          </a:solidFill>
-                          <a:latin typeface="Aptos"/>
-                        </a:rPr>
-                        <a:t>0.00</a:t>
+                            <a:srgbClr val="C00000"/>
+                          </a:solidFill>
+                          <a:latin typeface="Aptos"/>
+                        </a:rPr>
+                        <a:t>(17,369.00)</a:t>
                       </a:r>
                     </a:p>
                   </a:txBody>
@@ -17476,11 +17476,11 @@
                       <a:r>
                         <a:rPr b="1" sz="950">
                           <a:solidFill>
-                            <a:srgbClr val="0F172A"/>
-                          </a:solidFill>
-                          <a:latin typeface="Aptos"/>
-                        </a:rPr>
-                        <a:t>229,000.00</a:t>
+                            <a:srgbClr val="C00000"/>
+                          </a:solidFill>
+                          <a:latin typeface="Aptos"/>
+                        </a:rPr>
+                        <a:t>(14,400.00)</a:t>
                       </a:r>
                     </a:p>
                   </a:txBody>
@@ -17525,11 +17525,11 @@
                       <a:r>
                         <a:rPr b="1" sz="950">
                           <a:solidFill>
-                            <a:srgbClr val="0F172A"/>
-                          </a:solidFill>
-                          <a:latin typeface="Aptos"/>
-                        </a:rPr>
-                        <a:t>949,000.00</a:t>
+                            <a:srgbClr val="C00000"/>
+                          </a:solidFill>
+                          <a:latin typeface="Aptos"/>
+                        </a:rPr>
+                        <a:t>(131,992.00)</a:t>
                       </a:r>
                     </a:p>
                   </a:txBody>
@@ -17578,7 +17578,7 @@
                           </a:solidFill>
                           <a:latin typeface="Aptos"/>
                         </a:rPr>
-                        <a:t>14.3%</a:t>
+                        <a:t>2.2%</a:t>
                       </a:r>
                     </a:p>
                   </a:txBody>
@@ -17627,7 +17627,7 @@
                           </a:solidFill>
                           <a:latin typeface="Aptos"/>
                         </a:rPr>
-                        <a:t>Investor fund; Sep reclassified from financing</a:t>
+                        <a:t>Jul truck &amp; phone; reduced every month</a:t>
                       </a:r>
                     </a:p>
                   </a:txBody>
@@ -17678,7 +17678,7 @@
                           </a:solidFill>
                           <a:latin typeface="Aptos"/>
                         </a:rPr>
-                        <a:t>Purchase of property and equipment</a:t>
+                        <a:t>Capex New Branches</a:t>
                       </a:r>
                     </a:p>
                   </a:txBody>
@@ -17727,7 +17727,7 @@
                           </a:solidFill>
                           <a:latin typeface="Aptos"/>
                         </a:rPr>
-                        <a:t>(100,223.00)</a:t>
+                        <a:t>(2,300,748.36)</a:t>
                       </a:r>
                     </a:p>
                   </a:txBody>
@@ -17776,7 +17776,7 @@
                           </a:solidFill>
                           <a:latin typeface="Aptos"/>
                         </a:rPr>
-                        <a:t>(17,369.00)</a:t>
+                        <a:t>(402,958.69)</a:t>
                       </a:r>
                     </a:p>
                   </a:txBody>
@@ -17825,7 +17825,7 @@
                           </a:solidFill>
                           <a:latin typeface="Aptos"/>
                         </a:rPr>
-                        <a:t>(14,400.00)</a:t>
+                        <a:t>(639,849.95)</a:t>
                       </a:r>
                     </a:p>
                   </a:txBody>
@@ -17874,7 +17874,7 @@
                           </a:solidFill>
                           <a:latin typeface="Aptos"/>
                         </a:rPr>
-                        <a:t>(131,992.00)</a:t>
+                        <a:t>(3,343,557.00)</a:t>
                       </a:r>
                     </a:p>
                   </a:txBody>
@@ -17923,7 +17923,7 @@
                           </a:solidFill>
                           <a:latin typeface="Aptos"/>
                         </a:rPr>
-                        <a:t>2.0%</a:t>
+                        <a:t>56.1%</a:t>
                       </a:r>
                     </a:p>
                   </a:txBody>
@@ -17972,7 +17972,7 @@
                           </a:solidFill>
                           <a:latin typeface="Aptos"/>
                         </a:rPr>
-                        <a:t>Reduced every month</a:t>
+                        <a:t>For outlet expansion; Jul-26 highest</a:t>
                       </a:r>
                     </a:p>
                   </a:txBody>
@@ -18023,7 +18023,7 @@
                           </a:solidFill>
                           <a:latin typeface="Aptos"/>
                         </a:rPr>
-                        <a:t>Capex New Branches</a:t>
+                        <a:t>Placement of Fixed Deposit</a:t>
                       </a:r>
                     </a:p>
                   </a:txBody>
@@ -18068,11 +18068,11 @@
                       <a:r>
                         <a:rPr b="1" sz="950">
                           <a:solidFill>
-                            <a:srgbClr val="C00000"/>
-                          </a:solidFill>
-                          <a:latin typeface="Aptos"/>
-                        </a:rPr>
-                        <a:t>(2,300,748.36)</a:t>
+                            <a:srgbClr val="0F172A"/>
+                          </a:solidFill>
+                          <a:latin typeface="Aptos"/>
+                        </a:rPr>
+                        <a:t>0.00</a:t>
                       </a:r>
                     </a:p>
                   </a:txBody>
@@ -18117,11 +18117,11 @@
                       <a:r>
                         <a:rPr b="1" sz="950">
                           <a:solidFill>
-                            <a:srgbClr val="C00000"/>
-                          </a:solidFill>
-                          <a:latin typeface="Aptos"/>
-                        </a:rPr>
-                        <a:t>(402,958.69)</a:t>
+                            <a:srgbClr val="0F172A"/>
+                          </a:solidFill>
+                          <a:latin typeface="Aptos"/>
+                        </a:rPr>
+                        <a:t>0.00</a:t>
                       </a:r>
                     </a:p>
                   </a:txBody>
@@ -18170,7 +18170,7 @@
                           </a:solidFill>
                           <a:latin typeface="Aptos"/>
                         </a:rPr>
-                        <a:t>(639,849.95)</a:t>
+                        <a:t>(2,000,000.00)</a:t>
                       </a:r>
                     </a:p>
                   </a:txBody>
@@ -18219,7 +18219,7 @@
                           </a:solidFill>
                           <a:latin typeface="Aptos"/>
                         </a:rPr>
-                        <a:t>(3,343,557.00)</a:t>
+                        <a:t>(2,000,000.00)</a:t>
                       </a:r>
                     </a:p>
                   </a:txBody>
@@ -18268,7 +18268,7 @@
                           </a:solidFill>
                           <a:latin typeface="Aptos"/>
                         </a:rPr>
-                        <a:t>50.5%</a:t>
+                        <a:t>33.6%</a:t>
                       </a:r>
                     </a:p>
                   </a:txBody>
@@ -18317,7 +18317,7 @@
                           </a:solidFill>
                           <a:latin typeface="Aptos"/>
                         </a:rPr>
-                        <a:t>For outlet expansion; Jul-26 highest</a:t>
+                        <a:t>RM2.0M placed in fixed deposit in Sep</a:t>
                       </a:r>
                     </a:p>
                   </a:txBody>
@@ -18368,7 +18368,7 @@
                           </a:solidFill>
                           <a:latin typeface="Aptos"/>
                         </a:rPr>
-                        <a:t>Placement of Fixed Deposit</a:t>
+                        <a:t>Purchase of investment</a:t>
                       </a:r>
                     </a:p>
                   </a:txBody>
@@ -18413,11 +18413,11 @@
                       <a:r>
                         <a:rPr b="1" sz="950">
                           <a:solidFill>
-                            <a:srgbClr val="0F172A"/>
-                          </a:solidFill>
-                          <a:latin typeface="Aptos"/>
-                        </a:rPr>
-                        <a:t>0.00</a:t>
+                            <a:srgbClr val="C00000"/>
+                          </a:solidFill>
+                          <a:latin typeface="Aptos"/>
+                        </a:rPr>
+                        <a:t>(286,293.00)</a:t>
                       </a:r>
                     </a:p>
                   </a:txBody>
@@ -18511,11 +18511,11 @@
                       <a:r>
                         <a:rPr b="1" sz="950">
                           <a:solidFill>
-                            <a:srgbClr val="C00000"/>
-                          </a:solidFill>
-                          <a:latin typeface="Aptos"/>
-                        </a:rPr>
-                        <a:t>(2,000,000.00)</a:t>
+                            <a:srgbClr val="0F172A"/>
+                          </a:solidFill>
+                          <a:latin typeface="Aptos"/>
+                        </a:rPr>
+                        <a:t>0.00</a:t>
                       </a:r>
                     </a:p>
                   </a:txBody>
@@ -18564,7 +18564,7 @@
                           </a:solidFill>
                           <a:latin typeface="Aptos"/>
                         </a:rPr>
-                        <a:t>(2,000,000.00)</a:t>
+                        <a:t>(286,293.00)</a:t>
                       </a:r>
                     </a:p>
                   </a:txBody>
@@ -18613,7 +18613,7 @@
                           </a:solidFill>
                           <a:latin typeface="Aptos"/>
                         </a:rPr>
-                        <a:t>30.2%</a:t>
+                        <a:t>4.8%</a:t>
                       </a:r>
                     </a:p>
                   </a:txBody>
@@ -18662,7 +18662,7 @@
                           </a:solidFill>
                           <a:latin typeface="Aptos"/>
                         </a:rPr>
-                        <a:t>RM2.0M placed in fixed deposit in Sep</a:t>
+                        <a:t>Jul fixed deposit (per accounts remark)</a:t>
                       </a:r>
                     </a:p>
                   </a:txBody>
@@ -18762,7 +18762,7 @@
                           </a:solidFill>
                           <a:latin typeface="Aptos"/>
                         </a:rPr>
-                        <a:t>(1,490,846.36)</a:t>
+                        <a:t>(2,497,139.36)</a:t>
                       </a:r>
                     </a:p>
                   </a:txBody>
@@ -18860,7 +18860,7 @@
                           </a:solidFill>
                           <a:latin typeface="Aptos"/>
                         </a:rPr>
-                        <a:t>(2,416,279.73)</a:t>
+                        <a:t>(2,645,279.73)</a:t>
                       </a:r>
                     </a:p>
                   </a:txBody>
@@ -18909,7 +18909,7 @@
                           </a:solidFill>
                           <a:latin typeface="Aptos"/>
                         </a:rPr>
-                        <a:t>(4,327,453.78)</a:t>
+                        <a:t>(5,562,746.78)</a:t>
                       </a:r>
                     </a:p>
                   </a:txBody>
@@ -19129,13 +19129,13 @@
                 <a:tableStyleId>{2D5ABB26-0587-4C30-8999-92F81FD0307C}</a:tableStyleId>
               </a:tblPr>
               <a:tblGrid>
-                <a:gridCol w="2743200"/>
-                <a:gridCol w="1234440"/>
-                <a:gridCol w="1234440"/>
-                <a:gridCol w="1234440"/>
-                <a:gridCol w="1325880"/>
+                <a:gridCol w="2331720"/>
+                <a:gridCol w="1188720"/>
+                <a:gridCol w="1188720"/>
+                <a:gridCol w="1188720"/>
+                <a:gridCol w="1280160"/>
                 <a:gridCol w="685800"/>
-                <a:gridCol w="3218688"/>
+                <a:gridCol w="3813048"/>
               </a:tblGrid>
               <a:tr h="274320">
                 <a:tc>
@@ -19498,7 +19498,7 @@
                           </a:solidFill>
                           <a:latin typeface="Aptos"/>
                         </a:rPr>
-                        <a:t>Repayment from related parties</a:t>
+                        <a:t>Collection of Investor funds</a:t>
                       </a:r>
                     </a:p>
                   </a:txBody>
@@ -19543,11 +19543,11 @@
                       <a:r>
                         <a:rPr b="1" sz="950">
                           <a:solidFill>
-                            <a:srgbClr val="C00000"/>
-                          </a:solidFill>
-                          <a:latin typeface="Aptos"/>
-                        </a:rPr>
-                        <a:t>(79,760.50)</a:t>
+                            <a:srgbClr val="0F172A"/>
+                          </a:solidFill>
+                          <a:latin typeface="Aptos"/>
+                        </a:rPr>
+                        <a:t>720,000.00</a:t>
                       </a:r>
                     </a:p>
                   </a:txBody>
@@ -19596,7 +19596,7 @@
                           </a:solidFill>
                           <a:latin typeface="Aptos"/>
                         </a:rPr>
-                        <a:t>230,281.85</a:t>
+                        <a:t>0.00</a:t>
                       </a:r>
                     </a:p>
                   </a:txBody>
@@ -19645,7 +19645,7 @@
                           </a:solidFill>
                           <a:latin typeface="Aptos"/>
                         </a:rPr>
-                        <a:t>15,899.00</a:t>
+                        <a:t>229,000.00</a:t>
                       </a:r>
                     </a:p>
                   </a:txBody>
@@ -19694,7 +19694,7 @@
                           </a:solidFill>
                           <a:latin typeface="Aptos"/>
                         </a:rPr>
-                        <a:t>166,420.35</a:t>
+                        <a:t>949,000.00</a:t>
                       </a:r>
                     </a:p>
                   </a:txBody>
@@ -19743,7 +19743,7 @@
                           </a:solidFill>
                           <a:latin typeface="Aptos"/>
                         </a:rPr>
-                        <a:t>21.5%</a:t>
+                        <a:t>42.0%</a:t>
                       </a:r>
                     </a:p>
                   </a:txBody>
@@ -19792,7 +19792,7 @@
                           </a:solidFill>
                           <a:latin typeface="Aptos"/>
                         </a:rPr>
-                        <a:t>Net outflow in Jul; RM230.3K received in Aug</a:t>
+                        <a:t>Jul: Dungun 120K, Pekan 600K; Sep: Imam Khairi 169K, PG 60K</a:t>
                       </a:r>
                     </a:p>
                   </a:txBody>
@@ -19843,7 +19843,7 @@
                           </a:solidFill>
                           <a:latin typeface="Aptos"/>
                         </a:rPr>
-                        <a:t>Purchase of investment</a:t>
+                        <a:t>Repayment from related parties</a:t>
                       </a:r>
                     </a:p>
                   </a:txBody>
@@ -19888,11 +19888,11 @@
                       <a:r>
                         <a:rPr b="1" sz="950">
                           <a:solidFill>
-                            <a:srgbClr val="C00000"/>
-                          </a:solidFill>
-                          <a:latin typeface="Aptos"/>
-                        </a:rPr>
-                        <a:t>(286,293.00)</a:t>
+                            <a:srgbClr val="0F172A"/>
+                          </a:solidFill>
+                          <a:latin typeface="Aptos"/>
+                        </a:rPr>
+                        <a:t>0.00</a:t>
                       </a:r>
                     </a:p>
                   </a:txBody>
@@ -19941,7 +19941,7 @@
                           </a:solidFill>
                           <a:latin typeface="Aptos"/>
                         </a:rPr>
-                        <a:t>0.00</a:t>
+                        <a:t>210,691.35</a:t>
                       </a:r>
                     </a:p>
                   </a:txBody>
@@ -19990,7 +19990,7 @@
                           </a:solidFill>
                           <a:latin typeface="Aptos"/>
                         </a:rPr>
-                        <a:t>0.00</a:t>
+                        <a:t>8,189.42</a:t>
                       </a:r>
                     </a:p>
                   </a:txBody>
@@ -20035,11 +20035,11 @@
                       <a:r>
                         <a:rPr b="1" sz="950">
                           <a:solidFill>
-                            <a:srgbClr val="C00000"/>
-                          </a:solidFill>
-                          <a:latin typeface="Aptos"/>
-                        </a:rPr>
-                        <a:t>(286,293.00)</a:t>
+                            <a:srgbClr val="0F172A"/>
+                          </a:solidFill>
+                          <a:latin typeface="Aptos"/>
+                        </a:rPr>
+                        <a:t>218,880.77</a:t>
                       </a:r>
                     </a:p>
                   </a:txBody>
@@ -20088,7 +20088,7 @@
                           </a:solidFill>
                           <a:latin typeface="Aptos"/>
                         </a:rPr>
-                        <a:t>18.9%</a:t>
+                        <a:t>9.7%</a:t>
                       </a:r>
                     </a:p>
                   </a:txBody>
@@ -20137,7 +20137,7 @@
                           </a:solidFill>
                           <a:latin typeface="Aptos"/>
                         </a:rPr>
-                        <a:t>Jul only (recorded under financing)</a:t>
+                        <a:t>Aug mainly Authentic RM210.6K; Sep TGCK RM8.2K</a:t>
                       </a:r>
                     </a:p>
                   </a:txBody>
@@ -20433,7 +20433,7 @@
                           </a:solidFill>
                           <a:latin typeface="Aptos"/>
                         </a:rPr>
-                        <a:t>31.4%</a:t>
+                        <a:t>21.0%</a:t>
                       </a:r>
                     </a:p>
                   </a:txBody>
@@ -20582,7 +20582,7 @@
                           </a:solidFill>
                           <a:latin typeface="Aptos"/>
                         </a:rPr>
-                        <a:t>(233,400.76)</a:t>
+                        <a:t>(417,714.58)</a:t>
                       </a:r>
                     </a:p>
                   </a:txBody>
@@ -20680,7 +20680,7 @@
                           </a:solidFill>
                           <a:latin typeface="Aptos"/>
                         </a:rPr>
-                        <a:t>(192,813.64)</a:t>
+                        <a:t>(201,003.06)</a:t>
                       </a:r>
                     </a:p>
                   </a:txBody>
@@ -20729,7 +20729,7 @@
                           </a:solidFill>
                           <a:latin typeface="Aptos"/>
                         </a:rPr>
-                        <a:t>(426,632.33)</a:t>
+                        <a:t>(619,135.57)</a:t>
                       </a:r>
                     </a:p>
                   </a:txBody>
@@ -20778,7 +20778,7 @@
                           </a:solidFill>
                           <a:latin typeface="Aptos"/>
                         </a:rPr>
-                        <a:t>28.2%</a:t>
+                        <a:t>27.4%</a:t>
                       </a:r>
                     </a:p>
                   </a:txBody>
@@ -20827,7 +20827,7 @@
                           </a:solidFill>
                           <a:latin typeface="Aptos"/>
                         </a:rPr>
-                        <a:t>Jul-26 highest; Aug-26 minimal</a:t>
+                        <a:t>Jul: Bebeks 193.7K, Authentic 168.6K; Sep: Rindu Rasa 188.6K</a:t>
                       </a:r>
                     </a:p>
                   </a:txBody>
@@ -20923,11 +20923,11 @@
                       <a:r>
                         <a:rPr b="1" sz="950">
                           <a:solidFill>
-                            <a:srgbClr val="C00000"/>
-                          </a:solidFill>
-                          <a:latin typeface="Aptos"/>
-                        </a:rPr>
-                        <a:t>(759,199.41)</a:t>
+                            <a:srgbClr val="0F172A"/>
+                          </a:solidFill>
+                          <a:latin typeface="Aptos"/>
+                        </a:rPr>
+                        <a:t>142,540.27</a:t>
                       </a:r>
                     </a:p>
                   </a:txBody>
@@ -20976,7 +20976,7 @@
                           </a:solidFill>
                           <a:latin typeface="Aptos"/>
                         </a:rPr>
-                        <a:t>74,626.92</a:t>
+                        <a:t>55,036.42</a:t>
                       </a:r>
                     </a:p>
                   </a:txBody>
@@ -21025,7 +21025,7 @@
                           </a:solidFill>
                           <a:latin typeface="Aptos"/>
                         </a:rPr>
-                        <a:t>(336,801.93)</a:t>
+                        <a:t>(123,700.93)</a:t>
                       </a:r>
                     </a:p>
                   </a:txBody>
@@ -21070,11 +21070,11 @@
                       <a:r>
                         <a:rPr b="1" sz="950">
                           <a:solidFill>
-                            <a:srgbClr val="C00000"/>
-                          </a:solidFill>
-                          <a:latin typeface="Aptos"/>
-                        </a:rPr>
-                        <a:t>(1,021,374.42)</a:t>
+                            <a:srgbClr val="0F172A"/>
+                          </a:solidFill>
+                          <a:latin typeface="Aptos"/>
+                        </a:rPr>
+                        <a:t>73,875.76</a:t>
                       </a:r>
                     </a:p>
                   </a:txBody>
@@ -21172,7 +21172,7 @@
                           </a:solidFill>
                           <a:latin typeface="Aptos"/>
                         </a:rPr>
-                        <a:t>Aug-26 positive; Jul-26 lowest</a:t>
+                        <a:t>Positive Jul-Aug; Sep-26 net outflow</a:t>
                       </a:r>
                     </a:p>
                   </a:txBody>

</xml_diff>

<commit_message>
Show September interest received under financing in Q3 deck
Moves RM8,970.22 Maybank pooled interest from investing to financing
as requested; the statement still shows it under investing, so the
slide source line notes the difference. Net cash flow is unchanged.

Co-Authored-By: Claude Opus 5.5 <noreply@anthropic.com>
Claude-Session: https://claude.ai/code/session_01UekZ1BuiJW323matwahEES
</commit_message>
<xml_diff>
--- a/q3-finance-report/Q3_2026_Finance_Report.pptx
+++ b/q3-finance-report/Q3_2026_Finance_Report.pptx
@@ -3330,7 +3330,7 @@
                 </a:solidFill>
                 <a:latin typeface="Aptos"/>
               </a:rPr>
-              <a:t>Source: TGFB Cash Flow Statement PDFs for July, August and September 2026 (latest revised upload)</a:t>
+              <a:t>Source: TGFB Cash Flow Statement PDFs for July, August and September 2026 (latest revised upload). Sep interest received (RM8,970.22) shown under financing; statement shows it under investing.</a:t>
             </a:r>
           </a:p>
         </p:txBody>
@@ -5597,7 +5597,7 @@
                           </a:solidFill>
                           <a:latin typeface="Aptos"/>
                         </a:rPr>
-                        <a:t>(2,645,279.73)</a:t>
+                        <a:t>(2,654,249.95)</a:t>
                       </a:r>
                     </a:p>
                   </a:txBody>
@@ -5646,7 +5646,7 @@
                           </a:solidFill>
                           <a:latin typeface="Aptos"/>
                         </a:rPr>
-                        <a:t>(5,562,746.78)</a:t>
+                        <a:t>(5,571,717.00)</a:t>
                       </a:r>
                     </a:p>
                   </a:txBody>
@@ -5893,7 +5893,7 @@
                           </a:solidFill>
                           <a:latin typeface="Aptos"/>
                         </a:rPr>
-                        <a:t>(123,700.93)</a:t>
+                        <a:t>(114,730.71)</a:t>
                       </a:r>
                     </a:p>
                   </a:txBody>
@@ -5942,7 +5942,7 @@
                           </a:solidFill>
                           <a:latin typeface="Aptos"/>
                         </a:rPr>
-                        <a:t>73,875.76</a:t>
+                        <a:t>82,845.98</a:t>
                       </a:r>
                     </a:p>
                   </a:txBody>
@@ -6658,7 +6658,7 @@
                 </a:solidFill>
                 <a:latin typeface="Aptos"/>
               </a:rPr>
-              <a:t>Source: TGFB Cash Flow Statement PDFs for July, August and September 2026 (latest revised upload)</a:t>
+              <a:t>Source: TGFB Cash Flow Statement PDFs for July, August and September 2026 (latest revised upload). Sep interest received (RM8,970.22) shown under financing; statement shows it under investing.</a:t>
             </a:r>
           </a:p>
         </p:txBody>
@@ -9199,7 +9199,7 @@
                 </a:solidFill>
                 <a:latin typeface="Aptos"/>
               </a:rPr>
-              <a:t>Source: TGFB Cash Flow Statement PDFs for July, August and September 2026 (latest revised upload)</a:t>
+              <a:t>Source: TGFB Cash Flow Statement PDFs for July, August and September 2026 (latest revised upload). Sep interest received (RM8,970.22) shown under financing; statement shows it under investing.</a:t>
             </a:r>
           </a:p>
         </p:txBody>
@@ -16186,7 +16186,7 @@
                 </a:solidFill>
                 <a:latin typeface="Aptos"/>
               </a:rPr>
-              <a:t>Source: TGFB Cash Flow Statement PDFs for July, August and September 2026 (latest revised upload)</a:t>
+              <a:t>Source: TGFB Cash Flow Statement PDFs for July, August and September 2026 (latest revised upload). Sep interest received (RM8,970.22) shown under financing; statement shows it under investing.</a:t>
             </a:r>
           </a:p>
         </p:txBody>
@@ -16265,7 +16265,7 @@
         </p:nvGraphicFramePr>
         <p:xfrm>
           <a:off x="256032" y="1609344"/>
-          <a:ext cx="11676888" cy="2194560"/>
+          <a:ext cx="11676888" cy="1920240"/>
         </p:xfrm>
         <a:graphic>
           <a:graphicData uri="http://schemas.openxmlformats.org/drawingml/2006/table">
@@ -16988,7 +16988,7 @@
                           </a:solidFill>
                           <a:latin typeface="Aptos"/>
                         </a:rPr>
-                        <a:t>Interest received (Maybank pooled)</a:t>
+                        <a:t>Purchase of property and equipment</a:t>
                       </a:r>
                     </a:p>
                   </a:txBody>
@@ -17033,11 +17033,11 @@
                       <a:r>
                         <a:rPr b="1" sz="950">
                           <a:solidFill>
-                            <a:srgbClr val="0F172A"/>
-                          </a:solidFill>
-                          <a:latin typeface="Aptos"/>
-                        </a:rPr>
-                        <a:t>0.00</a:t>
+                            <a:srgbClr val="C00000"/>
+                          </a:solidFill>
+                          <a:latin typeface="Aptos"/>
+                        </a:rPr>
+                        <a:t>(100,223.00)</a:t>
                       </a:r>
                     </a:p>
                   </a:txBody>
@@ -17082,11 +17082,11 @@
                       <a:r>
                         <a:rPr b="1" sz="950">
                           <a:solidFill>
-                            <a:srgbClr val="0F172A"/>
-                          </a:solidFill>
-                          <a:latin typeface="Aptos"/>
-                        </a:rPr>
-                        <a:t>0.00</a:t>
+                            <a:srgbClr val="C00000"/>
+                          </a:solidFill>
+                          <a:latin typeface="Aptos"/>
+                        </a:rPr>
+                        <a:t>(17,369.00)</a:t>
                       </a:r>
                     </a:p>
                   </a:txBody>
@@ -17131,11 +17131,11 @@
                       <a:r>
                         <a:rPr b="1" sz="950">
                           <a:solidFill>
-                            <a:srgbClr val="0F172A"/>
-                          </a:solidFill>
-                          <a:latin typeface="Aptos"/>
-                        </a:rPr>
-                        <a:t>8,970.22</a:t>
+                            <a:srgbClr val="C00000"/>
+                          </a:solidFill>
+                          <a:latin typeface="Aptos"/>
+                        </a:rPr>
+                        <a:t>(14,400.00)</a:t>
                       </a:r>
                     </a:p>
                   </a:txBody>
@@ -17180,11 +17180,11 @@
                       <a:r>
                         <a:rPr b="1" sz="950">
                           <a:solidFill>
-                            <a:srgbClr val="0F172A"/>
-                          </a:solidFill>
-                          <a:latin typeface="Aptos"/>
-                        </a:rPr>
-                        <a:t>8,970.22</a:t>
+                            <a:srgbClr val="C00000"/>
+                          </a:solidFill>
+                          <a:latin typeface="Aptos"/>
+                        </a:rPr>
+                        <a:t>(131,992.00)</a:t>
                       </a:r>
                     </a:p>
                   </a:txBody>
@@ -17233,7 +17233,7 @@
                           </a:solidFill>
                           <a:latin typeface="Aptos"/>
                         </a:rPr>
-                        <a:t>0.2%</a:t>
+                        <a:t>2.2%</a:t>
                       </a:r>
                     </a:p>
                   </a:txBody>
@@ -17282,7 +17282,7 @@
                           </a:solidFill>
                           <a:latin typeface="Aptos"/>
                         </a:rPr>
-                        <a:t>Interest from Maybank pooled account</a:t>
+                        <a:t>Jul truck &amp; phone; reduced every month</a:t>
                       </a:r>
                     </a:p>
                   </a:txBody>
@@ -17333,7 +17333,7 @@
                           </a:solidFill>
                           <a:latin typeface="Aptos"/>
                         </a:rPr>
-                        <a:t>Purchase of property and equipment</a:t>
+                        <a:t>Capex New Branches</a:t>
                       </a:r>
                     </a:p>
                   </a:txBody>
@@ -17382,7 +17382,7 @@
                           </a:solidFill>
                           <a:latin typeface="Aptos"/>
                         </a:rPr>
-                        <a:t>(100,223.00)</a:t>
+                        <a:t>(2,300,748.36)</a:t>
                       </a:r>
                     </a:p>
                   </a:txBody>
@@ -17431,7 +17431,7 @@
                           </a:solidFill>
                           <a:latin typeface="Aptos"/>
                         </a:rPr>
-                        <a:t>(17,369.00)</a:t>
+                        <a:t>(402,958.69)</a:t>
                       </a:r>
                     </a:p>
                   </a:txBody>
@@ -17480,7 +17480,7 @@
                           </a:solidFill>
                           <a:latin typeface="Aptos"/>
                         </a:rPr>
-                        <a:t>(14,400.00)</a:t>
+                        <a:t>(639,849.95)</a:t>
                       </a:r>
                     </a:p>
                   </a:txBody>
@@ -17529,7 +17529,7 @@
                           </a:solidFill>
                           <a:latin typeface="Aptos"/>
                         </a:rPr>
-                        <a:t>(131,992.00)</a:t>
+                        <a:t>(3,343,557.00)</a:t>
                       </a:r>
                     </a:p>
                   </a:txBody>
@@ -17578,7 +17578,7 @@
                           </a:solidFill>
                           <a:latin typeface="Aptos"/>
                         </a:rPr>
-                        <a:t>2.2%</a:t>
+                        <a:t>56.2%</a:t>
                       </a:r>
                     </a:p>
                   </a:txBody>
@@ -17627,7 +17627,7 @@
                           </a:solidFill>
                           <a:latin typeface="Aptos"/>
                         </a:rPr>
-                        <a:t>Jul truck &amp; phone; reduced every month</a:t>
+                        <a:t>For outlet expansion; Jul-26 highest</a:t>
                       </a:r>
                     </a:p>
                   </a:txBody>
@@ -17678,7 +17678,7 @@
                           </a:solidFill>
                           <a:latin typeface="Aptos"/>
                         </a:rPr>
-                        <a:t>Capex New Branches</a:t>
+                        <a:t>Placement of Fixed Deposit</a:t>
                       </a:r>
                     </a:p>
                   </a:txBody>
@@ -17723,11 +17723,11 @@
                       <a:r>
                         <a:rPr b="1" sz="950">
                           <a:solidFill>
-                            <a:srgbClr val="C00000"/>
-                          </a:solidFill>
-                          <a:latin typeface="Aptos"/>
-                        </a:rPr>
-                        <a:t>(2,300,748.36)</a:t>
+                            <a:srgbClr val="0F172A"/>
+                          </a:solidFill>
+                          <a:latin typeface="Aptos"/>
+                        </a:rPr>
+                        <a:t>0.00</a:t>
                       </a:r>
                     </a:p>
                   </a:txBody>
@@ -17772,11 +17772,11 @@
                       <a:r>
                         <a:rPr b="1" sz="950">
                           <a:solidFill>
-                            <a:srgbClr val="C00000"/>
-                          </a:solidFill>
-                          <a:latin typeface="Aptos"/>
-                        </a:rPr>
-                        <a:t>(402,958.69)</a:t>
+                            <a:srgbClr val="0F172A"/>
+                          </a:solidFill>
+                          <a:latin typeface="Aptos"/>
+                        </a:rPr>
+                        <a:t>0.00</a:t>
                       </a:r>
                     </a:p>
                   </a:txBody>
@@ -17825,7 +17825,7 @@
                           </a:solidFill>
                           <a:latin typeface="Aptos"/>
                         </a:rPr>
-                        <a:t>(639,849.95)</a:t>
+                        <a:t>(2,000,000.00)</a:t>
                       </a:r>
                     </a:p>
                   </a:txBody>
@@ -17874,7 +17874,7 @@
                           </a:solidFill>
                           <a:latin typeface="Aptos"/>
                         </a:rPr>
-                        <a:t>(3,343,557.00)</a:t>
+                        <a:t>(2,000,000.00)</a:t>
                       </a:r>
                     </a:p>
                   </a:txBody>
@@ -17923,7 +17923,7 @@
                           </a:solidFill>
                           <a:latin typeface="Aptos"/>
                         </a:rPr>
-                        <a:t>56.1%</a:t>
+                        <a:t>33.6%</a:t>
                       </a:r>
                     </a:p>
                   </a:txBody>
@@ -17972,7 +17972,7 @@
                           </a:solidFill>
                           <a:latin typeface="Aptos"/>
                         </a:rPr>
-                        <a:t>For outlet expansion; Jul-26 highest</a:t>
+                        <a:t>RM2.0M placed in fixed deposit in Sep</a:t>
                       </a:r>
                     </a:p>
                   </a:txBody>
@@ -18023,7 +18023,7 @@
                           </a:solidFill>
                           <a:latin typeface="Aptos"/>
                         </a:rPr>
-                        <a:t>Placement of Fixed Deposit</a:t>
+                        <a:t>Purchase of investment</a:t>
                       </a:r>
                     </a:p>
                   </a:txBody>
@@ -18068,11 +18068,11 @@
                       <a:r>
                         <a:rPr b="1" sz="950">
                           <a:solidFill>
-                            <a:srgbClr val="0F172A"/>
-                          </a:solidFill>
-                          <a:latin typeface="Aptos"/>
-                        </a:rPr>
-                        <a:t>0.00</a:t>
+                            <a:srgbClr val="C00000"/>
+                          </a:solidFill>
+                          <a:latin typeface="Aptos"/>
+                        </a:rPr>
+                        <a:t>(286,293.00)</a:t>
                       </a:r>
                     </a:p>
                   </a:txBody>
@@ -18166,11 +18166,11 @@
                       <a:r>
                         <a:rPr b="1" sz="950">
                           <a:solidFill>
-                            <a:srgbClr val="C00000"/>
-                          </a:solidFill>
-                          <a:latin typeface="Aptos"/>
-                        </a:rPr>
-                        <a:t>(2,000,000.00)</a:t>
+                            <a:srgbClr val="0F172A"/>
+                          </a:solidFill>
+                          <a:latin typeface="Aptos"/>
+                        </a:rPr>
+                        <a:t>0.00</a:t>
                       </a:r>
                     </a:p>
                   </a:txBody>
@@ -18219,7 +18219,7 @@
                           </a:solidFill>
                           <a:latin typeface="Aptos"/>
                         </a:rPr>
-                        <a:t>(2,000,000.00)</a:t>
+                        <a:t>(286,293.00)</a:t>
                       </a:r>
                     </a:p>
                   </a:txBody>
@@ -18268,7 +18268,7 @@
                           </a:solidFill>
                           <a:latin typeface="Aptos"/>
                         </a:rPr>
-                        <a:t>33.6%</a:t>
+                        <a:t>4.8%</a:t>
                       </a:r>
                     </a:p>
                   </a:txBody>
@@ -18317,7 +18317,7 @@
                           </a:solidFill>
                           <a:latin typeface="Aptos"/>
                         </a:rPr>
-                        <a:t>RM2.0M placed in fixed deposit in Sep</a:t>
+                        <a:t>Jul fixed deposit (per accounts remark)</a:t>
                       </a:r>
                     </a:p>
                   </a:txBody>
@@ -18364,41 +18364,41 @@
                       <a:r>
                         <a:rPr b="1" sz="950">
                           <a:solidFill>
-                            <a:srgbClr val="0F172A"/>
-                          </a:solidFill>
-                          <a:latin typeface="Aptos"/>
-                        </a:rPr>
-                        <a:t>Purchase of investment</a:t>
-                      </a:r>
-                    </a:p>
-                  </a:txBody>
-                  <a:tcPr marL="45720" marR="45720" marT="0" marB="0" anchor="ctr">
-                    <a:lnL w="12700" cap="flat" cmpd="sng" algn="ctr">
-                      <a:solidFill>
-                        <a:srgbClr val="FFFFFF"/>
-                      </a:solidFill>
-                      <a:prstDash val="solid"/>
-                    </a:lnL>
-                    <a:lnR w="12700" cap="flat" cmpd="sng" algn="ctr">
-                      <a:solidFill>
-                        <a:srgbClr val="FFFFFF"/>
-                      </a:solidFill>
-                      <a:prstDash val="solid"/>
-                    </a:lnR>
-                    <a:lnT w="12700" cap="flat" cmpd="sng" algn="ctr">
-                      <a:solidFill>
-                        <a:srgbClr val="FFFFFF"/>
-                      </a:solidFill>
-                      <a:prstDash val="solid"/>
-                    </a:lnT>
-                    <a:lnB w="12700" cap="flat" cmpd="sng" algn="ctr">
-                      <a:solidFill>
-                        <a:srgbClr val="FFFFFF"/>
-                      </a:solidFill>
-                      <a:prstDash val="solid"/>
-                    </a:lnB>
-                    <a:solidFill>
-                      <a:srgbClr val="FFF2B3"/>
+                            <a:srgbClr val="FFFFFF"/>
+                          </a:solidFill>
+                          <a:latin typeface="Aptos"/>
+                        </a:rPr>
+                        <a:t>NET INVESTING ACTIVITIES</a:t>
+                      </a:r>
+                    </a:p>
+                  </a:txBody>
+                  <a:tcPr marL="45720" marR="45720" marT="0" marB="0" anchor="ctr">
+                    <a:lnL w="12700" cap="flat" cmpd="sng" algn="ctr">
+                      <a:solidFill>
+                        <a:srgbClr val="FFFFFF"/>
+                      </a:solidFill>
+                      <a:prstDash val="solid"/>
+                    </a:lnL>
+                    <a:lnR w="12700" cap="flat" cmpd="sng" algn="ctr">
+                      <a:solidFill>
+                        <a:srgbClr val="FFFFFF"/>
+                      </a:solidFill>
+                      <a:prstDash val="solid"/>
+                    </a:lnR>
+                    <a:lnT w="12700" cap="flat" cmpd="sng" algn="ctr">
+                      <a:solidFill>
+                        <a:srgbClr val="FFFFFF"/>
+                      </a:solidFill>
+                      <a:prstDash val="solid"/>
+                    </a:lnT>
+                    <a:lnB w="12700" cap="flat" cmpd="sng" algn="ctr">
+                      <a:solidFill>
+                        <a:srgbClr val="FFFFFF"/>
+                      </a:solidFill>
+                      <a:prstDash val="solid"/>
+                    </a:lnB>
+                    <a:solidFill>
+                      <a:srgbClr val="081E42"/>
                     </a:solidFill>
                   </a:tcPr>
                 </a:tc>
@@ -18417,37 +18417,37 @@
                           </a:solidFill>
                           <a:latin typeface="Aptos"/>
                         </a:rPr>
-                        <a:t>(286,293.00)</a:t>
-                      </a:r>
-                    </a:p>
-                  </a:txBody>
-                  <a:tcPr marL="45720" marR="45720" marT="0" marB="0" anchor="ctr">
-                    <a:lnL w="12700" cap="flat" cmpd="sng" algn="ctr">
-                      <a:solidFill>
-                        <a:srgbClr val="FFFFFF"/>
-                      </a:solidFill>
-                      <a:prstDash val="solid"/>
-                    </a:lnL>
-                    <a:lnR w="12700" cap="flat" cmpd="sng" algn="ctr">
-                      <a:solidFill>
-                        <a:srgbClr val="FFFFFF"/>
-                      </a:solidFill>
-                      <a:prstDash val="solid"/>
-                    </a:lnR>
-                    <a:lnT w="12700" cap="flat" cmpd="sng" algn="ctr">
-                      <a:solidFill>
-                        <a:srgbClr val="FFFFFF"/>
-                      </a:solidFill>
-                      <a:prstDash val="solid"/>
-                    </a:lnT>
-                    <a:lnB w="12700" cap="flat" cmpd="sng" algn="ctr">
-                      <a:solidFill>
-                        <a:srgbClr val="FFFFFF"/>
-                      </a:solidFill>
-                      <a:prstDash val="solid"/>
-                    </a:lnB>
-                    <a:solidFill>
-                      <a:srgbClr val="F8FAFC"/>
+                        <a:t>(2,497,139.36)</a:t>
+                      </a:r>
+                    </a:p>
+                  </a:txBody>
+                  <a:tcPr marL="45720" marR="45720" marT="0" marB="0" anchor="ctr">
+                    <a:lnL w="12700" cap="flat" cmpd="sng" algn="ctr">
+                      <a:solidFill>
+                        <a:srgbClr val="FFFFFF"/>
+                      </a:solidFill>
+                      <a:prstDash val="solid"/>
+                    </a:lnL>
+                    <a:lnR w="12700" cap="flat" cmpd="sng" algn="ctr">
+                      <a:solidFill>
+                        <a:srgbClr val="FFFFFF"/>
+                      </a:solidFill>
+                      <a:prstDash val="solid"/>
+                    </a:lnR>
+                    <a:lnT w="12700" cap="flat" cmpd="sng" algn="ctr">
+                      <a:solidFill>
+                        <a:srgbClr val="FFFFFF"/>
+                      </a:solidFill>
+                      <a:prstDash val="solid"/>
+                    </a:lnT>
+                    <a:lnB w="12700" cap="flat" cmpd="sng" algn="ctr">
+                      <a:solidFill>
+                        <a:srgbClr val="FFFFFF"/>
+                      </a:solidFill>
+                      <a:prstDash val="solid"/>
+                    </a:lnB>
+                    <a:solidFill>
+                      <a:srgbClr val="FFC20E"/>
                     </a:solidFill>
                   </a:tcPr>
                 </a:tc>
@@ -18462,41 +18462,41 @@
                       <a:r>
                         <a:rPr b="1" sz="950">
                           <a:solidFill>
-                            <a:srgbClr val="0F172A"/>
-                          </a:solidFill>
-                          <a:latin typeface="Aptos"/>
-                        </a:rPr>
-                        <a:t>0.00</a:t>
-                      </a:r>
-                    </a:p>
-                  </a:txBody>
-                  <a:tcPr marL="45720" marR="45720" marT="0" marB="0" anchor="ctr">
-                    <a:lnL w="12700" cap="flat" cmpd="sng" algn="ctr">
-                      <a:solidFill>
-                        <a:srgbClr val="FFFFFF"/>
-                      </a:solidFill>
-                      <a:prstDash val="solid"/>
-                    </a:lnL>
-                    <a:lnR w="12700" cap="flat" cmpd="sng" algn="ctr">
-                      <a:solidFill>
-                        <a:srgbClr val="FFFFFF"/>
-                      </a:solidFill>
-                      <a:prstDash val="solid"/>
-                    </a:lnR>
-                    <a:lnT w="12700" cap="flat" cmpd="sng" algn="ctr">
-                      <a:solidFill>
-                        <a:srgbClr val="FFFFFF"/>
-                      </a:solidFill>
-                      <a:prstDash val="solid"/>
-                    </a:lnT>
-                    <a:lnB w="12700" cap="flat" cmpd="sng" algn="ctr">
-                      <a:solidFill>
-                        <a:srgbClr val="FFFFFF"/>
-                      </a:solidFill>
-                      <a:prstDash val="solid"/>
-                    </a:lnB>
-                    <a:solidFill>
-                      <a:srgbClr val="FFFFFF"/>
+                            <a:srgbClr val="C00000"/>
+                          </a:solidFill>
+                          <a:latin typeface="Aptos"/>
+                        </a:rPr>
+                        <a:t>(420,327.69)</a:t>
+                      </a:r>
+                    </a:p>
+                  </a:txBody>
+                  <a:tcPr marL="45720" marR="45720" marT="0" marB="0" anchor="ctr">
+                    <a:lnL w="12700" cap="flat" cmpd="sng" algn="ctr">
+                      <a:solidFill>
+                        <a:srgbClr val="FFFFFF"/>
+                      </a:solidFill>
+                      <a:prstDash val="solid"/>
+                    </a:lnL>
+                    <a:lnR w="12700" cap="flat" cmpd="sng" algn="ctr">
+                      <a:solidFill>
+                        <a:srgbClr val="FFFFFF"/>
+                      </a:solidFill>
+                      <a:prstDash val="solid"/>
+                    </a:lnR>
+                    <a:lnT w="12700" cap="flat" cmpd="sng" algn="ctr">
+                      <a:solidFill>
+                        <a:srgbClr val="FFFFFF"/>
+                      </a:solidFill>
+                      <a:prstDash val="solid"/>
+                    </a:lnT>
+                    <a:lnB w="12700" cap="flat" cmpd="sng" algn="ctr">
+                      <a:solidFill>
+                        <a:srgbClr val="FFFFFF"/>
+                      </a:solidFill>
+                      <a:prstDash val="solid"/>
+                    </a:lnB>
+                    <a:solidFill>
+                      <a:srgbClr val="FFC20E"/>
                     </a:solidFill>
                   </a:tcPr>
                 </a:tc>
@@ -18511,41 +18511,41 @@
                       <a:r>
                         <a:rPr b="1" sz="950">
                           <a:solidFill>
-                            <a:srgbClr val="0F172A"/>
-                          </a:solidFill>
-                          <a:latin typeface="Aptos"/>
-                        </a:rPr>
-                        <a:t>0.00</a:t>
-                      </a:r>
-                    </a:p>
-                  </a:txBody>
-                  <a:tcPr marL="45720" marR="45720" marT="0" marB="0" anchor="ctr">
-                    <a:lnL w="12700" cap="flat" cmpd="sng" algn="ctr">
-                      <a:solidFill>
-                        <a:srgbClr val="FFFFFF"/>
-                      </a:solidFill>
-                      <a:prstDash val="solid"/>
-                    </a:lnL>
-                    <a:lnR w="12700" cap="flat" cmpd="sng" algn="ctr">
-                      <a:solidFill>
-                        <a:srgbClr val="FFFFFF"/>
-                      </a:solidFill>
-                      <a:prstDash val="solid"/>
-                    </a:lnR>
-                    <a:lnT w="12700" cap="flat" cmpd="sng" algn="ctr">
-                      <a:solidFill>
-                        <a:srgbClr val="FFFFFF"/>
-                      </a:solidFill>
-                      <a:prstDash val="solid"/>
-                    </a:lnT>
-                    <a:lnB w="12700" cap="flat" cmpd="sng" algn="ctr">
-                      <a:solidFill>
-                        <a:srgbClr val="FFFFFF"/>
-                      </a:solidFill>
-                      <a:prstDash val="solid"/>
-                    </a:lnB>
-                    <a:solidFill>
-                      <a:srgbClr val="F8FAFC"/>
+                            <a:srgbClr val="C00000"/>
+                          </a:solidFill>
+                          <a:latin typeface="Aptos"/>
+                        </a:rPr>
+                        <a:t>(2,654,249.95)</a:t>
+                      </a:r>
+                    </a:p>
+                  </a:txBody>
+                  <a:tcPr marL="45720" marR="45720" marT="0" marB="0" anchor="ctr">
+                    <a:lnL w="12700" cap="flat" cmpd="sng" algn="ctr">
+                      <a:solidFill>
+                        <a:srgbClr val="FFFFFF"/>
+                      </a:solidFill>
+                      <a:prstDash val="solid"/>
+                    </a:lnL>
+                    <a:lnR w="12700" cap="flat" cmpd="sng" algn="ctr">
+                      <a:solidFill>
+                        <a:srgbClr val="FFFFFF"/>
+                      </a:solidFill>
+                      <a:prstDash val="solid"/>
+                    </a:lnR>
+                    <a:lnT w="12700" cap="flat" cmpd="sng" algn="ctr">
+                      <a:solidFill>
+                        <a:srgbClr val="FFFFFF"/>
+                      </a:solidFill>
+                      <a:prstDash val="solid"/>
+                    </a:lnT>
+                    <a:lnB w="12700" cap="flat" cmpd="sng" algn="ctr">
+                      <a:solidFill>
+                        <a:srgbClr val="FFFFFF"/>
+                      </a:solidFill>
+                      <a:prstDash val="solid"/>
+                    </a:lnB>
+                    <a:solidFill>
+                      <a:srgbClr val="FFC20E"/>
                     </a:solidFill>
                   </a:tcPr>
                 </a:tc>
@@ -18564,352 +18564,7 @@
                           </a:solidFill>
                           <a:latin typeface="Aptos"/>
                         </a:rPr>
-                        <a:t>(286,293.00)</a:t>
-                      </a:r>
-                    </a:p>
-                  </a:txBody>
-                  <a:tcPr marL="45720" marR="45720" marT="0" marB="0" anchor="ctr">
-                    <a:lnL w="12700" cap="flat" cmpd="sng" algn="ctr">
-                      <a:solidFill>
-                        <a:srgbClr val="FFFFFF"/>
-                      </a:solidFill>
-                      <a:prstDash val="solid"/>
-                    </a:lnL>
-                    <a:lnR w="12700" cap="flat" cmpd="sng" algn="ctr">
-                      <a:solidFill>
-                        <a:srgbClr val="FFFFFF"/>
-                      </a:solidFill>
-                      <a:prstDash val="solid"/>
-                    </a:lnR>
-                    <a:lnT w="12700" cap="flat" cmpd="sng" algn="ctr">
-                      <a:solidFill>
-                        <a:srgbClr val="FFFFFF"/>
-                      </a:solidFill>
-                      <a:prstDash val="solid"/>
-                    </a:lnT>
-                    <a:lnB w="12700" cap="flat" cmpd="sng" algn="ctr">
-                      <a:solidFill>
-                        <a:srgbClr val="FFFFFF"/>
-                      </a:solidFill>
-                      <a:prstDash val="solid"/>
-                    </a:lnB>
-                    <a:solidFill>
-                      <a:srgbClr val="FFFFFF"/>
-                    </a:solidFill>
-                  </a:tcPr>
-                </a:tc>
-                <a:tc>
-                  <a:txBody>
-                    <a:bodyPr wrap="square"/>
-                    <a:lstStyle/>
-                    <a:p>
-                      <a:pPr algn="ctr">
-                        <a:defRPr sz="950"/>
-                      </a:pPr>
-                      <a:r>
-                        <a:rPr b="1" sz="950">
-                          <a:solidFill>
-                            <a:srgbClr val="0F172A"/>
-                          </a:solidFill>
-                          <a:latin typeface="Aptos"/>
-                        </a:rPr>
-                        <a:t>4.8%</a:t>
-                      </a:r>
-                    </a:p>
-                  </a:txBody>
-                  <a:tcPr marL="45720" marR="45720" marT="0" marB="0" anchor="ctr">
-                    <a:lnL w="12700" cap="flat" cmpd="sng" algn="ctr">
-                      <a:solidFill>
-                        <a:srgbClr val="FFFFFF"/>
-                      </a:solidFill>
-                      <a:prstDash val="solid"/>
-                    </a:lnL>
-                    <a:lnR w="12700" cap="flat" cmpd="sng" algn="ctr">
-                      <a:solidFill>
-                        <a:srgbClr val="FFFFFF"/>
-                      </a:solidFill>
-                      <a:prstDash val="solid"/>
-                    </a:lnR>
-                    <a:lnT w="12700" cap="flat" cmpd="sng" algn="ctr">
-                      <a:solidFill>
-                        <a:srgbClr val="FFFFFF"/>
-                      </a:solidFill>
-                      <a:prstDash val="solid"/>
-                    </a:lnT>
-                    <a:lnB w="12700" cap="flat" cmpd="sng" algn="ctr">
-                      <a:solidFill>
-                        <a:srgbClr val="FFFFFF"/>
-                      </a:solidFill>
-                      <a:prstDash val="solid"/>
-                    </a:lnB>
-                    <a:solidFill>
-                      <a:srgbClr val="DDF0F8"/>
-                    </a:solidFill>
-                  </a:tcPr>
-                </a:tc>
-                <a:tc>
-                  <a:txBody>
-                    <a:bodyPr wrap="square"/>
-                    <a:lstStyle/>
-                    <a:p>
-                      <a:pPr algn="l">
-                        <a:defRPr sz="950"/>
-                      </a:pPr>
-                      <a:r>
-                        <a:rPr b="1" sz="950">
-                          <a:solidFill>
-                            <a:srgbClr val="0F172A"/>
-                          </a:solidFill>
-                          <a:latin typeface="Aptos"/>
-                        </a:rPr>
-                        <a:t>Jul fixed deposit (per accounts remark)</a:t>
-                      </a:r>
-                    </a:p>
-                  </a:txBody>
-                  <a:tcPr marL="45720" marR="45720" marT="0" marB="0" anchor="ctr">
-                    <a:lnL w="12700" cap="flat" cmpd="sng" algn="ctr">
-                      <a:solidFill>
-                        <a:srgbClr val="FFFFFF"/>
-                      </a:solidFill>
-                      <a:prstDash val="solid"/>
-                    </a:lnL>
-                    <a:lnR w="12700" cap="flat" cmpd="sng" algn="ctr">
-                      <a:solidFill>
-                        <a:srgbClr val="FFFFFF"/>
-                      </a:solidFill>
-                      <a:prstDash val="solid"/>
-                    </a:lnR>
-                    <a:lnT w="12700" cap="flat" cmpd="sng" algn="ctr">
-                      <a:solidFill>
-                        <a:srgbClr val="FFFFFF"/>
-                      </a:solidFill>
-                      <a:prstDash val="solid"/>
-                    </a:lnT>
-                    <a:lnB w="12700" cap="flat" cmpd="sng" algn="ctr">
-                      <a:solidFill>
-                        <a:srgbClr val="FFFFFF"/>
-                      </a:solidFill>
-                      <a:prstDash val="solid"/>
-                    </a:lnB>
-                    <a:solidFill>
-                      <a:srgbClr val="FFFFFF"/>
-                    </a:solidFill>
-                  </a:tcPr>
-                </a:tc>
-              </a:tr>
-              <a:tr h="274320">
-                <a:tc>
-                  <a:txBody>
-                    <a:bodyPr wrap="square"/>
-                    <a:lstStyle/>
-                    <a:p>
-                      <a:pPr algn="l">
-                        <a:defRPr sz="950"/>
-                      </a:pPr>
-                      <a:r>
-                        <a:rPr b="1" sz="950">
-                          <a:solidFill>
-                            <a:srgbClr val="FFFFFF"/>
-                          </a:solidFill>
-                          <a:latin typeface="Aptos"/>
-                        </a:rPr>
-                        <a:t>NET INVESTING ACTIVITIES</a:t>
-                      </a:r>
-                    </a:p>
-                  </a:txBody>
-                  <a:tcPr marL="45720" marR="45720" marT="0" marB="0" anchor="ctr">
-                    <a:lnL w="12700" cap="flat" cmpd="sng" algn="ctr">
-                      <a:solidFill>
-                        <a:srgbClr val="FFFFFF"/>
-                      </a:solidFill>
-                      <a:prstDash val="solid"/>
-                    </a:lnL>
-                    <a:lnR w="12700" cap="flat" cmpd="sng" algn="ctr">
-                      <a:solidFill>
-                        <a:srgbClr val="FFFFFF"/>
-                      </a:solidFill>
-                      <a:prstDash val="solid"/>
-                    </a:lnR>
-                    <a:lnT w="12700" cap="flat" cmpd="sng" algn="ctr">
-                      <a:solidFill>
-                        <a:srgbClr val="FFFFFF"/>
-                      </a:solidFill>
-                      <a:prstDash val="solid"/>
-                    </a:lnT>
-                    <a:lnB w="12700" cap="flat" cmpd="sng" algn="ctr">
-                      <a:solidFill>
-                        <a:srgbClr val="FFFFFF"/>
-                      </a:solidFill>
-                      <a:prstDash val="solid"/>
-                    </a:lnB>
-                    <a:solidFill>
-                      <a:srgbClr val="081E42"/>
-                    </a:solidFill>
-                  </a:tcPr>
-                </a:tc>
-                <a:tc>
-                  <a:txBody>
-                    <a:bodyPr wrap="square"/>
-                    <a:lstStyle/>
-                    <a:p>
-                      <a:pPr algn="r">
-                        <a:defRPr sz="950"/>
-                      </a:pPr>
-                      <a:r>
-                        <a:rPr b="1" sz="950">
-                          <a:solidFill>
-                            <a:srgbClr val="C00000"/>
-                          </a:solidFill>
-                          <a:latin typeface="Aptos"/>
-                        </a:rPr>
-                        <a:t>(2,497,139.36)</a:t>
-                      </a:r>
-                    </a:p>
-                  </a:txBody>
-                  <a:tcPr marL="45720" marR="45720" marT="0" marB="0" anchor="ctr">
-                    <a:lnL w="12700" cap="flat" cmpd="sng" algn="ctr">
-                      <a:solidFill>
-                        <a:srgbClr val="FFFFFF"/>
-                      </a:solidFill>
-                      <a:prstDash val="solid"/>
-                    </a:lnL>
-                    <a:lnR w="12700" cap="flat" cmpd="sng" algn="ctr">
-                      <a:solidFill>
-                        <a:srgbClr val="FFFFFF"/>
-                      </a:solidFill>
-                      <a:prstDash val="solid"/>
-                    </a:lnR>
-                    <a:lnT w="12700" cap="flat" cmpd="sng" algn="ctr">
-                      <a:solidFill>
-                        <a:srgbClr val="FFFFFF"/>
-                      </a:solidFill>
-                      <a:prstDash val="solid"/>
-                    </a:lnT>
-                    <a:lnB w="12700" cap="flat" cmpd="sng" algn="ctr">
-                      <a:solidFill>
-                        <a:srgbClr val="FFFFFF"/>
-                      </a:solidFill>
-                      <a:prstDash val="solid"/>
-                    </a:lnB>
-                    <a:solidFill>
-                      <a:srgbClr val="FFC20E"/>
-                    </a:solidFill>
-                  </a:tcPr>
-                </a:tc>
-                <a:tc>
-                  <a:txBody>
-                    <a:bodyPr wrap="square"/>
-                    <a:lstStyle/>
-                    <a:p>
-                      <a:pPr algn="r">
-                        <a:defRPr sz="950"/>
-                      </a:pPr>
-                      <a:r>
-                        <a:rPr b="1" sz="950">
-                          <a:solidFill>
-                            <a:srgbClr val="C00000"/>
-                          </a:solidFill>
-                          <a:latin typeface="Aptos"/>
-                        </a:rPr>
-                        <a:t>(420,327.69)</a:t>
-                      </a:r>
-                    </a:p>
-                  </a:txBody>
-                  <a:tcPr marL="45720" marR="45720" marT="0" marB="0" anchor="ctr">
-                    <a:lnL w="12700" cap="flat" cmpd="sng" algn="ctr">
-                      <a:solidFill>
-                        <a:srgbClr val="FFFFFF"/>
-                      </a:solidFill>
-                      <a:prstDash val="solid"/>
-                    </a:lnL>
-                    <a:lnR w="12700" cap="flat" cmpd="sng" algn="ctr">
-                      <a:solidFill>
-                        <a:srgbClr val="FFFFFF"/>
-                      </a:solidFill>
-                      <a:prstDash val="solid"/>
-                    </a:lnR>
-                    <a:lnT w="12700" cap="flat" cmpd="sng" algn="ctr">
-                      <a:solidFill>
-                        <a:srgbClr val="FFFFFF"/>
-                      </a:solidFill>
-                      <a:prstDash val="solid"/>
-                    </a:lnT>
-                    <a:lnB w="12700" cap="flat" cmpd="sng" algn="ctr">
-                      <a:solidFill>
-                        <a:srgbClr val="FFFFFF"/>
-                      </a:solidFill>
-                      <a:prstDash val="solid"/>
-                    </a:lnB>
-                    <a:solidFill>
-                      <a:srgbClr val="FFC20E"/>
-                    </a:solidFill>
-                  </a:tcPr>
-                </a:tc>
-                <a:tc>
-                  <a:txBody>
-                    <a:bodyPr wrap="square"/>
-                    <a:lstStyle/>
-                    <a:p>
-                      <a:pPr algn="r">
-                        <a:defRPr sz="950"/>
-                      </a:pPr>
-                      <a:r>
-                        <a:rPr b="1" sz="950">
-                          <a:solidFill>
-                            <a:srgbClr val="C00000"/>
-                          </a:solidFill>
-                          <a:latin typeface="Aptos"/>
-                        </a:rPr>
-                        <a:t>(2,645,279.73)</a:t>
-                      </a:r>
-                    </a:p>
-                  </a:txBody>
-                  <a:tcPr marL="45720" marR="45720" marT="0" marB="0" anchor="ctr">
-                    <a:lnL w="12700" cap="flat" cmpd="sng" algn="ctr">
-                      <a:solidFill>
-                        <a:srgbClr val="FFFFFF"/>
-                      </a:solidFill>
-                      <a:prstDash val="solid"/>
-                    </a:lnL>
-                    <a:lnR w="12700" cap="flat" cmpd="sng" algn="ctr">
-                      <a:solidFill>
-                        <a:srgbClr val="FFFFFF"/>
-                      </a:solidFill>
-                      <a:prstDash val="solid"/>
-                    </a:lnR>
-                    <a:lnT w="12700" cap="flat" cmpd="sng" algn="ctr">
-                      <a:solidFill>
-                        <a:srgbClr val="FFFFFF"/>
-                      </a:solidFill>
-                      <a:prstDash val="solid"/>
-                    </a:lnT>
-                    <a:lnB w="12700" cap="flat" cmpd="sng" algn="ctr">
-                      <a:solidFill>
-                        <a:srgbClr val="FFFFFF"/>
-                      </a:solidFill>
-                      <a:prstDash val="solid"/>
-                    </a:lnB>
-                    <a:solidFill>
-                      <a:srgbClr val="FFC20E"/>
-                    </a:solidFill>
-                  </a:tcPr>
-                </a:tc>
-                <a:tc>
-                  <a:txBody>
-                    <a:bodyPr wrap="square"/>
-                    <a:lstStyle/>
-                    <a:p>
-                      <a:pPr algn="r">
-                        <a:defRPr sz="950"/>
-                      </a:pPr>
-                      <a:r>
-                        <a:rPr b="1" sz="950">
-                          <a:solidFill>
-                            <a:srgbClr val="C00000"/>
-                          </a:solidFill>
-                          <a:latin typeface="Aptos"/>
-                        </a:rPr>
-                        <a:t>(5,562,746.78)</a:t>
+                        <a:t>(5,571,717.00)</a:t>
                       </a:r>
                     </a:p>
                   </a:txBody>
@@ -19054,7 +18709,7 @@
         </p:nvSpPr>
         <p:spPr>
           <a:xfrm>
-            <a:off x="256032" y="4078224"/>
+            <a:off x="256032" y="3803904"/>
             <a:ext cx="11679631" cy="237744"/>
           </a:xfrm>
           <a:prstGeom prst="rect">
@@ -19083,7 +18738,7 @@
         </p:nvSpPr>
         <p:spPr>
           <a:xfrm>
-            <a:off x="292608" y="4078224"/>
+            <a:off x="292608" y="3803904"/>
             <a:ext cx="11679631" cy="237744"/>
           </a:xfrm>
           <a:prstGeom prst="rect">
@@ -19119,8 +18774,8 @@
           <p:nvPr/>
         </p:nvGraphicFramePr>
         <p:xfrm>
-          <a:off x="256032" y="4315968"/>
-          <a:ext cx="11676888" cy="1645920"/>
+          <a:off x="256032" y="4041648"/>
+          <a:ext cx="11676888" cy="1920240"/>
         </p:xfrm>
         <a:graphic>
           <a:graphicData uri="http://schemas.openxmlformats.org/drawingml/2006/table">
@@ -19743,7 +19398,7 @@
                           </a:solidFill>
                           <a:latin typeface="Aptos"/>
                         </a:rPr>
-                        <a:t>42.0%</a:t>
+                        <a:t>41.8%</a:t>
                       </a:r>
                     </a:p>
                   </a:txBody>
@@ -19843,7 +19498,7 @@
                           </a:solidFill>
                           <a:latin typeface="Aptos"/>
                         </a:rPr>
-                        <a:t>Repayment from related parties</a:t>
+                        <a:t>Interest received (Maybank pooled)</a:t>
                       </a:r>
                     </a:p>
                   </a:txBody>
@@ -19941,7 +19596,7 @@
                           </a:solidFill>
                           <a:latin typeface="Aptos"/>
                         </a:rPr>
-                        <a:t>210,691.35</a:t>
+                        <a:t>0.00</a:t>
                       </a:r>
                     </a:p>
                   </a:txBody>
@@ -19990,7 +19645,7 @@
                           </a:solidFill>
                           <a:latin typeface="Aptos"/>
                         </a:rPr>
-                        <a:t>8,189.42</a:t>
+                        <a:t>8,970.22</a:t>
                       </a:r>
                     </a:p>
                   </a:txBody>
@@ -20039,7 +19694,7 @@
                           </a:solidFill>
                           <a:latin typeface="Aptos"/>
                         </a:rPr>
-                        <a:t>218,880.77</a:t>
+                        <a:t>8,970.22</a:t>
                       </a:r>
                     </a:p>
                   </a:txBody>
@@ -20088,7 +19743,7 @@
                           </a:solidFill>
                           <a:latin typeface="Aptos"/>
                         </a:rPr>
-                        <a:t>9.7%</a:t>
+                        <a:t>0.4%</a:t>
                       </a:r>
                     </a:p>
                   </a:txBody>
@@ -20137,7 +19792,7 @@
                           </a:solidFill>
                           <a:latin typeface="Aptos"/>
                         </a:rPr>
-                        <a:t>Aug mainly Authentic RM210.6K; Sep TGCK RM8.2K</a:t>
+                        <a:t>Interest from Maybank pooled account (Sep)</a:t>
                       </a:r>
                     </a:p>
                   </a:txBody>
@@ -20188,7 +19843,7 @@
                           </a:solidFill>
                           <a:latin typeface="Aptos"/>
                         </a:rPr>
-                        <a:t>Repayment of loans</a:t>
+                        <a:t>Repayment from related parties</a:t>
                       </a:r>
                     </a:p>
                   </a:txBody>
@@ -20233,11 +19888,11 @@
                       <a:r>
                         <a:rPr b="1" sz="950">
                           <a:solidFill>
-                            <a:srgbClr val="C00000"/>
-                          </a:solidFill>
-                          <a:latin typeface="Aptos"/>
-                        </a:rPr>
-                        <a:t>(159,745.15)</a:t>
+                            <a:srgbClr val="0F172A"/>
+                          </a:solidFill>
+                          <a:latin typeface="Aptos"/>
+                        </a:rPr>
+                        <a:t>0.00</a:t>
                       </a:r>
                     </a:p>
                   </a:txBody>
@@ -20282,11 +19937,11 @@
                       <a:r>
                         <a:rPr b="1" sz="950">
                           <a:solidFill>
-                            <a:srgbClr val="C00000"/>
-                          </a:solidFill>
-                          <a:latin typeface="Aptos"/>
-                        </a:rPr>
-                        <a:t>(155,237.00)</a:t>
+                            <a:srgbClr val="0F172A"/>
+                          </a:solidFill>
+                          <a:latin typeface="Aptos"/>
+                        </a:rPr>
+                        <a:t>210,691.35</a:t>
                       </a:r>
                     </a:p>
                   </a:txBody>
@@ -20331,11 +19986,11 @@
                       <a:r>
                         <a:rPr b="1" sz="950">
                           <a:solidFill>
-                            <a:srgbClr val="C00000"/>
-                          </a:solidFill>
-                          <a:latin typeface="Aptos"/>
-                        </a:rPr>
-                        <a:t>(159,887.29)</a:t>
+                            <a:srgbClr val="0F172A"/>
+                          </a:solidFill>
+                          <a:latin typeface="Aptos"/>
+                        </a:rPr>
+                        <a:t>8,189.42</a:t>
                       </a:r>
                     </a:p>
                   </a:txBody>
@@ -20380,11 +20035,11 @@
                       <a:r>
                         <a:rPr b="1" sz="950">
                           <a:solidFill>
-                            <a:srgbClr val="C00000"/>
-                          </a:solidFill>
-                          <a:latin typeface="Aptos"/>
-                        </a:rPr>
-                        <a:t>(474,869.44)</a:t>
+                            <a:srgbClr val="0F172A"/>
+                          </a:solidFill>
+                          <a:latin typeface="Aptos"/>
+                        </a:rPr>
+                        <a:t>218,880.77</a:t>
                       </a:r>
                     </a:p>
                   </a:txBody>
@@ -20433,7 +20088,7 @@
                           </a:solidFill>
                           <a:latin typeface="Aptos"/>
                         </a:rPr>
-                        <a:t>21.0%</a:t>
+                        <a:t>9.6%</a:t>
                       </a:r>
                     </a:p>
                   </a:txBody>
@@ -20482,7 +20137,7 @@
                           </a:solidFill>
                           <a:latin typeface="Aptos"/>
                         </a:rPr>
-                        <a:t>Stable at about RM155K-RM160K monthly</a:t>
+                        <a:t>Aug mainly Authentic RM210.6K; Sep TGCK RM8.2K</a:t>
                       </a:r>
                     </a:p>
                   </a:txBody>
@@ -20533,7 +20188,7 @@
                           </a:solidFill>
                           <a:latin typeface="Aptos"/>
                         </a:rPr>
-                        <a:t>Advance to related parties</a:t>
+                        <a:t>Repayment of loans</a:t>
                       </a:r>
                     </a:p>
                   </a:txBody>
@@ -20582,7 +20237,7 @@
                           </a:solidFill>
                           <a:latin typeface="Aptos"/>
                         </a:rPr>
-                        <a:t>(417,714.58)</a:t>
+                        <a:t>(159,745.15)</a:t>
                       </a:r>
                     </a:p>
                   </a:txBody>
@@ -20631,7 +20286,7 @@
                           </a:solidFill>
                           <a:latin typeface="Aptos"/>
                         </a:rPr>
-                        <a:t>(417.93)</a:t>
+                        <a:t>(155,237.00)</a:t>
                       </a:r>
                     </a:p>
                   </a:txBody>
@@ -20680,7 +20335,7 @@
                           </a:solidFill>
                           <a:latin typeface="Aptos"/>
                         </a:rPr>
-                        <a:t>(201,003.06)</a:t>
+                        <a:t>(159,887.29)</a:t>
                       </a:r>
                     </a:p>
                   </a:txBody>
@@ -20729,7 +20384,7 @@
                           </a:solidFill>
                           <a:latin typeface="Aptos"/>
                         </a:rPr>
-                        <a:t>(619,135.57)</a:t>
+                        <a:t>(474,869.44)</a:t>
                       </a:r>
                     </a:p>
                   </a:txBody>
@@ -20778,7 +20433,7 @@
                           </a:solidFill>
                           <a:latin typeface="Aptos"/>
                         </a:rPr>
-                        <a:t>27.4%</a:t>
+                        <a:t>20.9%</a:t>
                       </a:r>
                     </a:p>
                   </a:txBody>
@@ -20827,7 +20482,7 @@
                           </a:solidFill>
                           <a:latin typeface="Aptos"/>
                         </a:rPr>
-                        <a:t>Jul: Bebeks 193.7K, Authentic 168.6K; Sep: Rindu Rasa 188.6K</a:t>
+                        <a:t>Stable at about RM155K-RM160K monthly</a:t>
                       </a:r>
                     </a:p>
                   </a:txBody>
@@ -20874,41 +20529,41 @@
                       <a:r>
                         <a:rPr b="1" sz="950">
                           <a:solidFill>
-                            <a:srgbClr val="FFFFFF"/>
-                          </a:solidFill>
-                          <a:latin typeface="Aptos"/>
-                        </a:rPr>
-                        <a:t>NET FINANCING ACTIVITIES</a:t>
-                      </a:r>
-                    </a:p>
-                  </a:txBody>
-                  <a:tcPr marL="45720" marR="45720" marT="0" marB="0" anchor="ctr">
-                    <a:lnL w="12700" cap="flat" cmpd="sng" algn="ctr">
-                      <a:solidFill>
-                        <a:srgbClr val="FFFFFF"/>
-                      </a:solidFill>
-                      <a:prstDash val="solid"/>
-                    </a:lnL>
-                    <a:lnR w="12700" cap="flat" cmpd="sng" algn="ctr">
-                      <a:solidFill>
-                        <a:srgbClr val="FFFFFF"/>
-                      </a:solidFill>
-                      <a:prstDash val="solid"/>
-                    </a:lnR>
-                    <a:lnT w="12700" cap="flat" cmpd="sng" algn="ctr">
-                      <a:solidFill>
-                        <a:srgbClr val="FFFFFF"/>
-                      </a:solidFill>
-                      <a:prstDash val="solid"/>
-                    </a:lnT>
-                    <a:lnB w="12700" cap="flat" cmpd="sng" algn="ctr">
-                      <a:solidFill>
-                        <a:srgbClr val="FFFFFF"/>
-                      </a:solidFill>
-                      <a:prstDash val="solid"/>
-                    </a:lnB>
-                    <a:solidFill>
-                      <a:srgbClr val="081E42"/>
+                            <a:srgbClr val="0F172A"/>
+                          </a:solidFill>
+                          <a:latin typeface="Aptos"/>
+                        </a:rPr>
+                        <a:t>Advance to related parties</a:t>
+                      </a:r>
+                    </a:p>
+                  </a:txBody>
+                  <a:tcPr marL="45720" marR="45720" marT="0" marB="0" anchor="ctr">
+                    <a:lnL w="12700" cap="flat" cmpd="sng" algn="ctr">
+                      <a:solidFill>
+                        <a:srgbClr val="FFFFFF"/>
+                      </a:solidFill>
+                      <a:prstDash val="solid"/>
+                    </a:lnL>
+                    <a:lnR w="12700" cap="flat" cmpd="sng" algn="ctr">
+                      <a:solidFill>
+                        <a:srgbClr val="FFFFFF"/>
+                      </a:solidFill>
+                      <a:prstDash val="solid"/>
+                    </a:lnR>
+                    <a:lnT w="12700" cap="flat" cmpd="sng" algn="ctr">
+                      <a:solidFill>
+                        <a:srgbClr val="FFFFFF"/>
+                      </a:solidFill>
+                      <a:prstDash val="solid"/>
+                    </a:lnT>
+                    <a:lnB w="12700" cap="flat" cmpd="sng" algn="ctr">
+                      <a:solidFill>
+                        <a:srgbClr val="FFFFFF"/>
+                      </a:solidFill>
+                      <a:prstDash val="solid"/>
+                    </a:lnB>
+                    <a:solidFill>
+                      <a:srgbClr val="FFF2B3"/>
                     </a:solidFill>
                   </a:tcPr>
                 </a:tc>
@@ -20923,41 +20578,41 @@
                       <a:r>
                         <a:rPr b="1" sz="950">
                           <a:solidFill>
-                            <a:srgbClr val="0F172A"/>
-                          </a:solidFill>
-                          <a:latin typeface="Aptos"/>
-                        </a:rPr>
-                        <a:t>142,540.27</a:t>
-                      </a:r>
-                    </a:p>
-                  </a:txBody>
-                  <a:tcPr marL="45720" marR="45720" marT="0" marB="0" anchor="ctr">
-                    <a:lnL w="12700" cap="flat" cmpd="sng" algn="ctr">
-                      <a:solidFill>
-                        <a:srgbClr val="FFFFFF"/>
-                      </a:solidFill>
-                      <a:prstDash val="solid"/>
-                    </a:lnL>
-                    <a:lnR w="12700" cap="flat" cmpd="sng" algn="ctr">
-                      <a:solidFill>
-                        <a:srgbClr val="FFFFFF"/>
-                      </a:solidFill>
-                      <a:prstDash val="solid"/>
-                    </a:lnR>
-                    <a:lnT w="12700" cap="flat" cmpd="sng" algn="ctr">
-                      <a:solidFill>
-                        <a:srgbClr val="FFFFFF"/>
-                      </a:solidFill>
-                      <a:prstDash val="solid"/>
-                    </a:lnT>
-                    <a:lnB w="12700" cap="flat" cmpd="sng" algn="ctr">
-                      <a:solidFill>
-                        <a:srgbClr val="FFFFFF"/>
-                      </a:solidFill>
-                      <a:prstDash val="solid"/>
-                    </a:lnB>
-                    <a:solidFill>
-                      <a:srgbClr val="FFC20E"/>
+                            <a:srgbClr val="C00000"/>
+                          </a:solidFill>
+                          <a:latin typeface="Aptos"/>
+                        </a:rPr>
+                        <a:t>(417,714.58)</a:t>
+                      </a:r>
+                    </a:p>
+                  </a:txBody>
+                  <a:tcPr marL="45720" marR="45720" marT="0" marB="0" anchor="ctr">
+                    <a:lnL w="12700" cap="flat" cmpd="sng" algn="ctr">
+                      <a:solidFill>
+                        <a:srgbClr val="FFFFFF"/>
+                      </a:solidFill>
+                      <a:prstDash val="solid"/>
+                    </a:lnL>
+                    <a:lnR w="12700" cap="flat" cmpd="sng" algn="ctr">
+                      <a:solidFill>
+                        <a:srgbClr val="FFFFFF"/>
+                      </a:solidFill>
+                      <a:prstDash val="solid"/>
+                    </a:lnR>
+                    <a:lnT w="12700" cap="flat" cmpd="sng" algn="ctr">
+                      <a:solidFill>
+                        <a:srgbClr val="FFFFFF"/>
+                      </a:solidFill>
+                      <a:prstDash val="solid"/>
+                    </a:lnT>
+                    <a:lnB w="12700" cap="flat" cmpd="sng" algn="ctr">
+                      <a:solidFill>
+                        <a:srgbClr val="FFFFFF"/>
+                      </a:solidFill>
+                      <a:prstDash val="solid"/>
+                    </a:lnB>
+                    <a:solidFill>
+                      <a:srgbClr val="F8FAFC"/>
                     </a:solidFill>
                   </a:tcPr>
                 </a:tc>
@@ -20972,41 +20627,41 @@
                       <a:r>
                         <a:rPr b="1" sz="950">
                           <a:solidFill>
-                            <a:srgbClr val="0F172A"/>
-                          </a:solidFill>
-                          <a:latin typeface="Aptos"/>
-                        </a:rPr>
-                        <a:t>55,036.42</a:t>
-                      </a:r>
-                    </a:p>
-                  </a:txBody>
-                  <a:tcPr marL="45720" marR="45720" marT="0" marB="0" anchor="ctr">
-                    <a:lnL w="12700" cap="flat" cmpd="sng" algn="ctr">
-                      <a:solidFill>
-                        <a:srgbClr val="FFFFFF"/>
-                      </a:solidFill>
-                      <a:prstDash val="solid"/>
-                    </a:lnL>
-                    <a:lnR w="12700" cap="flat" cmpd="sng" algn="ctr">
-                      <a:solidFill>
-                        <a:srgbClr val="FFFFFF"/>
-                      </a:solidFill>
-                      <a:prstDash val="solid"/>
-                    </a:lnR>
-                    <a:lnT w="12700" cap="flat" cmpd="sng" algn="ctr">
-                      <a:solidFill>
-                        <a:srgbClr val="FFFFFF"/>
-                      </a:solidFill>
-                      <a:prstDash val="solid"/>
-                    </a:lnT>
-                    <a:lnB w="12700" cap="flat" cmpd="sng" algn="ctr">
-                      <a:solidFill>
-                        <a:srgbClr val="FFFFFF"/>
-                      </a:solidFill>
-                      <a:prstDash val="solid"/>
-                    </a:lnB>
-                    <a:solidFill>
-                      <a:srgbClr val="FFC20E"/>
+                            <a:srgbClr val="C00000"/>
+                          </a:solidFill>
+                          <a:latin typeface="Aptos"/>
+                        </a:rPr>
+                        <a:t>(417.93)</a:t>
+                      </a:r>
+                    </a:p>
+                  </a:txBody>
+                  <a:tcPr marL="45720" marR="45720" marT="0" marB="0" anchor="ctr">
+                    <a:lnL w="12700" cap="flat" cmpd="sng" algn="ctr">
+                      <a:solidFill>
+                        <a:srgbClr val="FFFFFF"/>
+                      </a:solidFill>
+                      <a:prstDash val="solid"/>
+                    </a:lnL>
+                    <a:lnR w="12700" cap="flat" cmpd="sng" algn="ctr">
+                      <a:solidFill>
+                        <a:srgbClr val="FFFFFF"/>
+                      </a:solidFill>
+                      <a:prstDash val="solid"/>
+                    </a:lnR>
+                    <a:lnT w="12700" cap="flat" cmpd="sng" algn="ctr">
+                      <a:solidFill>
+                        <a:srgbClr val="FFFFFF"/>
+                      </a:solidFill>
+                      <a:prstDash val="solid"/>
+                    </a:lnT>
+                    <a:lnB w="12700" cap="flat" cmpd="sng" algn="ctr">
+                      <a:solidFill>
+                        <a:srgbClr val="FFFFFF"/>
+                      </a:solidFill>
+                      <a:prstDash val="solid"/>
+                    </a:lnB>
+                    <a:solidFill>
+                      <a:srgbClr val="FFFFFF"/>
                     </a:solidFill>
                   </a:tcPr>
                 </a:tc>
@@ -21025,37 +20680,37 @@
                           </a:solidFill>
                           <a:latin typeface="Aptos"/>
                         </a:rPr>
-                        <a:t>(123,700.93)</a:t>
-                      </a:r>
-                    </a:p>
-                  </a:txBody>
-                  <a:tcPr marL="45720" marR="45720" marT="0" marB="0" anchor="ctr">
-                    <a:lnL w="12700" cap="flat" cmpd="sng" algn="ctr">
-                      <a:solidFill>
-                        <a:srgbClr val="FFFFFF"/>
-                      </a:solidFill>
-                      <a:prstDash val="solid"/>
-                    </a:lnL>
-                    <a:lnR w="12700" cap="flat" cmpd="sng" algn="ctr">
-                      <a:solidFill>
-                        <a:srgbClr val="FFFFFF"/>
-                      </a:solidFill>
-                      <a:prstDash val="solid"/>
-                    </a:lnR>
-                    <a:lnT w="12700" cap="flat" cmpd="sng" algn="ctr">
-                      <a:solidFill>
-                        <a:srgbClr val="FFFFFF"/>
-                      </a:solidFill>
-                      <a:prstDash val="solid"/>
-                    </a:lnT>
-                    <a:lnB w="12700" cap="flat" cmpd="sng" algn="ctr">
-                      <a:solidFill>
-                        <a:srgbClr val="FFFFFF"/>
-                      </a:solidFill>
-                      <a:prstDash val="solid"/>
-                    </a:lnB>
-                    <a:solidFill>
-                      <a:srgbClr val="FFC20E"/>
+                        <a:t>(201,003.06)</a:t>
+                      </a:r>
+                    </a:p>
+                  </a:txBody>
+                  <a:tcPr marL="45720" marR="45720" marT="0" marB="0" anchor="ctr">
+                    <a:lnL w="12700" cap="flat" cmpd="sng" algn="ctr">
+                      <a:solidFill>
+                        <a:srgbClr val="FFFFFF"/>
+                      </a:solidFill>
+                      <a:prstDash val="solid"/>
+                    </a:lnL>
+                    <a:lnR w="12700" cap="flat" cmpd="sng" algn="ctr">
+                      <a:solidFill>
+                        <a:srgbClr val="FFFFFF"/>
+                      </a:solidFill>
+                      <a:prstDash val="solid"/>
+                    </a:lnR>
+                    <a:lnT w="12700" cap="flat" cmpd="sng" algn="ctr">
+                      <a:solidFill>
+                        <a:srgbClr val="FFFFFF"/>
+                      </a:solidFill>
+                      <a:prstDash val="solid"/>
+                    </a:lnT>
+                    <a:lnB w="12700" cap="flat" cmpd="sng" algn="ctr">
+                      <a:solidFill>
+                        <a:srgbClr val="FFFFFF"/>
+                      </a:solidFill>
+                      <a:prstDash val="solid"/>
+                    </a:lnB>
+                    <a:solidFill>
+                      <a:srgbClr val="F8FAFC"/>
                     </a:solidFill>
                   </a:tcPr>
                 </a:tc>
@@ -21070,11 +20725,356 @@
                       <a:r>
                         <a:rPr b="1" sz="950">
                           <a:solidFill>
-                            <a:srgbClr val="0F172A"/>
-                          </a:solidFill>
-                          <a:latin typeface="Aptos"/>
-                        </a:rPr>
-                        <a:t>73,875.76</a:t>
+                            <a:srgbClr val="C00000"/>
+                          </a:solidFill>
+                          <a:latin typeface="Aptos"/>
+                        </a:rPr>
+                        <a:t>(619,135.57)</a:t>
+                      </a:r>
+                    </a:p>
+                  </a:txBody>
+                  <a:tcPr marL="45720" marR="45720" marT="0" marB="0" anchor="ctr">
+                    <a:lnL w="12700" cap="flat" cmpd="sng" algn="ctr">
+                      <a:solidFill>
+                        <a:srgbClr val="FFFFFF"/>
+                      </a:solidFill>
+                      <a:prstDash val="solid"/>
+                    </a:lnL>
+                    <a:lnR w="12700" cap="flat" cmpd="sng" algn="ctr">
+                      <a:solidFill>
+                        <a:srgbClr val="FFFFFF"/>
+                      </a:solidFill>
+                      <a:prstDash val="solid"/>
+                    </a:lnR>
+                    <a:lnT w="12700" cap="flat" cmpd="sng" algn="ctr">
+                      <a:solidFill>
+                        <a:srgbClr val="FFFFFF"/>
+                      </a:solidFill>
+                      <a:prstDash val="solid"/>
+                    </a:lnT>
+                    <a:lnB w="12700" cap="flat" cmpd="sng" algn="ctr">
+                      <a:solidFill>
+                        <a:srgbClr val="FFFFFF"/>
+                      </a:solidFill>
+                      <a:prstDash val="solid"/>
+                    </a:lnB>
+                    <a:solidFill>
+                      <a:srgbClr val="FFFFFF"/>
+                    </a:solidFill>
+                  </a:tcPr>
+                </a:tc>
+                <a:tc>
+                  <a:txBody>
+                    <a:bodyPr wrap="square"/>
+                    <a:lstStyle/>
+                    <a:p>
+                      <a:pPr algn="ctr">
+                        <a:defRPr sz="950"/>
+                      </a:pPr>
+                      <a:r>
+                        <a:rPr b="1" sz="950">
+                          <a:solidFill>
+                            <a:srgbClr val="0F172A"/>
+                          </a:solidFill>
+                          <a:latin typeface="Aptos"/>
+                        </a:rPr>
+                        <a:t>27.3%</a:t>
+                      </a:r>
+                    </a:p>
+                  </a:txBody>
+                  <a:tcPr marL="45720" marR="45720" marT="0" marB="0" anchor="ctr">
+                    <a:lnL w="12700" cap="flat" cmpd="sng" algn="ctr">
+                      <a:solidFill>
+                        <a:srgbClr val="FFFFFF"/>
+                      </a:solidFill>
+                      <a:prstDash val="solid"/>
+                    </a:lnL>
+                    <a:lnR w="12700" cap="flat" cmpd="sng" algn="ctr">
+                      <a:solidFill>
+                        <a:srgbClr val="FFFFFF"/>
+                      </a:solidFill>
+                      <a:prstDash val="solid"/>
+                    </a:lnR>
+                    <a:lnT w="12700" cap="flat" cmpd="sng" algn="ctr">
+                      <a:solidFill>
+                        <a:srgbClr val="FFFFFF"/>
+                      </a:solidFill>
+                      <a:prstDash val="solid"/>
+                    </a:lnT>
+                    <a:lnB w="12700" cap="flat" cmpd="sng" algn="ctr">
+                      <a:solidFill>
+                        <a:srgbClr val="FFFFFF"/>
+                      </a:solidFill>
+                      <a:prstDash val="solid"/>
+                    </a:lnB>
+                    <a:solidFill>
+                      <a:srgbClr val="DDF0F8"/>
+                    </a:solidFill>
+                  </a:tcPr>
+                </a:tc>
+                <a:tc>
+                  <a:txBody>
+                    <a:bodyPr wrap="square"/>
+                    <a:lstStyle/>
+                    <a:p>
+                      <a:pPr algn="l">
+                        <a:defRPr sz="950"/>
+                      </a:pPr>
+                      <a:r>
+                        <a:rPr b="1" sz="950">
+                          <a:solidFill>
+                            <a:srgbClr val="0F172A"/>
+                          </a:solidFill>
+                          <a:latin typeface="Aptos"/>
+                        </a:rPr>
+                        <a:t>Jul: Bebeks 193.7K, Authentic 168.6K; Sep: Rindu Rasa 188.6K</a:t>
+                      </a:r>
+                    </a:p>
+                  </a:txBody>
+                  <a:tcPr marL="45720" marR="45720" marT="0" marB="0" anchor="ctr">
+                    <a:lnL w="12700" cap="flat" cmpd="sng" algn="ctr">
+                      <a:solidFill>
+                        <a:srgbClr val="FFFFFF"/>
+                      </a:solidFill>
+                      <a:prstDash val="solid"/>
+                    </a:lnL>
+                    <a:lnR w="12700" cap="flat" cmpd="sng" algn="ctr">
+                      <a:solidFill>
+                        <a:srgbClr val="FFFFFF"/>
+                      </a:solidFill>
+                      <a:prstDash val="solid"/>
+                    </a:lnR>
+                    <a:lnT w="12700" cap="flat" cmpd="sng" algn="ctr">
+                      <a:solidFill>
+                        <a:srgbClr val="FFFFFF"/>
+                      </a:solidFill>
+                      <a:prstDash val="solid"/>
+                    </a:lnT>
+                    <a:lnB w="12700" cap="flat" cmpd="sng" algn="ctr">
+                      <a:solidFill>
+                        <a:srgbClr val="FFFFFF"/>
+                      </a:solidFill>
+                      <a:prstDash val="solid"/>
+                    </a:lnB>
+                    <a:solidFill>
+                      <a:srgbClr val="FFFFFF"/>
+                    </a:solidFill>
+                  </a:tcPr>
+                </a:tc>
+              </a:tr>
+              <a:tr h="274320">
+                <a:tc>
+                  <a:txBody>
+                    <a:bodyPr wrap="square"/>
+                    <a:lstStyle/>
+                    <a:p>
+                      <a:pPr algn="l">
+                        <a:defRPr sz="950"/>
+                      </a:pPr>
+                      <a:r>
+                        <a:rPr b="1" sz="950">
+                          <a:solidFill>
+                            <a:srgbClr val="FFFFFF"/>
+                          </a:solidFill>
+                          <a:latin typeface="Aptos"/>
+                        </a:rPr>
+                        <a:t>NET FINANCING ACTIVITIES</a:t>
+                      </a:r>
+                    </a:p>
+                  </a:txBody>
+                  <a:tcPr marL="45720" marR="45720" marT="0" marB="0" anchor="ctr">
+                    <a:lnL w="12700" cap="flat" cmpd="sng" algn="ctr">
+                      <a:solidFill>
+                        <a:srgbClr val="FFFFFF"/>
+                      </a:solidFill>
+                      <a:prstDash val="solid"/>
+                    </a:lnL>
+                    <a:lnR w="12700" cap="flat" cmpd="sng" algn="ctr">
+                      <a:solidFill>
+                        <a:srgbClr val="FFFFFF"/>
+                      </a:solidFill>
+                      <a:prstDash val="solid"/>
+                    </a:lnR>
+                    <a:lnT w="12700" cap="flat" cmpd="sng" algn="ctr">
+                      <a:solidFill>
+                        <a:srgbClr val="FFFFFF"/>
+                      </a:solidFill>
+                      <a:prstDash val="solid"/>
+                    </a:lnT>
+                    <a:lnB w="12700" cap="flat" cmpd="sng" algn="ctr">
+                      <a:solidFill>
+                        <a:srgbClr val="FFFFFF"/>
+                      </a:solidFill>
+                      <a:prstDash val="solid"/>
+                    </a:lnB>
+                    <a:solidFill>
+                      <a:srgbClr val="081E42"/>
+                    </a:solidFill>
+                  </a:tcPr>
+                </a:tc>
+                <a:tc>
+                  <a:txBody>
+                    <a:bodyPr wrap="square"/>
+                    <a:lstStyle/>
+                    <a:p>
+                      <a:pPr algn="r">
+                        <a:defRPr sz="950"/>
+                      </a:pPr>
+                      <a:r>
+                        <a:rPr b="1" sz="950">
+                          <a:solidFill>
+                            <a:srgbClr val="0F172A"/>
+                          </a:solidFill>
+                          <a:latin typeface="Aptos"/>
+                        </a:rPr>
+                        <a:t>142,540.27</a:t>
+                      </a:r>
+                    </a:p>
+                  </a:txBody>
+                  <a:tcPr marL="45720" marR="45720" marT="0" marB="0" anchor="ctr">
+                    <a:lnL w="12700" cap="flat" cmpd="sng" algn="ctr">
+                      <a:solidFill>
+                        <a:srgbClr val="FFFFFF"/>
+                      </a:solidFill>
+                      <a:prstDash val="solid"/>
+                    </a:lnL>
+                    <a:lnR w="12700" cap="flat" cmpd="sng" algn="ctr">
+                      <a:solidFill>
+                        <a:srgbClr val="FFFFFF"/>
+                      </a:solidFill>
+                      <a:prstDash val="solid"/>
+                    </a:lnR>
+                    <a:lnT w="12700" cap="flat" cmpd="sng" algn="ctr">
+                      <a:solidFill>
+                        <a:srgbClr val="FFFFFF"/>
+                      </a:solidFill>
+                      <a:prstDash val="solid"/>
+                    </a:lnT>
+                    <a:lnB w="12700" cap="flat" cmpd="sng" algn="ctr">
+                      <a:solidFill>
+                        <a:srgbClr val="FFFFFF"/>
+                      </a:solidFill>
+                      <a:prstDash val="solid"/>
+                    </a:lnB>
+                    <a:solidFill>
+                      <a:srgbClr val="FFC20E"/>
+                    </a:solidFill>
+                  </a:tcPr>
+                </a:tc>
+                <a:tc>
+                  <a:txBody>
+                    <a:bodyPr wrap="square"/>
+                    <a:lstStyle/>
+                    <a:p>
+                      <a:pPr algn="r">
+                        <a:defRPr sz="950"/>
+                      </a:pPr>
+                      <a:r>
+                        <a:rPr b="1" sz="950">
+                          <a:solidFill>
+                            <a:srgbClr val="0F172A"/>
+                          </a:solidFill>
+                          <a:latin typeface="Aptos"/>
+                        </a:rPr>
+                        <a:t>55,036.42</a:t>
+                      </a:r>
+                    </a:p>
+                  </a:txBody>
+                  <a:tcPr marL="45720" marR="45720" marT="0" marB="0" anchor="ctr">
+                    <a:lnL w="12700" cap="flat" cmpd="sng" algn="ctr">
+                      <a:solidFill>
+                        <a:srgbClr val="FFFFFF"/>
+                      </a:solidFill>
+                      <a:prstDash val="solid"/>
+                    </a:lnL>
+                    <a:lnR w="12700" cap="flat" cmpd="sng" algn="ctr">
+                      <a:solidFill>
+                        <a:srgbClr val="FFFFFF"/>
+                      </a:solidFill>
+                      <a:prstDash val="solid"/>
+                    </a:lnR>
+                    <a:lnT w="12700" cap="flat" cmpd="sng" algn="ctr">
+                      <a:solidFill>
+                        <a:srgbClr val="FFFFFF"/>
+                      </a:solidFill>
+                      <a:prstDash val="solid"/>
+                    </a:lnT>
+                    <a:lnB w="12700" cap="flat" cmpd="sng" algn="ctr">
+                      <a:solidFill>
+                        <a:srgbClr val="FFFFFF"/>
+                      </a:solidFill>
+                      <a:prstDash val="solid"/>
+                    </a:lnB>
+                    <a:solidFill>
+                      <a:srgbClr val="FFC20E"/>
+                    </a:solidFill>
+                  </a:tcPr>
+                </a:tc>
+                <a:tc>
+                  <a:txBody>
+                    <a:bodyPr wrap="square"/>
+                    <a:lstStyle/>
+                    <a:p>
+                      <a:pPr algn="r">
+                        <a:defRPr sz="950"/>
+                      </a:pPr>
+                      <a:r>
+                        <a:rPr b="1" sz="950">
+                          <a:solidFill>
+                            <a:srgbClr val="C00000"/>
+                          </a:solidFill>
+                          <a:latin typeface="Aptos"/>
+                        </a:rPr>
+                        <a:t>(114,730.71)</a:t>
+                      </a:r>
+                    </a:p>
+                  </a:txBody>
+                  <a:tcPr marL="45720" marR="45720" marT="0" marB="0" anchor="ctr">
+                    <a:lnL w="12700" cap="flat" cmpd="sng" algn="ctr">
+                      <a:solidFill>
+                        <a:srgbClr val="FFFFFF"/>
+                      </a:solidFill>
+                      <a:prstDash val="solid"/>
+                    </a:lnL>
+                    <a:lnR w="12700" cap="flat" cmpd="sng" algn="ctr">
+                      <a:solidFill>
+                        <a:srgbClr val="FFFFFF"/>
+                      </a:solidFill>
+                      <a:prstDash val="solid"/>
+                    </a:lnR>
+                    <a:lnT w="12700" cap="flat" cmpd="sng" algn="ctr">
+                      <a:solidFill>
+                        <a:srgbClr val="FFFFFF"/>
+                      </a:solidFill>
+                      <a:prstDash val="solid"/>
+                    </a:lnT>
+                    <a:lnB w="12700" cap="flat" cmpd="sng" algn="ctr">
+                      <a:solidFill>
+                        <a:srgbClr val="FFFFFF"/>
+                      </a:solidFill>
+                      <a:prstDash val="solid"/>
+                    </a:lnB>
+                    <a:solidFill>
+                      <a:srgbClr val="FFC20E"/>
+                    </a:solidFill>
+                  </a:tcPr>
+                </a:tc>
+                <a:tc>
+                  <a:txBody>
+                    <a:bodyPr wrap="square"/>
+                    <a:lstStyle/>
+                    <a:p>
+                      <a:pPr algn="r">
+                        <a:defRPr sz="950"/>
+                      </a:pPr>
+                      <a:r>
+                        <a:rPr b="1" sz="950">
+                          <a:solidFill>
+                            <a:srgbClr val="0F172A"/>
+                          </a:solidFill>
+                          <a:latin typeface="Aptos"/>
+                        </a:rPr>
+                        <a:t>82,845.98</a:t>
                       </a:r>
                     </a:p>
                   </a:txBody>

</xml_diff>

<commit_message>
Show July Bebeks payment as repayment to related parties in Q3 deck
Moves RM193,746.06 (investor fund transferred to Bebeks) from advance to
related parties to repayment to related parties, both within financing.
Net financing is unchanged; the source line notes the adjustment.

Co-Authored-By: Claude Opus 5.5 <noreply@anthropic.com>
Claude-Session: https://claude.ai/code/session_01UekZ1BuiJW323matwahEES
</commit_message>
<xml_diff>
--- a/q3-finance-report/Q3_2026_Finance_Report.pptx
+++ b/q3-finance-report/Q3_2026_Finance_Report.pptx
@@ -3330,7 +3330,7 @@
                 </a:solidFill>
                 <a:latin typeface="Aptos"/>
               </a:rPr>
-              <a:t>Source: TGFB Cash Flow Statement PDFs for July, August and September 2026 (latest revised upload). Sep interest received (RM8,970.22) shown under financing; statement shows it under investing.</a:t>
+              <a:t>Source: TGFB Cash Flow Statement PDFs for July, August and September 2026 (latest revised upload). Adjusted from statements: Sep interest received (RM8,970.22) shown under financing instead of investing; Jul Bebeks (RM193,746.06) shown as repayment to related parties instead of advance.</a:t>
             </a:r>
           </a:p>
         </p:txBody>
@@ -6658,7 +6658,7 @@
                 </a:solidFill>
                 <a:latin typeface="Aptos"/>
               </a:rPr>
-              <a:t>Source: TGFB Cash Flow Statement PDFs for July, August and September 2026 (latest revised upload). Sep interest received (RM8,970.22) shown under financing; statement shows it under investing.</a:t>
+              <a:t>Source: TGFB Cash Flow Statement PDFs for July, August and September 2026 (latest revised upload). Adjusted from statements: Sep interest received (RM8,970.22) shown under financing instead of investing; Jul Bebeks (RM193,746.06) shown as repayment to related parties instead of advance.</a:t>
             </a:r>
           </a:p>
         </p:txBody>
@@ -9199,7 +9199,7 @@
                 </a:solidFill>
                 <a:latin typeface="Aptos"/>
               </a:rPr>
-              <a:t>Source: TGFB Cash Flow Statement PDFs for July, August and September 2026 (latest revised upload). Sep interest received (RM8,970.22) shown under financing; statement shows it under investing.</a:t>
+              <a:t>Source: TGFB Cash Flow Statement PDFs for July, August and September 2026 (latest revised upload). Adjusted from statements: Sep interest received (RM8,970.22) shown under financing instead of investing; Jul Bebeks (RM193,746.06) shown as repayment to related parties instead of advance.</a:t>
             </a:r>
           </a:p>
         </p:txBody>
@@ -16186,7 +16186,7 @@
                 </a:solidFill>
                 <a:latin typeface="Aptos"/>
               </a:rPr>
-              <a:t>Source: TGFB Cash Flow Statement PDFs for July, August and September 2026 (latest revised upload). Sep interest received (RM8,970.22) shown under financing; statement shows it under investing.</a:t>
+              <a:t>Source: TGFB Cash Flow Statement PDFs for July, August and September 2026 (latest revised upload). Adjusted from statements: Sep interest received (RM8,970.22) shown under financing instead of investing; Jul Bebeks (RM193,746.06) shown as repayment to related parties instead of advance.</a:t>
             </a:r>
           </a:p>
         </p:txBody>
@@ -18775,7 +18775,7 @@
         </p:nvGraphicFramePr>
         <p:xfrm>
           <a:off x="256032" y="4041648"/>
-          <a:ext cx="11676888" cy="1920240"/>
+          <a:ext cx="11676888" cy="2194560"/>
         </p:xfrm>
         <a:graphic>
           <a:graphicData uri="http://schemas.openxmlformats.org/drawingml/2006/table">
@@ -20582,7 +20582,7 @@
                           </a:solidFill>
                           <a:latin typeface="Aptos"/>
                         </a:rPr>
-                        <a:t>(417,714.58)</a:t>
+                        <a:t>(223,968.52)</a:t>
                       </a:r>
                     </a:p>
                   </a:txBody>
@@ -20729,7 +20729,7 @@
                           </a:solidFill>
                           <a:latin typeface="Aptos"/>
                         </a:rPr>
-                        <a:t>(619,135.57)</a:t>
+                        <a:t>(425,389.51)</a:t>
                       </a:r>
                     </a:p>
                   </a:txBody>
@@ -20778,7 +20778,7 @@
                           </a:solidFill>
                           <a:latin typeface="Aptos"/>
                         </a:rPr>
-                        <a:t>27.3%</a:t>
+                        <a:t>18.7%</a:t>
                       </a:r>
                     </a:p>
                   </a:txBody>
@@ -20827,7 +20827,352 @@
                           </a:solidFill>
                           <a:latin typeface="Aptos"/>
                         </a:rPr>
-                        <a:t>Jul: Bebeks 193.7K, Authentic 168.6K; Sep: Rindu Rasa 188.6K</a:t>
+                        <a:t>Jul: Authentic 168.6K, TGL 27.9K; Sep: Rindu Rasa 188.6K</a:t>
+                      </a:r>
+                    </a:p>
+                  </a:txBody>
+                  <a:tcPr marL="45720" marR="45720" marT="0" marB="0" anchor="ctr">
+                    <a:lnL w="12700" cap="flat" cmpd="sng" algn="ctr">
+                      <a:solidFill>
+                        <a:srgbClr val="FFFFFF"/>
+                      </a:solidFill>
+                      <a:prstDash val="solid"/>
+                    </a:lnL>
+                    <a:lnR w="12700" cap="flat" cmpd="sng" algn="ctr">
+                      <a:solidFill>
+                        <a:srgbClr val="FFFFFF"/>
+                      </a:solidFill>
+                      <a:prstDash val="solid"/>
+                    </a:lnR>
+                    <a:lnT w="12700" cap="flat" cmpd="sng" algn="ctr">
+                      <a:solidFill>
+                        <a:srgbClr val="FFFFFF"/>
+                      </a:solidFill>
+                      <a:prstDash val="solid"/>
+                    </a:lnT>
+                    <a:lnB w="12700" cap="flat" cmpd="sng" algn="ctr">
+                      <a:solidFill>
+                        <a:srgbClr val="FFFFFF"/>
+                      </a:solidFill>
+                      <a:prstDash val="solid"/>
+                    </a:lnB>
+                    <a:solidFill>
+                      <a:srgbClr val="FFFFFF"/>
+                    </a:solidFill>
+                  </a:tcPr>
+                </a:tc>
+              </a:tr>
+              <a:tr h="274320">
+                <a:tc>
+                  <a:txBody>
+                    <a:bodyPr wrap="square"/>
+                    <a:lstStyle/>
+                    <a:p>
+                      <a:pPr algn="l">
+                        <a:defRPr sz="950"/>
+                      </a:pPr>
+                      <a:r>
+                        <a:rPr b="1" sz="950">
+                          <a:solidFill>
+                            <a:srgbClr val="0F172A"/>
+                          </a:solidFill>
+                          <a:latin typeface="Aptos"/>
+                        </a:rPr>
+                        <a:t>Repayment to related parties</a:t>
+                      </a:r>
+                    </a:p>
+                  </a:txBody>
+                  <a:tcPr marL="45720" marR="45720" marT="0" marB="0" anchor="ctr">
+                    <a:lnL w="12700" cap="flat" cmpd="sng" algn="ctr">
+                      <a:solidFill>
+                        <a:srgbClr val="FFFFFF"/>
+                      </a:solidFill>
+                      <a:prstDash val="solid"/>
+                    </a:lnL>
+                    <a:lnR w="12700" cap="flat" cmpd="sng" algn="ctr">
+                      <a:solidFill>
+                        <a:srgbClr val="FFFFFF"/>
+                      </a:solidFill>
+                      <a:prstDash val="solid"/>
+                    </a:lnR>
+                    <a:lnT w="12700" cap="flat" cmpd="sng" algn="ctr">
+                      <a:solidFill>
+                        <a:srgbClr val="FFFFFF"/>
+                      </a:solidFill>
+                      <a:prstDash val="solid"/>
+                    </a:lnT>
+                    <a:lnB w="12700" cap="flat" cmpd="sng" algn="ctr">
+                      <a:solidFill>
+                        <a:srgbClr val="FFFFFF"/>
+                      </a:solidFill>
+                      <a:prstDash val="solid"/>
+                    </a:lnB>
+                    <a:solidFill>
+                      <a:srgbClr val="FFF2B3"/>
+                    </a:solidFill>
+                  </a:tcPr>
+                </a:tc>
+                <a:tc>
+                  <a:txBody>
+                    <a:bodyPr wrap="square"/>
+                    <a:lstStyle/>
+                    <a:p>
+                      <a:pPr algn="r">
+                        <a:defRPr sz="950"/>
+                      </a:pPr>
+                      <a:r>
+                        <a:rPr b="1" sz="950">
+                          <a:solidFill>
+                            <a:srgbClr val="C00000"/>
+                          </a:solidFill>
+                          <a:latin typeface="Aptos"/>
+                        </a:rPr>
+                        <a:t>(193,746.06)</a:t>
+                      </a:r>
+                    </a:p>
+                  </a:txBody>
+                  <a:tcPr marL="45720" marR="45720" marT="0" marB="0" anchor="ctr">
+                    <a:lnL w="12700" cap="flat" cmpd="sng" algn="ctr">
+                      <a:solidFill>
+                        <a:srgbClr val="FFFFFF"/>
+                      </a:solidFill>
+                      <a:prstDash val="solid"/>
+                    </a:lnL>
+                    <a:lnR w="12700" cap="flat" cmpd="sng" algn="ctr">
+                      <a:solidFill>
+                        <a:srgbClr val="FFFFFF"/>
+                      </a:solidFill>
+                      <a:prstDash val="solid"/>
+                    </a:lnR>
+                    <a:lnT w="12700" cap="flat" cmpd="sng" algn="ctr">
+                      <a:solidFill>
+                        <a:srgbClr val="FFFFFF"/>
+                      </a:solidFill>
+                      <a:prstDash val="solid"/>
+                    </a:lnT>
+                    <a:lnB w="12700" cap="flat" cmpd="sng" algn="ctr">
+                      <a:solidFill>
+                        <a:srgbClr val="FFFFFF"/>
+                      </a:solidFill>
+                      <a:prstDash val="solid"/>
+                    </a:lnB>
+                    <a:solidFill>
+                      <a:srgbClr val="F8FAFC"/>
+                    </a:solidFill>
+                  </a:tcPr>
+                </a:tc>
+                <a:tc>
+                  <a:txBody>
+                    <a:bodyPr wrap="square"/>
+                    <a:lstStyle/>
+                    <a:p>
+                      <a:pPr algn="r">
+                        <a:defRPr sz="950"/>
+                      </a:pPr>
+                      <a:r>
+                        <a:rPr b="1" sz="950">
+                          <a:solidFill>
+                            <a:srgbClr val="0F172A"/>
+                          </a:solidFill>
+                          <a:latin typeface="Aptos"/>
+                        </a:rPr>
+                        <a:t>0.00</a:t>
+                      </a:r>
+                    </a:p>
+                  </a:txBody>
+                  <a:tcPr marL="45720" marR="45720" marT="0" marB="0" anchor="ctr">
+                    <a:lnL w="12700" cap="flat" cmpd="sng" algn="ctr">
+                      <a:solidFill>
+                        <a:srgbClr val="FFFFFF"/>
+                      </a:solidFill>
+                      <a:prstDash val="solid"/>
+                    </a:lnL>
+                    <a:lnR w="12700" cap="flat" cmpd="sng" algn="ctr">
+                      <a:solidFill>
+                        <a:srgbClr val="FFFFFF"/>
+                      </a:solidFill>
+                      <a:prstDash val="solid"/>
+                    </a:lnR>
+                    <a:lnT w="12700" cap="flat" cmpd="sng" algn="ctr">
+                      <a:solidFill>
+                        <a:srgbClr val="FFFFFF"/>
+                      </a:solidFill>
+                      <a:prstDash val="solid"/>
+                    </a:lnT>
+                    <a:lnB w="12700" cap="flat" cmpd="sng" algn="ctr">
+                      <a:solidFill>
+                        <a:srgbClr val="FFFFFF"/>
+                      </a:solidFill>
+                      <a:prstDash val="solid"/>
+                    </a:lnB>
+                    <a:solidFill>
+                      <a:srgbClr val="FFFFFF"/>
+                    </a:solidFill>
+                  </a:tcPr>
+                </a:tc>
+                <a:tc>
+                  <a:txBody>
+                    <a:bodyPr wrap="square"/>
+                    <a:lstStyle/>
+                    <a:p>
+                      <a:pPr algn="r">
+                        <a:defRPr sz="950"/>
+                      </a:pPr>
+                      <a:r>
+                        <a:rPr b="1" sz="950">
+                          <a:solidFill>
+                            <a:srgbClr val="0F172A"/>
+                          </a:solidFill>
+                          <a:latin typeface="Aptos"/>
+                        </a:rPr>
+                        <a:t>0.00</a:t>
+                      </a:r>
+                    </a:p>
+                  </a:txBody>
+                  <a:tcPr marL="45720" marR="45720" marT="0" marB="0" anchor="ctr">
+                    <a:lnL w="12700" cap="flat" cmpd="sng" algn="ctr">
+                      <a:solidFill>
+                        <a:srgbClr val="FFFFFF"/>
+                      </a:solidFill>
+                      <a:prstDash val="solid"/>
+                    </a:lnL>
+                    <a:lnR w="12700" cap="flat" cmpd="sng" algn="ctr">
+                      <a:solidFill>
+                        <a:srgbClr val="FFFFFF"/>
+                      </a:solidFill>
+                      <a:prstDash val="solid"/>
+                    </a:lnR>
+                    <a:lnT w="12700" cap="flat" cmpd="sng" algn="ctr">
+                      <a:solidFill>
+                        <a:srgbClr val="FFFFFF"/>
+                      </a:solidFill>
+                      <a:prstDash val="solid"/>
+                    </a:lnT>
+                    <a:lnB w="12700" cap="flat" cmpd="sng" algn="ctr">
+                      <a:solidFill>
+                        <a:srgbClr val="FFFFFF"/>
+                      </a:solidFill>
+                      <a:prstDash val="solid"/>
+                    </a:lnB>
+                    <a:solidFill>
+                      <a:srgbClr val="F8FAFC"/>
+                    </a:solidFill>
+                  </a:tcPr>
+                </a:tc>
+                <a:tc>
+                  <a:txBody>
+                    <a:bodyPr wrap="square"/>
+                    <a:lstStyle/>
+                    <a:p>
+                      <a:pPr algn="r">
+                        <a:defRPr sz="950"/>
+                      </a:pPr>
+                      <a:r>
+                        <a:rPr b="1" sz="950">
+                          <a:solidFill>
+                            <a:srgbClr val="C00000"/>
+                          </a:solidFill>
+                          <a:latin typeface="Aptos"/>
+                        </a:rPr>
+                        <a:t>(193,746.06)</a:t>
+                      </a:r>
+                    </a:p>
+                  </a:txBody>
+                  <a:tcPr marL="45720" marR="45720" marT="0" marB="0" anchor="ctr">
+                    <a:lnL w="12700" cap="flat" cmpd="sng" algn="ctr">
+                      <a:solidFill>
+                        <a:srgbClr val="FFFFFF"/>
+                      </a:solidFill>
+                      <a:prstDash val="solid"/>
+                    </a:lnL>
+                    <a:lnR w="12700" cap="flat" cmpd="sng" algn="ctr">
+                      <a:solidFill>
+                        <a:srgbClr val="FFFFFF"/>
+                      </a:solidFill>
+                      <a:prstDash val="solid"/>
+                    </a:lnR>
+                    <a:lnT w="12700" cap="flat" cmpd="sng" algn="ctr">
+                      <a:solidFill>
+                        <a:srgbClr val="FFFFFF"/>
+                      </a:solidFill>
+                      <a:prstDash val="solid"/>
+                    </a:lnT>
+                    <a:lnB w="12700" cap="flat" cmpd="sng" algn="ctr">
+                      <a:solidFill>
+                        <a:srgbClr val="FFFFFF"/>
+                      </a:solidFill>
+                      <a:prstDash val="solid"/>
+                    </a:lnB>
+                    <a:solidFill>
+                      <a:srgbClr val="FFFFFF"/>
+                    </a:solidFill>
+                  </a:tcPr>
+                </a:tc>
+                <a:tc>
+                  <a:txBody>
+                    <a:bodyPr wrap="square"/>
+                    <a:lstStyle/>
+                    <a:p>
+                      <a:pPr algn="ctr">
+                        <a:defRPr sz="950"/>
+                      </a:pPr>
+                      <a:r>
+                        <a:rPr b="1" sz="950">
+                          <a:solidFill>
+                            <a:srgbClr val="0F172A"/>
+                          </a:solidFill>
+                          <a:latin typeface="Aptos"/>
+                        </a:rPr>
+                        <a:t>8.5%</a:t>
+                      </a:r>
+                    </a:p>
+                  </a:txBody>
+                  <a:tcPr marL="45720" marR="45720" marT="0" marB="0" anchor="ctr">
+                    <a:lnL w="12700" cap="flat" cmpd="sng" algn="ctr">
+                      <a:solidFill>
+                        <a:srgbClr val="FFFFFF"/>
+                      </a:solidFill>
+                      <a:prstDash val="solid"/>
+                    </a:lnL>
+                    <a:lnR w="12700" cap="flat" cmpd="sng" algn="ctr">
+                      <a:solidFill>
+                        <a:srgbClr val="FFFFFF"/>
+                      </a:solidFill>
+                      <a:prstDash val="solid"/>
+                    </a:lnR>
+                    <a:lnT w="12700" cap="flat" cmpd="sng" algn="ctr">
+                      <a:solidFill>
+                        <a:srgbClr val="FFFFFF"/>
+                      </a:solidFill>
+                      <a:prstDash val="solid"/>
+                    </a:lnT>
+                    <a:lnB w="12700" cap="flat" cmpd="sng" algn="ctr">
+                      <a:solidFill>
+                        <a:srgbClr val="FFFFFF"/>
+                      </a:solidFill>
+                      <a:prstDash val="solid"/>
+                    </a:lnB>
+                    <a:solidFill>
+                      <a:srgbClr val="DDF0F8"/>
+                    </a:solidFill>
+                  </a:tcPr>
+                </a:tc>
+                <a:tc>
+                  <a:txBody>
+                    <a:bodyPr wrap="square"/>
+                    <a:lstStyle/>
+                    <a:p>
+                      <a:pPr algn="l">
+                        <a:defRPr sz="950"/>
+                      </a:pPr>
+                      <a:r>
+                        <a:rPr b="1" sz="950">
+                          <a:solidFill>
+                            <a:srgbClr val="0F172A"/>
+                          </a:solidFill>
+                          <a:latin typeface="Aptos"/>
+                        </a:rPr>
+                        <a:t>Jul: Bebeks (investor fund Suhaib transferred)</a:t>
                       </a:r>
                     </a:p>
                   </a:txBody>

</xml_diff>